<commit_message>
Episode deck v3: real school logos (ESPN CDN) replace color badges
Co-Authored-By: Claude Fable 5 <noreply@anthropic.com>
</commit_message>
<xml_diff>
--- a/decks/2026_Week0_Episode1.pptx
+++ b/decks/2026_Week0_Episode1.pptx
@@ -3232,7 +3232,7 @@
             <a:avLst/>
           </a:prstGeom>
           <a:solidFill>
-            <a:srgbClr val="7BAFD4"/>
+            <a:srgbClr val="FFFFFF"/>
           </a:solidFill>
           <a:ln>
             <a:noFill/>
@@ -3254,25 +3254,40 @@
           </a:fontRef>
         </p:style>
         <p:txBody>
-          <a:bodyPr rtlCol="0" anchor="ctr" wrap="none" lIns="0" rIns="0"/>
+          <a:bodyPr rtlCol="0" anchor="ctr"/>
           <a:lstStyle/>
           <a:p>
             <a:pPr algn="ctr"/>
-            <a:r>
-              <a:rPr b="1" sz="1100">
-                <a:solidFill>
-                  <a:srgbClr val="16273D"/>
-                </a:solidFill>
-                <a:latin typeface="Arial"/>
-              </a:rPr>
-              <a:t>UNC</a:t>
-            </a:r>
-          </a:p>
-        </p:txBody>
-      </p:sp>
-      <p:sp>
-        <p:nvSpPr>
-          <p:cNvPr id="6" name="Oval 5"/>
+          </a:p>
+        </p:txBody>
+      </p:sp>
+      <p:pic>
+        <p:nvPicPr>
+          <p:cNvPr id="6" name="Picture 5" descr="unc.png"/>
+          <p:cNvPicPr>
+            <a:picLocks noChangeAspect="1"/>
+          </p:cNvPicPr>
+          <p:nvPr/>
+        </p:nvPicPr>
+        <p:blipFill>
+          <a:blip r:embed="rId2"/>
+          <a:stretch>
+            <a:fillRect/>
+          </a:stretch>
+        </p:blipFill>
+        <p:spPr>
+          <a:xfrm>
+            <a:off x="1113739" y="2951683"/>
+            <a:ext cx="497433" cy="497433"/>
+          </a:xfrm>
+          <a:prstGeom prst="rect">
+            <a:avLst/>
+          </a:prstGeom>
+        </p:spPr>
+      </p:pic>
+      <p:sp>
+        <p:nvSpPr>
+          <p:cNvPr id="7" name="Oval 6"/>
           <p:cNvSpPr/>
           <p:nvPr/>
         </p:nvSpPr>
@@ -3285,7 +3300,7 @@
             <a:avLst/>
           </a:prstGeom>
           <a:solidFill>
-            <a:srgbClr val="4D1979"/>
+            <a:srgbClr val="FFFFFF"/>
           </a:solidFill>
           <a:ln>
             <a:noFill/>
@@ -3307,25 +3322,40 @@
           </a:fontRef>
         </p:style>
         <p:txBody>
-          <a:bodyPr rtlCol="0" anchor="ctr" wrap="none" lIns="0" rIns="0"/>
+          <a:bodyPr rtlCol="0" anchor="ctr"/>
           <a:lstStyle/>
           <a:p>
             <a:pPr algn="ctr"/>
-            <a:r>
-              <a:rPr b="1" sz="1100">
-                <a:solidFill>
-                  <a:srgbClr val="FFFFFF"/>
-                </a:solidFill>
-                <a:latin typeface="Arial"/>
-              </a:rPr>
-              <a:t>TCU</a:t>
-            </a:r>
-          </a:p>
-        </p:txBody>
-      </p:sp>
-      <p:sp>
-        <p:nvSpPr>
-          <p:cNvPr id="7" name="TextBox 6"/>
+          </a:p>
+        </p:txBody>
+      </p:sp>
+      <p:pic>
+        <p:nvPicPr>
+          <p:cNvPr id="8" name="Picture 7" descr="tcu.png"/>
+          <p:cNvPicPr>
+            <a:picLocks noChangeAspect="1"/>
+          </p:cNvPicPr>
+          <p:nvPr/>
+        </p:nvPicPr>
+        <p:blipFill>
+          <a:blip r:embed="rId3"/>
+          <a:stretch>
+            <a:fillRect/>
+          </a:stretch>
+        </p:blipFill>
+        <p:spPr>
+          <a:xfrm>
+            <a:off x="1890979" y="2951683"/>
+            <a:ext cx="497433" cy="497433"/>
+          </a:xfrm>
+          <a:prstGeom prst="rect">
+            <a:avLst/>
+          </a:prstGeom>
+        </p:spPr>
+      </p:pic>
+      <p:sp>
+        <p:nvSpPr>
+          <p:cNvPr id="9" name="TextBox 8"/>
           <p:cNvSpPr txBox="1"/>
           <p:nvPr/>
         </p:nvSpPr>
@@ -3360,7 +3390,7 @@
       </p:sp>
       <p:sp>
         <p:nvSpPr>
-          <p:cNvPr id="8" name="TextBox 7"/>
+          <p:cNvPr id="10" name="TextBox 9"/>
           <p:cNvSpPr txBox="1"/>
           <p:nvPr/>
         </p:nvSpPr>
@@ -3395,7 +3425,7 @@
       </p:sp>
       <p:sp>
         <p:nvSpPr>
-          <p:cNvPr id="9" name="TextBox 8"/>
+          <p:cNvPr id="11" name="TextBox 10"/>
           <p:cNvSpPr txBox="1"/>
           <p:nvPr/>
         </p:nvSpPr>
@@ -3430,7 +3460,7 @@
       </p:sp>
       <p:sp>
         <p:nvSpPr>
-          <p:cNvPr id="10" name="TextBox 9"/>
+          <p:cNvPr id="12" name="TextBox 11"/>
           <p:cNvSpPr txBox="1"/>
           <p:nvPr/>
         </p:nvSpPr>
@@ -3465,7 +3495,7 @@
       </p:sp>
       <p:sp>
         <p:nvSpPr>
-          <p:cNvPr id="11" name="Rounded Rectangle 10"/>
+          <p:cNvPr id="13" name="Rounded Rectangle 12"/>
           <p:cNvSpPr/>
           <p:nvPr/>
         </p:nvSpPr>
@@ -3509,7 +3539,7 @@
       </p:sp>
       <p:sp>
         <p:nvSpPr>
-          <p:cNvPr id="12" name="Oval 11"/>
+          <p:cNvPr id="14" name="Oval 13"/>
           <p:cNvSpPr/>
           <p:nvPr/>
         </p:nvSpPr>
@@ -3522,7 +3552,7 @@
             <a:avLst/>
           </a:prstGeom>
           <a:solidFill>
-            <a:srgbClr val="CC0000"/>
+            <a:srgbClr val="FFFFFF"/>
           </a:solidFill>
           <a:ln>
             <a:noFill/>
@@ -3544,25 +3574,40 @@
           </a:fontRef>
         </p:style>
         <p:txBody>
-          <a:bodyPr rtlCol="0" anchor="ctr" wrap="none" lIns="0" rIns="0"/>
+          <a:bodyPr rtlCol="0" anchor="ctr"/>
           <a:lstStyle/>
           <a:p>
             <a:pPr algn="ctr"/>
-            <a:r>
-              <a:rPr b="1" sz="1100">
-                <a:solidFill>
-                  <a:srgbClr val="FFFFFF"/>
-                </a:solidFill>
-                <a:latin typeface="Arial"/>
-              </a:rPr>
-              <a:t>NCSU</a:t>
-            </a:r>
-          </a:p>
-        </p:txBody>
-      </p:sp>
-      <p:sp>
-        <p:nvSpPr>
-          <p:cNvPr id="13" name="Oval 12"/>
+          </a:p>
+        </p:txBody>
+      </p:sp>
+      <p:pic>
+        <p:nvPicPr>
+          <p:cNvPr id="15" name="Picture 14" descr="ncsu.png"/>
+          <p:cNvPicPr>
+            <a:picLocks noChangeAspect="1"/>
+          </p:cNvPicPr>
+          <p:nvPr/>
+        </p:nvPicPr>
+        <p:blipFill>
+          <a:blip r:embed="rId4"/>
+          <a:stretch>
+            <a:fillRect/>
+          </a:stretch>
+        </p:blipFill>
+        <p:spPr>
+          <a:xfrm>
+            <a:off x="1113739" y="4067251"/>
+            <a:ext cx="497433" cy="497433"/>
+          </a:xfrm>
+          <a:prstGeom prst="rect">
+            <a:avLst/>
+          </a:prstGeom>
+        </p:spPr>
+      </p:pic>
+      <p:sp>
+        <p:nvSpPr>
+          <p:cNvPr id="16" name="Oval 15"/>
           <p:cNvSpPr/>
           <p:nvPr/>
         </p:nvSpPr>
@@ -3575,7 +3620,7 @@
             <a:avLst/>
           </a:prstGeom>
           <a:solidFill>
-            <a:srgbClr val="232D4B"/>
+            <a:srgbClr val="FFFFFF"/>
           </a:solidFill>
           <a:ln>
             <a:noFill/>
@@ -3597,25 +3642,40 @@
           </a:fontRef>
         </p:style>
         <p:txBody>
-          <a:bodyPr rtlCol="0" anchor="ctr" wrap="none" lIns="0" rIns="0"/>
+          <a:bodyPr rtlCol="0" anchor="ctr"/>
           <a:lstStyle/>
           <a:p>
             <a:pPr algn="ctr"/>
-            <a:r>
-              <a:rPr b="1" sz="1100">
-                <a:solidFill>
-                  <a:srgbClr val="FFFFFF"/>
-                </a:solidFill>
-                <a:latin typeface="Arial"/>
-              </a:rPr>
-              <a:t>UVA</a:t>
-            </a:r>
-          </a:p>
-        </p:txBody>
-      </p:sp>
-      <p:sp>
-        <p:nvSpPr>
-          <p:cNvPr id="14" name="TextBox 13"/>
+          </a:p>
+        </p:txBody>
+      </p:sp>
+      <p:pic>
+        <p:nvPicPr>
+          <p:cNvPr id="17" name="Picture 16" descr="uva.png"/>
+          <p:cNvPicPr>
+            <a:picLocks noChangeAspect="1"/>
+          </p:cNvPicPr>
+          <p:nvPr/>
+        </p:nvPicPr>
+        <p:blipFill>
+          <a:blip r:embed="rId5"/>
+          <a:stretch>
+            <a:fillRect/>
+          </a:stretch>
+        </p:blipFill>
+        <p:spPr>
+          <a:xfrm>
+            <a:off x="1890979" y="4067251"/>
+            <a:ext cx="497433" cy="497433"/>
+          </a:xfrm>
+          <a:prstGeom prst="rect">
+            <a:avLst/>
+          </a:prstGeom>
+        </p:spPr>
+      </p:pic>
+      <p:sp>
+        <p:nvSpPr>
+          <p:cNvPr id="18" name="TextBox 17"/>
           <p:cNvSpPr txBox="1"/>
           <p:nvPr/>
         </p:nvSpPr>
@@ -3650,7 +3710,7 @@
       </p:sp>
       <p:sp>
         <p:nvSpPr>
-          <p:cNvPr id="15" name="TextBox 14"/>
+          <p:cNvPr id="19" name="TextBox 18"/>
           <p:cNvSpPr txBox="1"/>
           <p:nvPr/>
         </p:nvSpPr>
@@ -3685,7 +3745,7 @@
       </p:sp>
       <p:sp>
         <p:nvSpPr>
-          <p:cNvPr id="16" name="TextBox 15"/>
+          <p:cNvPr id="20" name="TextBox 19"/>
           <p:cNvSpPr txBox="1"/>
           <p:nvPr/>
         </p:nvSpPr>
@@ -3720,7 +3780,7 @@
       </p:sp>
       <p:sp>
         <p:nvSpPr>
-          <p:cNvPr id="17" name="TextBox 16"/>
+          <p:cNvPr id="21" name="TextBox 20"/>
           <p:cNvSpPr txBox="1"/>
           <p:nvPr/>
         </p:nvSpPr>
@@ -3755,7 +3815,7 @@
       </p:sp>
       <p:sp>
         <p:nvSpPr>
-          <p:cNvPr id="18" name="Rounded Rectangle 17"/>
+          <p:cNvPr id="22" name="Rounded Rectangle 21"/>
           <p:cNvSpPr/>
           <p:nvPr/>
         </p:nvSpPr>
@@ -3799,7 +3859,7 @@
       </p:sp>
       <p:sp>
         <p:nvSpPr>
-          <p:cNvPr id="19" name="Oval 18"/>
+          <p:cNvPr id="23" name="Oval 22"/>
           <p:cNvSpPr/>
           <p:nvPr/>
         </p:nvSpPr>
@@ -3812,7 +3872,7 @@
             <a:avLst/>
           </a:prstGeom>
           <a:solidFill>
-            <a:srgbClr val="B5121B"/>
+            <a:srgbClr val="FFFFFF"/>
           </a:solidFill>
           <a:ln>
             <a:noFill/>
@@ -3834,25 +3894,40 @@
           </a:fontRef>
         </p:style>
         <p:txBody>
-          <a:bodyPr rtlCol="0" anchor="ctr" wrap="none" lIns="0" rIns="0"/>
+          <a:bodyPr rtlCol="0" anchor="ctr"/>
           <a:lstStyle/>
           <a:p>
             <a:pPr algn="ctr"/>
-            <a:r>
-              <a:rPr b="1" sz="1100">
-                <a:solidFill>
-                  <a:srgbClr val="FFFFFF"/>
-                </a:solidFill>
-                <a:latin typeface="Arial"/>
-              </a:rPr>
-              <a:t>JSU</a:t>
-            </a:r>
-          </a:p>
-        </p:txBody>
-      </p:sp>
-      <p:sp>
-        <p:nvSpPr>
-          <p:cNvPr id="20" name="Oval 19"/>
+          </a:p>
+        </p:txBody>
+      </p:sp>
+      <p:pic>
+        <p:nvPicPr>
+          <p:cNvPr id="24" name="Picture 23" descr="jsu.png"/>
+          <p:cNvPicPr>
+            <a:picLocks noChangeAspect="1"/>
+          </p:cNvPicPr>
+          <p:nvPr/>
+        </p:nvPicPr>
+        <p:blipFill>
+          <a:blip r:embed="rId6"/>
+          <a:stretch>
+            <a:fillRect/>
+          </a:stretch>
+        </p:blipFill>
+        <p:spPr>
+          <a:xfrm>
+            <a:off x="1113739" y="5182819"/>
+            <a:ext cx="497433" cy="497433"/>
+          </a:xfrm>
+          <a:prstGeom prst="rect">
+            <a:avLst/>
+          </a:prstGeom>
+        </p:spPr>
+      </p:pic>
+      <p:sp>
+        <p:nvSpPr>
+          <p:cNvPr id="25" name="Oval 24"/>
           <p:cNvSpPr/>
           <p:nvPr/>
         </p:nvSpPr>
@@ -3865,7 +3940,7 @@
             <a:avLst/>
           </a:prstGeom>
           <a:solidFill>
-            <a:srgbClr val="0A5640"/>
+            <a:srgbClr val="FFFFFF"/>
           </a:solidFill>
           <a:ln>
             <a:noFill/>
@@ -3887,25 +3962,40 @@
           </a:fontRef>
         </p:style>
         <p:txBody>
-          <a:bodyPr rtlCol="0" anchor="ctr" wrap="none" lIns="0" rIns="0"/>
+          <a:bodyPr rtlCol="0" anchor="ctr"/>
           <a:lstStyle/>
           <a:p>
             <a:pPr algn="ctr"/>
-            <a:r>
-              <a:rPr b="1" sz="1100">
-                <a:solidFill>
-                  <a:srgbClr val="FFFFFF"/>
-                </a:solidFill>
-                <a:latin typeface="Arial"/>
-              </a:rPr>
-              <a:t>NDSU</a:t>
-            </a:r>
-          </a:p>
-        </p:txBody>
-      </p:sp>
-      <p:sp>
-        <p:nvSpPr>
-          <p:cNvPr id="21" name="TextBox 20"/>
+          </a:p>
+        </p:txBody>
+      </p:sp>
+      <p:pic>
+        <p:nvPicPr>
+          <p:cNvPr id="26" name="Picture 25" descr="ndsu.png"/>
+          <p:cNvPicPr>
+            <a:picLocks noChangeAspect="1"/>
+          </p:cNvPicPr>
+          <p:nvPr/>
+        </p:nvPicPr>
+        <p:blipFill>
+          <a:blip r:embed="rId7"/>
+          <a:stretch>
+            <a:fillRect/>
+          </a:stretch>
+        </p:blipFill>
+        <p:spPr>
+          <a:xfrm>
+            <a:off x="1890979" y="5182819"/>
+            <a:ext cx="497433" cy="497433"/>
+          </a:xfrm>
+          <a:prstGeom prst="rect">
+            <a:avLst/>
+          </a:prstGeom>
+        </p:spPr>
+      </p:pic>
+      <p:sp>
+        <p:nvSpPr>
+          <p:cNvPr id="27" name="TextBox 26"/>
           <p:cNvSpPr txBox="1"/>
           <p:nvPr/>
         </p:nvSpPr>
@@ -3940,7 +4030,7 @@
       </p:sp>
       <p:sp>
         <p:nvSpPr>
-          <p:cNvPr id="22" name="TextBox 21"/>
+          <p:cNvPr id="28" name="TextBox 27"/>
           <p:cNvSpPr txBox="1"/>
           <p:nvPr/>
         </p:nvSpPr>
@@ -3975,7 +4065,7 @@
       </p:sp>
       <p:sp>
         <p:nvSpPr>
-          <p:cNvPr id="23" name="TextBox 22"/>
+          <p:cNvPr id="29" name="TextBox 28"/>
           <p:cNvSpPr txBox="1"/>
           <p:nvPr/>
         </p:nvSpPr>
@@ -4010,7 +4100,7 @@
       </p:sp>
       <p:sp>
         <p:nvSpPr>
-          <p:cNvPr id="24" name="TextBox 23"/>
+          <p:cNvPr id="30" name="TextBox 29"/>
           <p:cNvSpPr txBox="1"/>
           <p:nvPr/>
         </p:nvSpPr>
@@ -4045,7 +4135,7 @@
       </p:sp>
       <p:sp>
         <p:nvSpPr>
-          <p:cNvPr id="25" name="TextBox 24"/>
+          <p:cNvPr id="31" name="TextBox 30"/>
           <p:cNvSpPr txBox="1"/>
           <p:nvPr/>
         </p:nvSpPr>
@@ -4104,59 +4194,30 @@
         <p:nvPr/>
       </p:nvGrpSpPr>
       <p:grpSpPr/>
-      <p:sp>
-        <p:nvSpPr>
-          <p:cNvPr id="2" name="Oval 1"/>
-          <p:cNvSpPr/>
-          <p:nvPr/>
-        </p:nvSpPr>
+      <p:pic>
+        <p:nvPicPr>
+          <p:cNvPr id="2" name="Picture 1" descr="unc.png"/>
+          <p:cNvPicPr>
+            <a:picLocks noChangeAspect="1"/>
+          </p:cNvPicPr>
+          <p:nvPr/>
+        </p:nvPicPr>
+        <p:blipFill>
+          <a:blip r:embed="rId2"/>
+          <a:stretch>
+            <a:fillRect/>
+          </a:stretch>
+        </p:blipFill>
         <p:spPr>
           <a:xfrm>
             <a:off x="822960" y="384048"/>
             <a:ext cx="731520" cy="731520"/>
           </a:xfrm>
-          <a:prstGeom prst="ellipse">
-            <a:avLst/>
-          </a:prstGeom>
-          <a:solidFill>
-            <a:srgbClr val="7BAFD4"/>
-          </a:solidFill>
-          <a:ln>
-            <a:noFill/>
-          </a:ln>
-          <a:effectLst/>
-        </p:spPr>
-        <p:style>
-          <a:lnRef idx="1">
-            <a:schemeClr val="accent1"/>
-          </a:lnRef>
-          <a:fillRef idx="3">
-            <a:schemeClr val="accent1"/>
-          </a:fillRef>
-          <a:effectRef idx="2">
-            <a:schemeClr val="accent1"/>
-          </a:effectRef>
-          <a:fontRef idx="minor">
-            <a:schemeClr val="lt1"/>
-          </a:fontRef>
-        </p:style>
-        <p:txBody>
-          <a:bodyPr rtlCol="0" anchor="ctr" wrap="none" lIns="0" rIns="0"/>
-          <a:lstStyle/>
-          <a:p>
-            <a:pPr algn="ctr"/>
-            <a:r>
-              <a:rPr b="1" sz="1500">
-                <a:solidFill>
-                  <a:srgbClr val="16273D"/>
-                </a:solidFill>
-                <a:latin typeface="Arial"/>
-              </a:rPr>
-              <a:t>UNC</a:t>
-            </a:r>
-          </a:p>
-        </p:txBody>
-      </p:sp>
+          <a:prstGeom prst="rect">
+            <a:avLst/>
+          </a:prstGeom>
+        </p:spPr>
+      </p:pic>
       <p:sp>
         <p:nvSpPr>
           <p:cNvPr id="3" name="TextBox 2"/>
@@ -4192,59 +4253,30 @@
           </a:p>
         </p:txBody>
       </p:sp>
-      <p:sp>
-        <p:nvSpPr>
-          <p:cNvPr id="4" name="Oval 3"/>
-          <p:cNvSpPr/>
-          <p:nvPr/>
-        </p:nvSpPr>
+      <p:pic>
+        <p:nvPicPr>
+          <p:cNvPr id="4" name="Picture 3" descr="tcu.png"/>
+          <p:cNvPicPr>
+            <a:picLocks noChangeAspect="1"/>
+          </p:cNvPicPr>
+          <p:nvPr/>
+        </p:nvPicPr>
+        <p:blipFill>
+          <a:blip r:embed="rId3"/>
+          <a:stretch>
+            <a:fillRect/>
+          </a:stretch>
+        </p:blipFill>
         <p:spPr>
           <a:xfrm>
             <a:off x="2148840" y="384048"/>
             <a:ext cx="731520" cy="731520"/>
           </a:xfrm>
-          <a:prstGeom prst="ellipse">
-            <a:avLst/>
-          </a:prstGeom>
-          <a:solidFill>
-            <a:srgbClr val="4D1979"/>
-          </a:solidFill>
-          <a:ln>
-            <a:noFill/>
-          </a:ln>
-          <a:effectLst/>
-        </p:spPr>
-        <p:style>
-          <a:lnRef idx="1">
-            <a:schemeClr val="accent1"/>
-          </a:lnRef>
-          <a:fillRef idx="3">
-            <a:schemeClr val="accent1"/>
-          </a:fillRef>
-          <a:effectRef idx="2">
-            <a:schemeClr val="accent1"/>
-          </a:effectRef>
-          <a:fontRef idx="minor">
-            <a:schemeClr val="lt1"/>
-          </a:fontRef>
-        </p:style>
-        <p:txBody>
-          <a:bodyPr rtlCol="0" anchor="ctr" wrap="none" lIns="0" rIns="0"/>
-          <a:lstStyle/>
-          <a:p>
-            <a:pPr algn="ctr"/>
-            <a:r>
-              <a:rPr b="1" sz="1500">
-                <a:solidFill>
-                  <a:srgbClr val="FFFFFF"/>
-                </a:solidFill>
-                <a:latin typeface="Arial"/>
-              </a:rPr>
-              <a:t>TCU</a:t>
-            </a:r>
-          </a:p>
-        </p:txBody>
-      </p:sp>
+          <a:prstGeom prst="rect">
+            <a:avLst/>
+          </a:prstGeom>
+        </p:spPr>
+      </p:pic>
       <p:sp>
         <p:nvSpPr>
           <p:cNvPr id="5" name="TextBox 4"/>
@@ -5288,59 +5320,30 @@
         <p:nvPr/>
       </p:nvGrpSpPr>
       <p:grpSpPr/>
-      <p:sp>
-        <p:nvSpPr>
-          <p:cNvPr id="2" name="Oval 1"/>
-          <p:cNvSpPr/>
-          <p:nvPr/>
-        </p:nvSpPr>
+      <p:pic>
+        <p:nvPicPr>
+          <p:cNvPr id="2" name="Picture 1" descr="unc.png"/>
+          <p:cNvPicPr>
+            <a:picLocks noChangeAspect="1"/>
+          </p:cNvPicPr>
+          <p:nvPr/>
+        </p:nvPicPr>
+        <p:blipFill>
+          <a:blip r:embed="rId2"/>
+          <a:stretch>
+            <a:fillRect/>
+          </a:stretch>
+        </p:blipFill>
         <p:spPr>
           <a:xfrm>
             <a:off x="822960" y="384048"/>
             <a:ext cx="731520" cy="731520"/>
           </a:xfrm>
-          <a:prstGeom prst="ellipse">
-            <a:avLst/>
-          </a:prstGeom>
-          <a:solidFill>
-            <a:srgbClr val="7BAFD4"/>
-          </a:solidFill>
-          <a:ln>
-            <a:noFill/>
-          </a:ln>
-          <a:effectLst/>
-        </p:spPr>
-        <p:style>
-          <a:lnRef idx="1">
-            <a:schemeClr val="accent1"/>
-          </a:lnRef>
-          <a:fillRef idx="3">
-            <a:schemeClr val="accent1"/>
-          </a:fillRef>
-          <a:effectRef idx="2">
-            <a:schemeClr val="accent1"/>
-          </a:effectRef>
-          <a:fontRef idx="minor">
-            <a:schemeClr val="lt1"/>
-          </a:fontRef>
-        </p:style>
-        <p:txBody>
-          <a:bodyPr rtlCol="0" anchor="ctr" wrap="none" lIns="0" rIns="0"/>
-          <a:lstStyle/>
-          <a:p>
-            <a:pPr algn="ctr"/>
-            <a:r>
-              <a:rPr b="1" sz="1500">
-                <a:solidFill>
-                  <a:srgbClr val="16273D"/>
-                </a:solidFill>
-                <a:latin typeface="Arial"/>
-              </a:rPr>
-              <a:t>UNC</a:t>
-            </a:r>
-          </a:p>
-        </p:txBody>
-      </p:sp>
+          <a:prstGeom prst="rect">
+            <a:avLst/>
+          </a:prstGeom>
+        </p:spPr>
+      </p:pic>
       <p:sp>
         <p:nvSpPr>
           <p:cNvPr id="3" name="TextBox 2"/>
@@ -5376,59 +5379,30 @@
           </a:p>
         </p:txBody>
       </p:sp>
-      <p:sp>
-        <p:nvSpPr>
-          <p:cNvPr id="4" name="Oval 3"/>
-          <p:cNvSpPr/>
-          <p:nvPr/>
-        </p:nvSpPr>
+      <p:pic>
+        <p:nvPicPr>
+          <p:cNvPr id="4" name="Picture 3" descr="tcu.png"/>
+          <p:cNvPicPr>
+            <a:picLocks noChangeAspect="1"/>
+          </p:cNvPicPr>
+          <p:nvPr/>
+        </p:nvPicPr>
+        <p:blipFill>
+          <a:blip r:embed="rId3"/>
+          <a:stretch>
+            <a:fillRect/>
+          </a:stretch>
+        </p:blipFill>
         <p:spPr>
           <a:xfrm>
             <a:off x="2148840" y="384048"/>
             <a:ext cx="731520" cy="731520"/>
           </a:xfrm>
-          <a:prstGeom prst="ellipse">
-            <a:avLst/>
-          </a:prstGeom>
-          <a:solidFill>
-            <a:srgbClr val="4D1979"/>
-          </a:solidFill>
-          <a:ln>
-            <a:noFill/>
-          </a:ln>
-          <a:effectLst/>
-        </p:spPr>
-        <p:style>
-          <a:lnRef idx="1">
-            <a:schemeClr val="accent1"/>
-          </a:lnRef>
-          <a:fillRef idx="3">
-            <a:schemeClr val="accent1"/>
-          </a:fillRef>
-          <a:effectRef idx="2">
-            <a:schemeClr val="accent1"/>
-          </a:effectRef>
-          <a:fontRef idx="minor">
-            <a:schemeClr val="lt1"/>
-          </a:fontRef>
-        </p:style>
-        <p:txBody>
-          <a:bodyPr rtlCol="0" anchor="ctr" wrap="none" lIns="0" rIns="0"/>
-          <a:lstStyle/>
-          <a:p>
-            <a:pPr algn="ctr"/>
-            <a:r>
-              <a:rPr b="1" sz="1500">
-                <a:solidFill>
-                  <a:srgbClr val="FFFFFF"/>
-                </a:solidFill>
-                <a:latin typeface="Arial"/>
-              </a:rPr>
-              <a:t>TCU</a:t>
-            </a:r>
-          </a:p>
-        </p:txBody>
-      </p:sp>
+          <a:prstGeom prst="rect">
+            <a:avLst/>
+          </a:prstGeom>
+        </p:spPr>
+      </p:pic>
       <p:sp>
         <p:nvSpPr>
           <p:cNvPr id="5" name="TextBox 4"/>
@@ -5508,59 +5482,30 @@
           </a:p>
         </p:txBody>
       </p:sp>
-      <p:sp>
-        <p:nvSpPr>
-          <p:cNvPr id="7" name="Oval 6"/>
-          <p:cNvSpPr/>
-          <p:nvPr/>
-        </p:nvSpPr>
+      <p:pic>
+        <p:nvPicPr>
+          <p:cNvPr id="7" name="Picture 6" descr="unc.png"/>
+          <p:cNvPicPr>
+            <a:picLocks noChangeAspect="1"/>
+          </p:cNvPicPr>
+          <p:nvPr/>
+        </p:nvPicPr>
+        <p:blipFill>
+          <a:blip r:embed="rId2"/>
+          <a:stretch>
+            <a:fillRect/>
+          </a:stretch>
+        </p:blipFill>
         <p:spPr>
           <a:xfrm>
             <a:off x="1097280" y="1691640"/>
             <a:ext cx="566928" cy="566928"/>
           </a:xfrm>
-          <a:prstGeom prst="ellipse">
-            <a:avLst/>
-          </a:prstGeom>
-          <a:solidFill>
-            <a:srgbClr val="7BAFD4"/>
-          </a:solidFill>
-          <a:ln>
-            <a:noFill/>
-          </a:ln>
-          <a:effectLst/>
-        </p:spPr>
-        <p:style>
-          <a:lnRef idx="1">
-            <a:schemeClr val="accent1"/>
-          </a:lnRef>
-          <a:fillRef idx="3">
-            <a:schemeClr val="accent1"/>
-          </a:fillRef>
-          <a:effectRef idx="2">
-            <a:schemeClr val="accent1"/>
-          </a:effectRef>
-          <a:fontRef idx="minor">
-            <a:schemeClr val="lt1"/>
-          </a:fontRef>
-        </p:style>
-        <p:txBody>
-          <a:bodyPr rtlCol="0" anchor="ctr" wrap="none" lIns="0" rIns="0"/>
-          <a:lstStyle/>
-          <a:p>
-            <a:pPr algn="ctr"/>
-            <a:r>
-              <a:rPr b="1" sz="1100">
-                <a:solidFill>
-                  <a:srgbClr val="16273D"/>
-                </a:solidFill>
-                <a:latin typeface="Arial"/>
-              </a:rPr>
-              <a:t>UNC</a:t>
-            </a:r>
-          </a:p>
-        </p:txBody>
-      </p:sp>
+          <a:prstGeom prst="rect">
+            <a:avLst/>
+          </a:prstGeom>
+        </p:spPr>
+      </p:pic>
       <p:sp>
         <p:nvSpPr>
           <p:cNvPr id="8" name="TextBox 7"/>
@@ -5955,59 +5900,30 @@
           </a:p>
         </p:txBody>
       </p:sp>
-      <p:sp>
-        <p:nvSpPr>
-          <p:cNvPr id="19" name="Oval 18"/>
-          <p:cNvSpPr/>
-          <p:nvPr/>
-        </p:nvSpPr>
+      <p:pic>
+        <p:nvPicPr>
+          <p:cNvPr id="19" name="Picture 18" descr="tcu.png"/>
+          <p:cNvPicPr>
+            <a:picLocks noChangeAspect="1"/>
+          </p:cNvPicPr>
+          <p:nvPr/>
+        </p:nvPicPr>
+        <p:blipFill>
+          <a:blip r:embed="rId3"/>
+          <a:stretch>
+            <a:fillRect/>
+          </a:stretch>
+        </p:blipFill>
         <p:spPr>
           <a:xfrm>
             <a:off x="6583680" y="1691640"/>
             <a:ext cx="566928" cy="566928"/>
           </a:xfrm>
-          <a:prstGeom prst="ellipse">
-            <a:avLst/>
-          </a:prstGeom>
-          <a:solidFill>
-            <a:srgbClr val="4D1979"/>
-          </a:solidFill>
-          <a:ln>
-            <a:noFill/>
-          </a:ln>
-          <a:effectLst/>
-        </p:spPr>
-        <p:style>
-          <a:lnRef idx="1">
-            <a:schemeClr val="accent1"/>
-          </a:lnRef>
-          <a:fillRef idx="3">
-            <a:schemeClr val="accent1"/>
-          </a:fillRef>
-          <a:effectRef idx="2">
-            <a:schemeClr val="accent1"/>
-          </a:effectRef>
-          <a:fontRef idx="minor">
-            <a:schemeClr val="lt1"/>
-          </a:fontRef>
-        </p:style>
-        <p:txBody>
-          <a:bodyPr rtlCol="0" anchor="ctr" wrap="none" lIns="0" rIns="0"/>
-          <a:lstStyle/>
-          <a:p>
-            <a:pPr algn="ctr"/>
-            <a:r>
-              <a:rPr b="1" sz="1100">
-                <a:solidFill>
-                  <a:srgbClr val="FFFFFF"/>
-                </a:solidFill>
-                <a:latin typeface="Arial"/>
-              </a:rPr>
-              <a:t>TCU</a:t>
-            </a:r>
-          </a:p>
-        </p:txBody>
-      </p:sp>
+          <a:prstGeom prst="rect">
+            <a:avLst/>
+          </a:prstGeom>
+        </p:spPr>
+      </p:pic>
       <p:sp>
         <p:nvSpPr>
           <p:cNvPr id="20" name="TextBox 19"/>
@@ -6419,59 +6335,30 @@
         <p:nvPr/>
       </p:nvGrpSpPr>
       <p:grpSpPr/>
-      <p:sp>
-        <p:nvSpPr>
-          <p:cNvPr id="2" name="Oval 1"/>
-          <p:cNvSpPr/>
-          <p:nvPr/>
-        </p:nvSpPr>
+      <p:pic>
+        <p:nvPicPr>
+          <p:cNvPr id="2" name="Picture 1" descr="ncsu.png"/>
+          <p:cNvPicPr>
+            <a:picLocks noChangeAspect="1"/>
+          </p:cNvPicPr>
+          <p:nvPr/>
+        </p:nvPicPr>
+        <p:blipFill>
+          <a:blip r:embed="rId2"/>
+          <a:stretch>
+            <a:fillRect/>
+          </a:stretch>
+        </p:blipFill>
         <p:spPr>
           <a:xfrm>
             <a:off x="822960" y="384048"/>
             <a:ext cx="731520" cy="731520"/>
           </a:xfrm>
-          <a:prstGeom prst="ellipse">
-            <a:avLst/>
-          </a:prstGeom>
-          <a:solidFill>
-            <a:srgbClr val="CC0000"/>
-          </a:solidFill>
-          <a:ln>
-            <a:noFill/>
-          </a:ln>
-          <a:effectLst/>
-        </p:spPr>
-        <p:style>
-          <a:lnRef idx="1">
-            <a:schemeClr val="accent1"/>
-          </a:lnRef>
-          <a:fillRef idx="3">
-            <a:schemeClr val="accent1"/>
-          </a:fillRef>
-          <a:effectRef idx="2">
-            <a:schemeClr val="accent1"/>
-          </a:effectRef>
-          <a:fontRef idx="minor">
-            <a:schemeClr val="lt1"/>
-          </a:fontRef>
-        </p:style>
-        <p:txBody>
-          <a:bodyPr rtlCol="0" anchor="ctr" wrap="none" lIns="0" rIns="0"/>
-          <a:lstStyle/>
-          <a:p>
-            <a:pPr algn="ctr"/>
-            <a:r>
-              <a:rPr b="1" sz="1500">
-                <a:solidFill>
-                  <a:srgbClr val="FFFFFF"/>
-                </a:solidFill>
-                <a:latin typeface="Arial"/>
-              </a:rPr>
-              <a:t>NCSU</a:t>
-            </a:r>
-          </a:p>
-        </p:txBody>
-      </p:sp>
+          <a:prstGeom prst="rect">
+            <a:avLst/>
+          </a:prstGeom>
+        </p:spPr>
+      </p:pic>
       <p:sp>
         <p:nvSpPr>
           <p:cNvPr id="3" name="TextBox 2"/>
@@ -6507,59 +6394,30 @@
           </a:p>
         </p:txBody>
       </p:sp>
-      <p:sp>
-        <p:nvSpPr>
-          <p:cNvPr id="4" name="Oval 3"/>
-          <p:cNvSpPr/>
-          <p:nvPr/>
-        </p:nvSpPr>
+      <p:pic>
+        <p:nvPicPr>
+          <p:cNvPr id="4" name="Picture 3" descr="uva.png"/>
+          <p:cNvPicPr>
+            <a:picLocks noChangeAspect="1"/>
+          </p:cNvPicPr>
+          <p:nvPr/>
+        </p:nvPicPr>
+        <p:blipFill>
+          <a:blip r:embed="rId3"/>
+          <a:stretch>
+            <a:fillRect/>
+          </a:stretch>
+        </p:blipFill>
         <p:spPr>
           <a:xfrm>
             <a:off x="2148840" y="384048"/>
             <a:ext cx="731520" cy="731520"/>
           </a:xfrm>
-          <a:prstGeom prst="ellipse">
-            <a:avLst/>
-          </a:prstGeom>
-          <a:solidFill>
-            <a:srgbClr val="232D4B"/>
-          </a:solidFill>
-          <a:ln>
-            <a:noFill/>
-          </a:ln>
-          <a:effectLst/>
-        </p:spPr>
-        <p:style>
-          <a:lnRef idx="1">
-            <a:schemeClr val="accent1"/>
-          </a:lnRef>
-          <a:fillRef idx="3">
-            <a:schemeClr val="accent1"/>
-          </a:fillRef>
-          <a:effectRef idx="2">
-            <a:schemeClr val="accent1"/>
-          </a:effectRef>
-          <a:fontRef idx="minor">
-            <a:schemeClr val="lt1"/>
-          </a:fontRef>
-        </p:style>
-        <p:txBody>
-          <a:bodyPr rtlCol="0" anchor="ctr" wrap="none" lIns="0" rIns="0"/>
-          <a:lstStyle/>
-          <a:p>
-            <a:pPr algn="ctr"/>
-            <a:r>
-              <a:rPr b="1" sz="1500">
-                <a:solidFill>
-                  <a:srgbClr val="FFFFFF"/>
-                </a:solidFill>
-                <a:latin typeface="Arial"/>
-              </a:rPr>
-              <a:t>UVA</a:t>
-            </a:r>
-          </a:p>
-        </p:txBody>
-      </p:sp>
+          <a:prstGeom prst="rect">
+            <a:avLst/>
+          </a:prstGeom>
+        </p:spPr>
+      </p:pic>
       <p:sp>
         <p:nvSpPr>
           <p:cNvPr id="5" name="TextBox 4"/>
@@ -7603,59 +7461,30 @@
         <p:nvPr/>
       </p:nvGrpSpPr>
       <p:grpSpPr/>
-      <p:sp>
-        <p:nvSpPr>
-          <p:cNvPr id="2" name="Oval 1"/>
-          <p:cNvSpPr/>
-          <p:nvPr/>
-        </p:nvSpPr>
+      <p:pic>
+        <p:nvPicPr>
+          <p:cNvPr id="2" name="Picture 1" descr="ncsu.png"/>
+          <p:cNvPicPr>
+            <a:picLocks noChangeAspect="1"/>
+          </p:cNvPicPr>
+          <p:nvPr/>
+        </p:nvPicPr>
+        <p:blipFill>
+          <a:blip r:embed="rId2"/>
+          <a:stretch>
+            <a:fillRect/>
+          </a:stretch>
+        </p:blipFill>
         <p:spPr>
           <a:xfrm>
             <a:off x="822960" y="384048"/>
             <a:ext cx="731520" cy="731520"/>
           </a:xfrm>
-          <a:prstGeom prst="ellipse">
-            <a:avLst/>
-          </a:prstGeom>
-          <a:solidFill>
-            <a:srgbClr val="CC0000"/>
-          </a:solidFill>
-          <a:ln>
-            <a:noFill/>
-          </a:ln>
-          <a:effectLst/>
-        </p:spPr>
-        <p:style>
-          <a:lnRef idx="1">
-            <a:schemeClr val="accent1"/>
-          </a:lnRef>
-          <a:fillRef idx="3">
-            <a:schemeClr val="accent1"/>
-          </a:fillRef>
-          <a:effectRef idx="2">
-            <a:schemeClr val="accent1"/>
-          </a:effectRef>
-          <a:fontRef idx="minor">
-            <a:schemeClr val="lt1"/>
-          </a:fontRef>
-        </p:style>
-        <p:txBody>
-          <a:bodyPr rtlCol="0" anchor="ctr" wrap="none" lIns="0" rIns="0"/>
-          <a:lstStyle/>
-          <a:p>
-            <a:pPr algn="ctr"/>
-            <a:r>
-              <a:rPr b="1" sz="1500">
-                <a:solidFill>
-                  <a:srgbClr val="FFFFFF"/>
-                </a:solidFill>
-                <a:latin typeface="Arial"/>
-              </a:rPr>
-              <a:t>NCSU</a:t>
-            </a:r>
-          </a:p>
-        </p:txBody>
-      </p:sp>
+          <a:prstGeom prst="rect">
+            <a:avLst/>
+          </a:prstGeom>
+        </p:spPr>
+      </p:pic>
       <p:sp>
         <p:nvSpPr>
           <p:cNvPr id="3" name="TextBox 2"/>
@@ -7691,59 +7520,30 @@
           </a:p>
         </p:txBody>
       </p:sp>
-      <p:sp>
-        <p:nvSpPr>
-          <p:cNvPr id="4" name="Oval 3"/>
-          <p:cNvSpPr/>
-          <p:nvPr/>
-        </p:nvSpPr>
+      <p:pic>
+        <p:nvPicPr>
+          <p:cNvPr id="4" name="Picture 3" descr="uva.png"/>
+          <p:cNvPicPr>
+            <a:picLocks noChangeAspect="1"/>
+          </p:cNvPicPr>
+          <p:nvPr/>
+        </p:nvPicPr>
+        <p:blipFill>
+          <a:blip r:embed="rId3"/>
+          <a:stretch>
+            <a:fillRect/>
+          </a:stretch>
+        </p:blipFill>
         <p:spPr>
           <a:xfrm>
             <a:off x="2148840" y="384048"/>
             <a:ext cx="731520" cy="731520"/>
           </a:xfrm>
-          <a:prstGeom prst="ellipse">
-            <a:avLst/>
-          </a:prstGeom>
-          <a:solidFill>
-            <a:srgbClr val="232D4B"/>
-          </a:solidFill>
-          <a:ln>
-            <a:noFill/>
-          </a:ln>
-          <a:effectLst/>
-        </p:spPr>
-        <p:style>
-          <a:lnRef idx="1">
-            <a:schemeClr val="accent1"/>
-          </a:lnRef>
-          <a:fillRef idx="3">
-            <a:schemeClr val="accent1"/>
-          </a:fillRef>
-          <a:effectRef idx="2">
-            <a:schemeClr val="accent1"/>
-          </a:effectRef>
-          <a:fontRef idx="minor">
-            <a:schemeClr val="lt1"/>
-          </a:fontRef>
-        </p:style>
-        <p:txBody>
-          <a:bodyPr rtlCol="0" anchor="ctr" wrap="none" lIns="0" rIns="0"/>
-          <a:lstStyle/>
-          <a:p>
-            <a:pPr algn="ctr"/>
-            <a:r>
-              <a:rPr b="1" sz="1500">
-                <a:solidFill>
-                  <a:srgbClr val="FFFFFF"/>
-                </a:solidFill>
-                <a:latin typeface="Arial"/>
-              </a:rPr>
-              <a:t>UVA</a:t>
-            </a:r>
-          </a:p>
-        </p:txBody>
-      </p:sp>
+          <a:prstGeom prst="rect">
+            <a:avLst/>
+          </a:prstGeom>
+        </p:spPr>
+      </p:pic>
       <p:sp>
         <p:nvSpPr>
           <p:cNvPr id="5" name="TextBox 4"/>
@@ -7823,59 +7623,30 @@
           </a:p>
         </p:txBody>
       </p:sp>
-      <p:sp>
-        <p:nvSpPr>
-          <p:cNvPr id="7" name="Oval 6"/>
-          <p:cNvSpPr/>
-          <p:nvPr/>
-        </p:nvSpPr>
+      <p:pic>
+        <p:nvPicPr>
+          <p:cNvPr id="7" name="Picture 6" descr="ncsu.png"/>
+          <p:cNvPicPr>
+            <a:picLocks noChangeAspect="1"/>
+          </p:cNvPicPr>
+          <p:nvPr/>
+        </p:nvPicPr>
+        <p:blipFill>
+          <a:blip r:embed="rId2"/>
+          <a:stretch>
+            <a:fillRect/>
+          </a:stretch>
+        </p:blipFill>
         <p:spPr>
           <a:xfrm>
             <a:off x="1097280" y="1691640"/>
             <a:ext cx="566928" cy="566928"/>
           </a:xfrm>
-          <a:prstGeom prst="ellipse">
-            <a:avLst/>
-          </a:prstGeom>
-          <a:solidFill>
-            <a:srgbClr val="CC0000"/>
-          </a:solidFill>
-          <a:ln>
-            <a:noFill/>
-          </a:ln>
-          <a:effectLst/>
-        </p:spPr>
-        <p:style>
-          <a:lnRef idx="1">
-            <a:schemeClr val="accent1"/>
-          </a:lnRef>
-          <a:fillRef idx="3">
-            <a:schemeClr val="accent1"/>
-          </a:fillRef>
-          <a:effectRef idx="2">
-            <a:schemeClr val="accent1"/>
-          </a:effectRef>
-          <a:fontRef idx="minor">
-            <a:schemeClr val="lt1"/>
-          </a:fontRef>
-        </p:style>
-        <p:txBody>
-          <a:bodyPr rtlCol="0" anchor="ctr" wrap="none" lIns="0" rIns="0"/>
-          <a:lstStyle/>
-          <a:p>
-            <a:pPr algn="ctr"/>
-            <a:r>
-              <a:rPr b="1" sz="1100">
-                <a:solidFill>
-                  <a:srgbClr val="FFFFFF"/>
-                </a:solidFill>
-                <a:latin typeface="Arial"/>
-              </a:rPr>
-              <a:t>NCSU</a:t>
-            </a:r>
-          </a:p>
-        </p:txBody>
-      </p:sp>
+          <a:prstGeom prst="rect">
+            <a:avLst/>
+          </a:prstGeom>
+        </p:spPr>
+      </p:pic>
       <p:sp>
         <p:nvSpPr>
           <p:cNvPr id="8" name="TextBox 7"/>
@@ -8270,59 +8041,30 @@
           </a:p>
         </p:txBody>
       </p:sp>
-      <p:sp>
-        <p:nvSpPr>
-          <p:cNvPr id="19" name="Oval 18"/>
-          <p:cNvSpPr/>
-          <p:nvPr/>
-        </p:nvSpPr>
+      <p:pic>
+        <p:nvPicPr>
+          <p:cNvPr id="19" name="Picture 18" descr="uva.png"/>
+          <p:cNvPicPr>
+            <a:picLocks noChangeAspect="1"/>
+          </p:cNvPicPr>
+          <p:nvPr/>
+        </p:nvPicPr>
+        <p:blipFill>
+          <a:blip r:embed="rId3"/>
+          <a:stretch>
+            <a:fillRect/>
+          </a:stretch>
+        </p:blipFill>
         <p:spPr>
           <a:xfrm>
             <a:off x="6583680" y="1691640"/>
             <a:ext cx="566928" cy="566928"/>
           </a:xfrm>
-          <a:prstGeom prst="ellipse">
-            <a:avLst/>
-          </a:prstGeom>
-          <a:solidFill>
-            <a:srgbClr val="232D4B"/>
-          </a:solidFill>
-          <a:ln>
-            <a:noFill/>
-          </a:ln>
-          <a:effectLst/>
-        </p:spPr>
-        <p:style>
-          <a:lnRef idx="1">
-            <a:schemeClr val="accent1"/>
-          </a:lnRef>
-          <a:fillRef idx="3">
-            <a:schemeClr val="accent1"/>
-          </a:fillRef>
-          <a:effectRef idx="2">
-            <a:schemeClr val="accent1"/>
-          </a:effectRef>
-          <a:fontRef idx="minor">
-            <a:schemeClr val="lt1"/>
-          </a:fontRef>
-        </p:style>
-        <p:txBody>
-          <a:bodyPr rtlCol="0" anchor="ctr" wrap="none" lIns="0" rIns="0"/>
-          <a:lstStyle/>
-          <a:p>
-            <a:pPr algn="ctr"/>
-            <a:r>
-              <a:rPr b="1" sz="1100">
-                <a:solidFill>
-                  <a:srgbClr val="FFFFFF"/>
-                </a:solidFill>
-                <a:latin typeface="Arial"/>
-              </a:rPr>
-              <a:t>UVA</a:t>
-            </a:r>
-          </a:p>
-        </p:txBody>
-      </p:sp>
+          <a:prstGeom prst="rect">
+            <a:avLst/>
+          </a:prstGeom>
+        </p:spPr>
+      </p:pic>
       <p:sp>
         <p:nvSpPr>
           <p:cNvPr id="20" name="TextBox 19"/>
@@ -8734,59 +8476,30 @@
         <p:nvPr/>
       </p:nvGrpSpPr>
       <p:grpSpPr/>
-      <p:sp>
-        <p:nvSpPr>
-          <p:cNvPr id="2" name="Oval 1"/>
-          <p:cNvSpPr/>
-          <p:nvPr/>
-        </p:nvSpPr>
+      <p:pic>
+        <p:nvPicPr>
+          <p:cNvPr id="2" name="Picture 1" descr="jsu.png"/>
+          <p:cNvPicPr>
+            <a:picLocks noChangeAspect="1"/>
+          </p:cNvPicPr>
+          <p:nvPr/>
+        </p:nvPicPr>
+        <p:blipFill>
+          <a:blip r:embed="rId2"/>
+          <a:stretch>
+            <a:fillRect/>
+          </a:stretch>
+        </p:blipFill>
         <p:spPr>
           <a:xfrm>
             <a:off x="822960" y="384048"/>
             <a:ext cx="731520" cy="731520"/>
           </a:xfrm>
-          <a:prstGeom prst="ellipse">
-            <a:avLst/>
-          </a:prstGeom>
-          <a:solidFill>
-            <a:srgbClr val="B5121B"/>
-          </a:solidFill>
-          <a:ln>
-            <a:noFill/>
-          </a:ln>
-          <a:effectLst/>
-        </p:spPr>
-        <p:style>
-          <a:lnRef idx="1">
-            <a:schemeClr val="accent1"/>
-          </a:lnRef>
-          <a:fillRef idx="3">
-            <a:schemeClr val="accent1"/>
-          </a:fillRef>
-          <a:effectRef idx="2">
-            <a:schemeClr val="accent1"/>
-          </a:effectRef>
-          <a:fontRef idx="minor">
-            <a:schemeClr val="lt1"/>
-          </a:fontRef>
-        </p:style>
-        <p:txBody>
-          <a:bodyPr rtlCol="0" anchor="ctr" wrap="none" lIns="0" rIns="0"/>
-          <a:lstStyle/>
-          <a:p>
-            <a:pPr algn="ctr"/>
-            <a:r>
-              <a:rPr b="1" sz="1500">
-                <a:solidFill>
-                  <a:srgbClr val="FFFFFF"/>
-                </a:solidFill>
-                <a:latin typeface="Arial"/>
-              </a:rPr>
-              <a:t>JSU</a:t>
-            </a:r>
-          </a:p>
-        </p:txBody>
-      </p:sp>
+          <a:prstGeom prst="rect">
+            <a:avLst/>
+          </a:prstGeom>
+        </p:spPr>
+      </p:pic>
       <p:sp>
         <p:nvSpPr>
           <p:cNvPr id="3" name="TextBox 2"/>
@@ -8822,59 +8535,30 @@
           </a:p>
         </p:txBody>
       </p:sp>
-      <p:sp>
-        <p:nvSpPr>
-          <p:cNvPr id="4" name="Oval 3"/>
-          <p:cNvSpPr/>
-          <p:nvPr/>
-        </p:nvSpPr>
+      <p:pic>
+        <p:nvPicPr>
+          <p:cNvPr id="4" name="Picture 3" descr="ndsu.png"/>
+          <p:cNvPicPr>
+            <a:picLocks noChangeAspect="1"/>
+          </p:cNvPicPr>
+          <p:nvPr/>
+        </p:nvPicPr>
+        <p:blipFill>
+          <a:blip r:embed="rId3"/>
+          <a:stretch>
+            <a:fillRect/>
+          </a:stretch>
+        </p:blipFill>
         <p:spPr>
           <a:xfrm>
             <a:off x="2148840" y="384048"/>
             <a:ext cx="731520" cy="731520"/>
           </a:xfrm>
-          <a:prstGeom prst="ellipse">
-            <a:avLst/>
-          </a:prstGeom>
-          <a:solidFill>
-            <a:srgbClr val="0A5640"/>
-          </a:solidFill>
-          <a:ln>
-            <a:noFill/>
-          </a:ln>
-          <a:effectLst/>
-        </p:spPr>
-        <p:style>
-          <a:lnRef idx="1">
-            <a:schemeClr val="accent1"/>
-          </a:lnRef>
-          <a:fillRef idx="3">
-            <a:schemeClr val="accent1"/>
-          </a:fillRef>
-          <a:effectRef idx="2">
-            <a:schemeClr val="accent1"/>
-          </a:effectRef>
-          <a:fontRef idx="minor">
-            <a:schemeClr val="lt1"/>
-          </a:fontRef>
-        </p:style>
-        <p:txBody>
-          <a:bodyPr rtlCol="0" anchor="ctr" wrap="none" lIns="0" rIns="0"/>
-          <a:lstStyle/>
-          <a:p>
-            <a:pPr algn="ctr"/>
-            <a:r>
-              <a:rPr b="1" sz="1500">
-                <a:solidFill>
-                  <a:srgbClr val="FFFFFF"/>
-                </a:solidFill>
-                <a:latin typeface="Arial"/>
-              </a:rPr>
-              <a:t>NDSU</a:t>
-            </a:r>
-          </a:p>
-        </p:txBody>
-      </p:sp>
+          <a:prstGeom prst="rect">
+            <a:avLst/>
+          </a:prstGeom>
+        </p:spPr>
+      </p:pic>
       <p:sp>
         <p:nvSpPr>
           <p:cNvPr id="5" name="TextBox 4"/>
@@ -9918,59 +9602,30 @@
         <p:nvPr/>
       </p:nvGrpSpPr>
       <p:grpSpPr/>
-      <p:sp>
-        <p:nvSpPr>
-          <p:cNvPr id="2" name="Oval 1"/>
-          <p:cNvSpPr/>
-          <p:nvPr/>
-        </p:nvSpPr>
+      <p:pic>
+        <p:nvPicPr>
+          <p:cNvPr id="2" name="Picture 1" descr="jsu.png"/>
+          <p:cNvPicPr>
+            <a:picLocks noChangeAspect="1"/>
+          </p:cNvPicPr>
+          <p:nvPr/>
+        </p:nvPicPr>
+        <p:blipFill>
+          <a:blip r:embed="rId2"/>
+          <a:stretch>
+            <a:fillRect/>
+          </a:stretch>
+        </p:blipFill>
         <p:spPr>
           <a:xfrm>
             <a:off x="822960" y="384048"/>
             <a:ext cx="731520" cy="731520"/>
           </a:xfrm>
-          <a:prstGeom prst="ellipse">
-            <a:avLst/>
-          </a:prstGeom>
-          <a:solidFill>
-            <a:srgbClr val="B5121B"/>
-          </a:solidFill>
-          <a:ln>
-            <a:noFill/>
-          </a:ln>
-          <a:effectLst/>
-        </p:spPr>
-        <p:style>
-          <a:lnRef idx="1">
-            <a:schemeClr val="accent1"/>
-          </a:lnRef>
-          <a:fillRef idx="3">
-            <a:schemeClr val="accent1"/>
-          </a:fillRef>
-          <a:effectRef idx="2">
-            <a:schemeClr val="accent1"/>
-          </a:effectRef>
-          <a:fontRef idx="minor">
-            <a:schemeClr val="lt1"/>
-          </a:fontRef>
-        </p:style>
-        <p:txBody>
-          <a:bodyPr rtlCol="0" anchor="ctr" wrap="none" lIns="0" rIns="0"/>
-          <a:lstStyle/>
-          <a:p>
-            <a:pPr algn="ctr"/>
-            <a:r>
-              <a:rPr b="1" sz="1500">
-                <a:solidFill>
-                  <a:srgbClr val="FFFFFF"/>
-                </a:solidFill>
-                <a:latin typeface="Arial"/>
-              </a:rPr>
-              <a:t>JSU</a:t>
-            </a:r>
-          </a:p>
-        </p:txBody>
-      </p:sp>
+          <a:prstGeom prst="rect">
+            <a:avLst/>
+          </a:prstGeom>
+        </p:spPr>
+      </p:pic>
       <p:sp>
         <p:nvSpPr>
           <p:cNvPr id="3" name="TextBox 2"/>
@@ -10006,59 +9661,30 @@
           </a:p>
         </p:txBody>
       </p:sp>
-      <p:sp>
-        <p:nvSpPr>
-          <p:cNvPr id="4" name="Oval 3"/>
-          <p:cNvSpPr/>
-          <p:nvPr/>
-        </p:nvSpPr>
+      <p:pic>
+        <p:nvPicPr>
+          <p:cNvPr id="4" name="Picture 3" descr="ndsu.png"/>
+          <p:cNvPicPr>
+            <a:picLocks noChangeAspect="1"/>
+          </p:cNvPicPr>
+          <p:nvPr/>
+        </p:nvPicPr>
+        <p:blipFill>
+          <a:blip r:embed="rId3"/>
+          <a:stretch>
+            <a:fillRect/>
+          </a:stretch>
+        </p:blipFill>
         <p:spPr>
           <a:xfrm>
             <a:off x="2148840" y="384048"/>
             <a:ext cx="731520" cy="731520"/>
           </a:xfrm>
-          <a:prstGeom prst="ellipse">
-            <a:avLst/>
-          </a:prstGeom>
-          <a:solidFill>
-            <a:srgbClr val="0A5640"/>
-          </a:solidFill>
-          <a:ln>
-            <a:noFill/>
-          </a:ln>
-          <a:effectLst/>
-        </p:spPr>
-        <p:style>
-          <a:lnRef idx="1">
-            <a:schemeClr val="accent1"/>
-          </a:lnRef>
-          <a:fillRef idx="3">
-            <a:schemeClr val="accent1"/>
-          </a:fillRef>
-          <a:effectRef idx="2">
-            <a:schemeClr val="accent1"/>
-          </a:effectRef>
-          <a:fontRef idx="minor">
-            <a:schemeClr val="lt1"/>
-          </a:fontRef>
-        </p:style>
-        <p:txBody>
-          <a:bodyPr rtlCol="0" anchor="ctr" wrap="none" lIns="0" rIns="0"/>
-          <a:lstStyle/>
-          <a:p>
-            <a:pPr algn="ctr"/>
-            <a:r>
-              <a:rPr b="1" sz="1500">
-                <a:solidFill>
-                  <a:srgbClr val="FFFFFF"/>
-                </a:solidFill>
-                <a:latin typeface="Arial"/>
-              </a:rPr>
-              <a:t>NDSU</a:t>
-            </a:r>
-          </a:p>
-        </p:txBody>
-      </p:sp>
+          <a:prstGeom prst="rect">
+            <a:avLst/>
+          </a:prstGeom>
+        </p:spPr>
+      </p:pic>
       <p:sp>
         <p:nvSpPr>
           <p:cNvPr id="5" name="TextBox 4"/>
@@ -10138,59 +9764,30 @@
           </a:p>
         </p:txBody>
       </p:sp>
-      <p:sp>
-        <p:nvSpPr>
-          <p:cNvPr id="7" name="Oval 6"/>
-          <p:cNvSpPr/>
-          <p:nvPr/>
-        </p:nvSpPr>
+      <p:pic>
+        <p:nvPicPr>
+          <p:cNvPr id="7" name="Picture 6" descr="jsu.png"/>
+          <p:cNvPicPr>
+            <a:picLocks noChangeAspect="1"/>
+          </p:cNvPicPr>
+          <p:nvPr/>
+        </p:nvPicPr>
+        <p:blipFill>
+          <a:blip r:embed="rId2"/>
+          <a:stretch>
+            <a:fillRect/>
+          </a:stretch>
+        </p:blipFill>
         <p:spPr>
           <a:xfrm>
             <a:off x="1097280" y="1691640"/>
             <a:ext cx="566928" cy="566928"/>
           </a:xfrm>
-          <a:prstGeom prst="ellipse">
-            <a:avLst/>
-          </a:prstGeom>
-          <a:solidFill>
-            <a:srgbClr val="B5121B"/>
-          </a:solidFill>
-          <a:ln>
-            <a:noFill/>
-          </a:ln>
-          <a:effectLst/>
-        </p:spPr>
-        <p:style>
-          <a:lnRef idx="1">
-            <a:schemeClr val="accent1"/>
-          </a:lnRef>
-          <a:fillRef idx="3">
-            <a:schemeClr val="accent1"/>
-          </a:fillRef>
-          <a:effectRef idx="2">
-            <a:schemeClr val="accent1"/>
-          </a:effectRef>
-          <a:fontRef idx="minor">
-            <a:schemeClr val="lt1"/>
-          </a:fontRef>
-        </p:style>
-        <p:txBody>
-          <a:bodyPr rtlCol="0" anchor="ctr" wrap="none" lIns="0" rIns="0"/>
-          <a:lstStyle/>
-          <a:p>
-            <a:pPr algn="ctr"/>
-            <a:r>
-              <a:rPr b="1" sz="1100">
-                <a:solidFill>
-                  <a:srgbClr val="FFFFFF"/>
-                </a:solidFill>
-                <a:latin typeface="Arial"/>
-              </a:rPr>
-              <a:t>JSU</a:t>
-            </a:r>
-          </a:p>
-        </p:txBody>
-      </p:sp>
+          <a:prstGeom prst="rect">
+            <a:avLst/>
+          </a:prstGeom>
+        </p:spPr>
+      </p:pic>
       <p:sp>
         <p:nvSpPr>
           <p:cNvPr id="8" name="TextBox 7"/>
@@ -10585,59 +10182,30 @@
           </a:p>
         </p:txBody>
       </p:sp>
-      <p:sp>
-        <p:nvSpPr>
-          <p:cNvPr id="19" name="Oval 18"/>
-          <p:cNvSpPr/>
-          <p:nvPr/>
-        </p:nvSpPr>
+      <p:pic>
+        <p:nvPicPr>
+          <p:cNvPr id="19" name="Picture 18" descr="ndsu.png"/>
+          <p:cNvPicPr>
+            <a:picLocks noChangeAspect="1"/>
+          </p:cNvPicPr>
+          <p:nvPr/>
+        </p:nvPicPr>
+        <p:blipFill>
+          <a:blip r:embed="rId3"/>
+          <a:stretch>
+            <a:fillRect/>
+          </a:stretch>
+        </p:blipFill>
         <p:spPr>
           <a:xfrm>
             <a:off x="6583680" y="1691640"/>
             <a:ext cx="566928" cy="566928"/>
           </a:xfrm>
-          <a:prstGeom prst="ellipse">
-            <a:avLst/>
-          </a:prstGeom>
-          <a:solidFill>
-            <a:srgbClr val="0A5640"/>
-          </a:solidFill>
-          <a:ln>
-            <a:noFill/>
-          </a:ln>
-          <a:effectLst/>
-        </p:spPr>
-        <p:style>
-          <a:lnRef idx="1">
-            <a:schemeClr val="accent1"/>
-          </a:lnRef>
-          <a:fillRef idx="3">
-            <a:schemeClr val="accent1"/>
-          </a:fillRef>
-          <a:effectRef idx="2">
-            <a:schemeClr val="accent1"/>
-          </a:effectRef>
-          <a:fontRef idx="minor">
-            <a:schemeClr val="lt1"/>
-          </a:fontRef>
-        </p:style>
-        <p:txBody>
-          <a:bodyPr rtlCol="0" anchor="ctr" wrap="none" lIns="0" rIns="0"/>
-          <a:lstStyle/>
-          <a:p>
-            <a:pPr algn="ctr"/>
-            <a:r>
-              <a:rPr b="1" sz="1100">
-                <a:solidFill>
-                  <a:srgbClr val="FFFFFF"/>
-                </a:solidFill>
-                <a:latin typeface="Arial"/>
-              </a:rPr>
-              <a:t>NDSU</a:t>
-            </a:r>
-          </a:p>
-        </p:txBody>
-      </p:sp>
+          <a:prstGeom prst="rect">
+            <a:avLst/>
+          </a:prstGeom>
+        </p:spPr>
+      </p:pic>
       <p:sp>
         <p:nvSpPr>
           <p:cNvPr id="20" name="TextBox 19"/>
@@ -11178,7 +10746,7 @@
             <a:avLst/>
           </a:prstGeom>
           <a:solidFill>
-            <a:srgbClr val="7BAFD4"/>
+            <a:srgbClr val="FFFFFF"/>
           </a:solidFill>
           <a:ln>
             <a:noFill/>
@@ -11200,25 +10768,40 @@
           </a:fontRef>
         </p:style>
         <p:txBody>
-          <a:bodyPr rtlCol="0" anchor="ctr" wrap="none" lIns="0" rIns="0"/>
+          <a:bodyPr rtlCol="0" anchor="ctr"/>
           <a:lstStyle/>
           <a:p>
             <a:pPr algn="ctr"/>
-            <a:r>
-              <a:rPr b="1" sz="1100">
-                <a:solidFill>
-                  <a:srgbClr val="16273D"/>
-                </a:solidFill>
-                <a:latin typeface="Arial"/>
-              </a:rPr>
-              <a:t>UNC</a:t>
-            </a:r>
-          </a:p>
-        </p:txBody>
-      </p:sp>
-      <p:sp>
-        <p:nvSpPr>
-          <p:cNvPr id="6" name="Oval 5"/>
+          </a:p>
+        </p:txBody>
+      </p:sp>
+      <p:pic>
+        <p:nvPicPr>
+          <p:cNvPr id="6" name="Picture 5" descr="unc.png"/>
+          <p:cNvPicPr>
+            <a:picLocks noChangeAspect="1"/>
+          </p:cNvPicPr>
+          <p:nvPr/>
+        </p:nvPicPr>
+        <p:blipFill>
+          <a:blip r:embed="rId2"/>
+          <a:stretch>
+            <a:fillRect/>
+          </a:stretch>
+        </p:blipFill>
+        <p:spPr>
+          <a:xfrm>
+            <a:off x="1113739" y="2567635"/>
+            <a:ext cx="497433" cy="497433"/>
+          </a:xfrm>
+          <a:prstGeom prst="rect">
+            <a:avLst/>
+          </a:prstGeom>
+        </p:spPr>
+      </p:pic>
+      <p:sp>
+        <p:nvSpPr>
+          <p:cNvPr id="7" name="Oval 6"/>
           <p:cNvSpPr/>
           <p:nvPr/>
         </p:nvSpPr>
@@ -11231,7 +10814,7 @@
             <a:avLst/>
           </a:prstGeom>
           <a:solidFill>
-            <a:srgbClr val="4D1979"/>
+            <a:srgbClr val="FFFFFF"/>
           </a:solidFill>
           <a:ln>
             <a:noFill/>
@@ -11253,25 +10836,40 @@
           </a:fontRef>
         </p:style>
         <p:txBody>
-          <a:bodyPr rtlCol="0" anchor="ctr" wrap="none" lIns="0" rIns="0"/>
+          <a:bodyPr rtlCol="0" anchor="ctr"/>
           <a:lstStyle/>
           <a:p>
             <a:pPr algn="ctr"/>
-            <a:r>
-              <a:rPr b="1" sz="1100">
-                <a:solidFill>
-                  <a:srgbClr val="FFFFFF"/>
-                </a:solidFill>
-                <a:latin typeface="Arial"/>
-              </a:rPr>
-              <a:t>TCU</a:t>
-            </a:r>
-          </a:p>
-        </p:txBody>
-      </p:sp>
-      <p:sp>
-        <p:nvSpPr>
-          <p:cNvPr id="7" name="TextBox 6"/>
+          </a:p>
+        </p:txBody>
+      </p:sp>
+      <p:pic>
+        <p:nvPicPr>
+          <p:cNvPr id="8" name="Picture 7" descr="tcu.png"/>
+          <p:cNvPicPr>
+            <a:picLocks noChangeAspect="1"/>
+          </p:cNvPicPr>
+          <p:nvPr/>
+        </p:nvPicPr>
+        <p:blipFill>
+          <a:blip r:embed="rId3"/>
+          <a:stretch>
+            <a:fillRect/>
+          </a:stretch>
+        </p:blipFill>
+        <p:spPr>
+          <a:xfrm>
+            <a:off x="1890979" y="2567635"/>
+            <a:ext cx="497433" cy="497433"/>
+          </a:xfrm>
+          <a:prstGeom prst="rect">
+            <a:avLst/>
+          </a:prstGeom>
+        </p:spPr>
+      </p:pic>
+      <p:sp>
+        <p:nvSpPr>
+          <p:cNvPr id="9" name="TextBox 8"/>
           <p:cNvSpPr txBox="1"/>
           <p:nvPr/>
         </p:nvSpPr>
@@ -11306,7 +10904,7 @@
       </p:sp>
       <p:sp>
         <p:nvSpPr>
-          <p:cNvPr id="8" name="TextBox 7"/>
+          <p:cNvPr id="10" name="TextBox 9"/>
           <p:cNvSpPr txBox="1"/>
           <p:nvPr/>
         </p:nvSpPr>
@@ -11341,7 +10939,7 @@
       </p:sp>
       <p:sp>
         <p:nvSpPr>
-          <p:cNvPr id="9" name="TextBox 8"/>
+          <p:cNvPr id="11" name="TextBox 10"/>
           <p:cNvSpPr txBox="1"/>
           <p:nvPr/>
         </p:nvSpPr>
@@ -11376,7 +10974,7 @@
       </p:sp>
       <p:sp>
         <p:nvSpPr>
-          <p:cNvPr id="10" name="TextBox 9"/>
+          <p:cNvPr id="12" name="TextBox 11"/>
           <p:cNvSpPr txBox="1"/>
           <p:nvPr/>
         </p:nvSpPr>
@@ -11411,7 +11009,7 @@
       </p:sp>
       <p:sp>
         <p:nvSpPr>
-          <p:cNvPr id="11" name="Rounded Rectangle 10"/>
+          <p:cNvPr id="13" name="Rounded Rectangle 12"/>
           <p:cNvSpPr/>
           <p:nvPr/>
         </p:nvSpPr>
@@ -11455,7 +11053,7 @@
       </p:sp>
       <p:sp>
         <p:nvSpPr>
-          <p:cNvPr id="12" name="Oval 11"/>
+          <p:cNvPr id="14" name="Oval 13"/>
           <p:cNvSpPr/>
           <p:nvPr/>
         </p:nvSpPr>
@@ -11468,7 +11066,7 @@
             <a:avLst/>
           </a:prstGeom>
           <a:solidFill>
-            <a:srgbClr val="CC0000"/>
+            <a:srgbClr val="FFFFFF"/>
           </a:solidFill>
           <a:ln>
             <a:noFill/>
@@ -11490,25 +11088,40 @@
           </a:fontRef>
         </p:style>
         <p:txBody>
-          <a:bodyPr rtlCol="0" anchor="ctr" wrap="none" lIns="0" rIns="0"/>
+          <a:bodyPr rtlCol="0" anchor="ctr"/>
           <a:lstStyle/>
           <a:p>
             <a:pPr algn="ctr"/>
-            <a:r>
-              <a:rPr b="1" sz="1100">
-                <a:solidFill>
-                  <a:srgbClr val="FFFFFF"/>
-                </a:solidFill>
-                <a:latin typeface="Arial"/>
-              </a:rPr>
-              <a:t>NCSU</a:t>
-            </a:r>
-          </a:p>
-        </p:txBody>
-      </p:sp>
-      <p:sp>
-        <p:nvSpPr>
-          <p:cNvPr id="13" name="Oval 12"/>
+          </a:p>
+        </p:txBody>
+      </p:sp>
+      <p:pic>
+        <p:nvPicPr>
+          <p:cNvPr id="15" name="Picture 14" descr="ncsu.png"/>
+          <p:cNvPicPr>
+            <a:picLocks noChangeAspect="1"/>
+          </p:cNvPicPr>
+          <p:nvPr/>
+        </p:nvPicPr>
+        <p:blipFill>
+          <a:blip r:embed="rId4"/>
+          <a:stretch>
+            <a:fillRect/>
+          </a:stretch>
+        </p:blipFill>
+        <p:spPr>
+          <a:xfrm>
+            <a:off x="1113739" y="3829507"/>
+            <a:ext cx="497433" cy="497433"/>
+          </a:xfrm>
+          <a:prstGeom prst="rect">
+            <a:avLst/>
+          </a:prstGeom>
+        </p:spPr>
+      </p:pic>
+      <p:sp>
+        <p:nvSpPr>
+          <p:cNvPr id="16" name="Oval 15"/>
           <p:cNvSpPr/>
           <p:nvPr/>
         </p:nvSpPr>
@@ -11521,7 +11134,7 @@
             <a:avLst/>
           </a:prstGeom>
           <a:solidFill>
-            <a:srgbClr val="232D4B"/>
+            <a:srgbClr val="FFFFFF"/>
           </a:solidFill>
           <a:ln>
             <a:noFill/>
@@ -11543,25 +11156,40 @@
           </a:fontRef>
         </p:style>
         <p:txBody>
-          <a:bodyPr rtlCol="0" anchor="ctr" wrap="none" lIns="0" rIns="0"/>
+          <a:bodyPr rtlCol="0" anchor="ctr"/>
           <a:lstStyle/>
           <a:p>
             <a:pPr algn="ctr"/>
-            <a:r>
-              <a:rPr b="1" sz="1100">
-                <a:solidFill>
-                  <a:srgbClr val="FFFFFF"/>
-                </a:solidFill>
-                <a:latin typeface="Arial"/>
-              </a:rPr>
-              <a:t>UVA</a:t>
-            </a:r>
-          </a:p>
-        </p:txBody>
-      </p:sp>
-      <p:sp>
-        <p:nvSpPr>
-          <p:cNvPr id="14" name="TextBox 13"/>
+          </a:p>
+        </p:txBody>
+      </p:sp>
+      <p:pic>
+        <p:nvPicPr>
+          <p:cNvPr id="17" name="Picture 16" descr="uva.png"/>
+          <p:cNvPicPr>
+            <a:picLocks noChangeAspect="1"/>
+          </p:cNvPicPr>
+          <p:nvPr/>
+        </p:nvPicPr>
+        <p:blipFill>
+          <a:blip r:embed="rId5"/>
+          <a:stretch>
+            <a:fillRect/>
+          </a:stretch>
+        </p:blipFill>
+        <p:spPr>
+          <a:xfrm>
+            <a:off x="1890979" y="3829507"/>
+            <a:ext cx="497433" cy="497433"/>
+          </a:xfrm>
+          <a:prstGeom prst="rect">
+            <a:avLst/>
+          </a:prstGeom>
+        </p:spPr>
+      </p:pic>
+      <p:sp>
+        <p:nvSpPr>
+          <p:cNvPr id="18" name="TextBox 17"/>
           <p:cNvSpPr txBox="1"/>
           <p:nvPr/>
         </p:nvSpPr>
@@ -11596,7 +11224,7 @@
       </p:sp>
       <p:sp>
         <p:nvSpPr>
-          <p:cNvPr id="15" name="TextBox 14"/>
+          <p:cNvPr id="19" name="TextBox 18"/>
           <p:cNvSpPr txBox="1"/>
           <p:nvPr/>
         </p:nvSpPr>
@@ -11631,7 +11259,7 @@
       </p:sp>
       <p:sp>
         <p:nvSpPr>
-          <p:cNvPr id="16" name="TextBox 15"/>
+          <p:cNvPr id="20" name="TextBox 19"/>
           <p:cNvSpPr txBox="1"/>
           <p:nvPr/>
         </p:nvSpPr>
@@ -11666,7 +11294,7 @@
       </p:sp>
       <p:sp>
         <p:nvSpPr>
-          <p:cNvPr id="17" name="TextBox 16"/>
+          <p:cNvPr id="21" name="TextBox 20"/>
           <p:cNvSpPr txBox="1"/>
           <p:nvPr/>
         </p:nvSpPr>
@@ -11701,7 +11329,7 @@
       </p:sp>
       <p:sp>
         <p:nvSpPr>
-          <p:cNvPr id="18" name="Rounded Rectangle 17"/>
+          <p:cNvPr id="22" name="Rounded Rectangle 21"/>
           <p:cNvSpPr/>
           <p:nvPr/>
         </p:nvSpPr>
@@ -11745,7 +11373,7 @@
       </p:sp>
       <p:sp>
         <p:nvSpPr>
-          <p:cNvPr id="19" name="Oval 18"/>
+          <p:cNvPr id="23" name="Oval 22"/>
           <p:cNvSpPr/>
           <p:nvPr/>
         </p:nvSpPr>
@@ -11758,7 +11386,7 @@
             <a:avLst/>
           </a:prstGeom>
           <a:solidFill>
-            <a:srgbClr val="B5121B"/>
+            <a:srgbClr val="FFFFFF"/>
           </a:solidFill>
           <a:ln>
             <a:noFill/>
@@ -11780,25 +11408,40 @@
           </a:fontRef>
         </p:style>
         <p:txBody>
-          <a:bodyPr rtlCol="0" anchor="ctr" wrap="none" lIns="0" rIns="0"/>
+          <a:bodyPr rtlCol="0" anchor="ctr"/>
           <a:lstStyle/>
           <a:p>
             <a:pPr algn="ctr"/>
-            <a:r>
-              <a:rPr b="1" sz="1100">
-                <a:solidFill>
-                  <a:srgbClr val="FFFFFF"/>
-                </a:solidFill>
-                <a:latin typeface="Arial"/>
-              </a:rPr>
-              <a:t>JSU</a:t>
-            </a:r>
-          </a:p>
-        </p:txBody>
-      </p:sp>
-      <p:sp>
-        <p:nvSpPr>
-          <p:cNvPr id="20" name="Oval 19"/>
+          </a:p>
+        </p:txBody>
+      </p:sp>
+      <p:pic>
+        <p:nvPicPr>
+          <p:cNvPr id="24" name="Picture 23" descr="jsu.png"/>
+          <p:cNvPicPr>
+            <a:picLocks noChangeAspect="1"/>
+          </p:cNvPicPr>
+          <p:nvPr/>
+        </p:nvPicPr>
+        <p:blipFill>
+          <a:blip r:embed="rId6"/>
+          <a:stretch>
+            <a:fillRect/>
+          </a:stretch>
+        </p:blipFill>
+        <p:spPr>
+          <a:xfrm>
+            <a:off x="1113739" y="5091379"/>
+            <a:ext cx="497433" cy="497433"/>
+          </a:xfrm>
+          <a:prstGeom prst="rect">
+            <a:avLst/>
+          </a:prstGeom>
+        </p:spPr>
+      </p:pic>
+      <p:sp>
+        <p:nvSpPr>
+          <p:cNvPr id="25" name="Oval 24"/>
           <p:cNvSpPr/>
           <p:nvPr/>
         </p:nvSpPr>
@@ -11811,7 +11454,7 @@
             <a:avLst/>
           </a:prstGeom>
           <a:solidFill>
-            <a:srgbClr val="0A5640"/>
+            <a:srgbClr val="FFFFFF"/>
           </a:solidFill>
           <a:ln>
             <a:noFill/>
@@ -11833,25 +11476,40 @@
           </a:fontRef>
         </p:style>
         <p:txBody>
-          <a:bodyPr rtlCol="0" anchor="ctr" wrap="none" lIns="0" rIns="0"/>
+          <a:bodyPr rtlCol="0" anchor="ctr"/>
           <a:lstStyle/>
           <a:p>
             <a:pPr algn="ctr"/>
-            <a:r>
-              <a:rPr b="1" sz="1100">
-                <a:solidFill>
-                  <a:srgbClr val="FFFFFF"/>
-                </a:solidFill>
-                <a:latin typeface="Arial"/>
-              </a:rPr>
-              <a:t>NDSU</a:t>
-            </a:r>
-          </a:p>
-        </p:txBody>
-      </p:sp>
-      <p:sp>
-        <p:nvSpPr>
-          <p:cNvPr id="21" name="TextBox 20"/>
+          </a:p>
+        </p:txBody>
+      </p:sp>
+      <p:pic>
+        <p:nvPicPr>
+          <p:cNvPr id="26" name="Picture 25" descr="ndsu.png"/>
+          <p:cNvPicPr>
+            <a:picLocks noChangeAspect="1"/>
+          </p:cNvPicPr>
+          <p:nvPr/>
+        </p:nvPicPr>
+        <p:blipFill>
+          <a:blip r:embed="rId7"/>
+          <a:stretch>
+            <a:fillRect/>
+          </a:stretch>
+        </p:blipFill>
+        <p:spPr>
+          <a:xfrm>
+            <a:off x="1890979" y="5091379"/>
+            <a:ext cx="497433" cy="497433"/>
+          </a:xfrm>
+          <a:prstGeom prst="rect">
+            <a:avLst/>
+          </a:prstGeom>
+        </p:spPr>
+      </p:pic>
+      <p:sp>
+        <p:nvSpPr>
+          <p:cNvPr id="27" name="TextBox 26"/>
           <p:cNvSpPr txBox="1"/>
           <p:nvPr/>
         </p:nvSpPr>
@@ -11886,7 +11544,7 @@
       </p:sp>
       <p:sp>
         <p:nvSpPr>
-          <p:cNvPr id="22" name="TextBox 21"/>
+          <p:cNvPr id="28" name="TextBox 27"/>
           <p:cNvSpPr txBox="1"/>
           <p:nvPr/>
         </p:nvSpPr>
@@ -11921,7 +11579,7 @@
       </p:sp>
       <p:sp>
         <p:nvSpPr>
-          <p:cNvPr id="23" name="TextBox 22"/>
+          <p:cNvPr id="29" name="TextBox 28"/>
           <p:cNvSpPr txBox="1"/>
           <p:nvPr/>
         </p:nvSpPr>
@@ -11956,7 +11614,7 @@
       </p:sp>
       <p:sp>
         <p:nvSpPr>
-          <p:cNvPr id="24" name="TextBox 23"/>
+          <p:cNvPr id="30" name="TextBox 29"/>
           <p:cNvSpPr txBox="1"/>
           <p:nvPr/>
         </p:nvSpPr>
@@ -11991,7 +11649,7 @@
       </p:sp>
       <p:sp>
         <p:nvSpPr>
-          <p:cNvPr id="25" name="TextBox 24"/>
+          <p:cNvPr id="31" name="TextBox 30"/>
           <p:cNvSpPr txBox="1"/>
           <p:nvPr/>
         </p:nvSpPr>

</xml_diff>

<commit_message>
Episode deck: 2025 stat lines for all 23 named players
CFBD season stats incl. Harvard (Craig 25-7) and NDSU FCS rows; transfers
credited to their 2025 team (Edwards/Kekahuna Wisconsin, Pribula Missouri,
Lewis Tennessee, Flores UCLA, Trader Miami).

Co-Authored-By: Claude Fable 5 <noreply@anthropic.com>
</commit_message>
<xml_diff>
--- a/decks/2026_Week0_Episode1.pptx
+++ b/decks/2026_Week0_Episode1.pptx
@@ -5641,7 +5641,7 @@
                 </a:solidFill>
                 <a:latin typeface="Arial"/>
               </a:rPr>
-              <a:t>QB — Maryland grad; 2,881 yds/15 TD in 2024; Belichick's pick</a:t>
+              <a:t>QB — Maryland grad; 2,881 yds/15 TD in '24; '25 at Wisconsin lost to injury (7/16, 113 yds); Belichick's pick</a:t>
             </a:r>
           </a:p>
         </p:txBody>
@@ -5711,7 +5711,7 @@
                 </a:solidFill>
                 <a:latin typeface="Arial"/>
               </a:rPr>
-              <a:t>RB — Corey's key, but see the run-front matchup</a:t>
+              <a:t>RB — 2025: 464 yds at 5.5/carry, 3 total TD — Corey's key, but see the run-front matchup</a:t>
             </a:r>
           </a:p>
         </p:txBody>
@@ -5781,7 +5781,7 @@
                 </a:solidFill>
                 <a:latin typeface="Arial"/>
               </a:rPr>
-              <a:t>WR — the X</a:t>
+              <a:t>WR — the X; 2025: 60 rec, 671 yds, 6 TD</a:t>
             </a:r>
           </a:p>
         </p:txBody>
@@ -5851,7 +5851,7 @@
                 </a:solidFill>
                 <a:latin typeface="Arial"/>
               </a:rPr>
-              <a:t>slot</a:t>
+              <a:t>slot — 2025 at Wisconsin: 26 rec, 211 yds; 129 rush yds, 1 TD</a:t>
             </a:r>
           </a:p>
         </p:txBody>
@@ -6059,7 +6059,7 @@
                 </a:solidFill>
                 <a:latin typeface="Arial"/>
               </a:rPr>
-              <a:t>QB — grad transfer, first year as the guy post-Hoover</a:t>
+              <a:t>QB — Harvard grad transfer; 2025: 61.6%, 2,829 yds, 25-7; first year as the guy post-Hoover</a:t>
             </a:r>
           </a:p>
         </p:txBody>
@@ -6129,7 +6129,7 @@
                 </a:solidFill>
                 <a:latin typeface="Arial"/>
               </a:rPr>
-              <a:t>WR</a:t>
+              <a:t>WR — 2025: 54 rec, 730 yds, 7 TD (13.5 avg)</a:t>
             </a:r>
           </a:p>
         </p:txBody>
@@ -6199,7 +6199,7 @@
                 </a:solidFill>
                 <a:latin typeface="Arial"/>
               </a:rPr>
-              <a:t>TE</a:t>
+              <a:t>TE — 2025: just 1 catch (a TD)</a:t>
             </a:r>
           </a:p>
         </p:txBody>
@@ -6269,7 +6269,7 @@
                 </a:solidFill>
                 <a:latin typeface="Arial"/>
               </a:rPr>
-              <a:t>NT — anchors the #28 run front</a:t>
+              <a:t>NT — anchors the #28 run front; 2025: 26 tkl, 2 TFL, 1 sack</a:t>
             </a:r>
           </a:p>
         </p:txBody>
@@ -7782,7 +7782,7 @@
                 </a:solidFill>
                 <a:latin typeface="Arial"/>
               </a:rPr>
-              <a:t>QB — yr 3; 3,105 yds, 25 TD at 68.8%; top-5 returning ACC QB</a:t>
+              <a:t>QB — yr 3; 2025: 3,105 yds, 25-9 at 68.8%; top-5 returning ACC QB</a:t>
             </a:r>
           </a:p>
         </p:txBody>
@@ -7852,7 +7852,7 @@
                 </a:solidFill>
                 <a:latin typeface="Arial"/>
               </a:rPr>
-              <a:t>RB</a:t>
+              <a:t>RB — 2025: 595 yds at 5.6/carry, 4 TD, plus 15 catches (Jayden on the stat sheet)</a:t>
             </a:r>
           </a:p>
         </p:txBody>
@@ -7922,7 +7922,7 @@
                 </a:solidFill>
                 <a:latin typeface="Arial"/>
               </a:rPr>
-              <a:t>WR</a:t>
+              <a:t>WR — Miami transfer; 2025: 13 rec, 178 yds, 1 TD</a:t>
             </a:r>
           </a:p>
         </p:txBody>
@@ -7992,7 +7992,7 @@
                 </a:solidFill>
                 <a:latin typeface="Arial"/>
               </a:rPr>
-              <a:t>DE</a:t>
+              <a:t>DE — 2025: 6 tkl, 2 TFL, 1 sack</a:t>
             </a:r>
           </a:p>
         </p:txBody>
@@ -8200,7 +8200,7 @@
                 </a:solidFill>
                 <a:latin typeface="Arial"/>
               </a:rPr>
-              <a:t>QB — Missouri transfer; named starter Jul 19; 11-9 TD-INT is the risk</a:t>
+              <a:t>QB — Missouri transfer; 2025: 67.4%, 1,946 yds, 11-9 TD-INT (+6 rush TD); named starter Jul 19</a:t>
             </a:r>
           </a:p>
         </p:txBody>
@@ -8270,7 +8270,7 @@
                 </a:solidFill>
                 <a:latin typeface="Arial"/>
               </a:rPr>
-              <a:t>RB</a:t>
+              <a:t>RB — Tennessee transfer; 2025: 290 yds, 7 TD on 70 carries</a:t>
             </a:r>
           </a:p>
         </p:txBody>
@@ -8340,7 +8340,7 @@
                 </a:solidFill>
                 <a:latin typeface="Arial"/>
               </a:rPr>
-              <a:t>WR</a:t>
+              <a:t>WR — UCLA transfer; 2025: 26 rec, 274 yds</a:t>
             </a:r>
           </a:p>
         </p:txBody>
@@ -8410,7 +8410,7 @@
                 </a:solidFill>
                 <a:latin typeface="Arial"/>
               </a:rPr>
-              <a:t>DE</a:t>
+              <a:t>DE — 2025: 44 tkl, 5.5 TFL, 3.5 sacks</a:t>
             </a:r>
           </a:p>
         </p:txBody>
@@ -9923,7 +9923,7 @@
                 </a:solidFill>
                 <a:latin typeface="Arial"/>
               </a:rPr>
-              <a:t>QB — 2,600+ combined yds; dual-threat = Bison D's soft spot</a:t>
+              <a:t>QB — 2025: 1,514 pass + 1,075 rush (5.9/carry), 16 total TD; dual-threat = Bison D's soft spot</a:t>
             </a:r>
           </a:p>
         </p:txBody>
@@ -9993,7 +9993,7 @@
                 </a:solidFill>
                 <a:latin typeface="Arial"/>
               </a:rPr>
-              <a:t>RB — the 'unleash' key</a:t>
+              <a:t>RB — the 'unleash' key; 2025: 201 yds on 51 carries behind Creel</a:t>
             </a:r>
           </a:p>
         </p:txBody>
@@ -10063,7 +10063,7 @@
                 </a:solidFill>
                 <a:latin typeface="Arial"/>
               </a:rPr>
-              <a:t>DT</a:t>
+              <a:t>DT — 2025: 20 tkl, 4.5 TFL, 2 sacks</a:t>
             </a:r>
           </a:p>
         </p:txBody>
@@ -10133,7 +10133,7 @@
                 </a:solidFill>
                 <a:latin typeface="Arial"/>
               </a:rPr>
-              <a:t>EDGE</a:t>
+              <a:t>EDGE — 2025: 14 tkl, 1.5 TFL, 1 INT</a:t>
             </a:r>
           </a:p>
         </p:txBody>
@@ -10341,7 +10341,7 @@
                 </a:solidFill>
                 <a:latin typeface="Arial"/>
               </a:rPr>
-              <a:t>QB — FIRST career start; 'strongest arm since Wentz'</a:t>
+              <a:t>QB — FIRST career start; 2025 in relief: 25/44, 381 yds, 4-1, plus 88 rush yds; 'strongest arm since Wentz'</a:t>
             </a:r>
           </a:p>
         </p:txBody>
@@ -10411,7 +10411,7 @@
                 </a:solidFill>
                 <a:latin typeface="Arial"/>
               </a:rPr>
-              <a:t>RB</a:t>
+              <a:t>RB — 2025: 502 yds at 5.3/carry, 6 TD</a:t>
             </a:r>
           </a:p>
         </p:txBody>
@@ -10481,7 +10481,7 @@
                 </a:solidFill>
                 <a:latin typeface="Arial"/>
               </a:rPr>
-              <a:t>WR</a:t>
+              <a:t>WR — 2025: 6 catches, 159 yds, 2 TD — 26.5 per grab</a:t>
             </a:r>
           </a:p>
         </p:txBody>

</xml_diff>

<commit_message>
Line ledger (review A): first-seen/current per book, CLV, EDGE_GONE/STRUCT flags, publish step
- line_ledger.py: append-only lines_history.jsonl (row = change, pull markers
  keep the as-of stamp); consensus series per game; assess() = CLV signed to
  the model side + EDGE_GONE / EDGE_FLIP / CLV+- flags. Seeded from alerts_log
  (Jul 14) and the Aug 18 cache so Week 0 has a true first-seen.
- fetch_lines: spread_book / ml_book provenance + per-book raw lines; real
  pulls are recorded to the ledger.
- edge_report: same-book devig, FIRST>NOW + CLV columns, STRUCT flag (>=15pp
  model vs no-vig ML), --week auto, --publish -> card_data_week{N}.json.
- make_episode_deck: machine/market/win-prob read from card_data; ledger strip
  + FLAGS ribbon per game. Deck v7.
- publish_friday.bat + Task Scheduler "NCAA Publish Pull" (Fri 17:00).

Co-Authored-By: Claude Fable 5 <noreply@anthropic.com>
</commit_message>
<xml_diff>
--- a/decks/2026_Week0_Episode1.pptx
+++ b/decks/2026_Week0_Episode1.pptx
@@ -5664,7 +5664,7 @@
           <a:p>
             <a:pPr algn="l"/>
             <a:r>
-              <a:rPr sz="1600" b="1" i="0">
+              <a:rPr sz="1250" b="1" i="0">
                 <a:solidFill>
                   <a:srgbClr val="F47321"/>
                 </a:solidFill>
@@ -5906,6 +5906,76 @@
       <p:sp>
         <p:nvSpPr>
           <p:cNvPr id="31" name="TextBox 30"/>
+          <p:cNvSpPr txBox="1"/>
+          <p:nvPr/>
+        </p:nvSpPr>
+        <p:spPr>
+          <a:xfrm>
+            <a:off x="8046720" y="5532120"/>
+            <a:ext cx="3017520" cy="274320"/>
+          </a:xfrm>
+          <a:prstGeom prst="rect">
+            <a:avLst/>
+          </a:prstGeom>
+          <a:noFill/>
+        </p:spPr>
+        <p:txBody>
+          <a:bodyPr wrap="square" lIns="0" rIns="0" tIns="0" bIns="0">
+            <a:spAutoFit/>
+          </a:bodyPr>
+          <a:lstStyle/>
+          <a:p>
+            <a:pPr algn="l"/>
+            <a:r>
+              <a:rPr sz="950" b="1" i="0">
+                <a:solidFill>
+                  <a:srgbClr val="F47321"/>
+                </a:solidFill>
+                <a:latin typeface="Arial"/>
+              </a:rPr>
+              <a:t>FLAGS  EDGE_GONE · CLV+2.5</a:t>
+            </a:r>
+          </a:p>
+        </p:txBody>
+      </p:sp>
+      <p:sp>
+        <p:nvSpPr>
+          <p:cNvPr id="32" name="TextBox 31"/>
+          <p:cNvSpPr txBox="1"/>
+          <p:nvPr/>
+        </p:nvSpPr>
+        <p:spPr>
+          <a:xfrm>
+            <a:off x="822960" y="6053328"/>
+            <a:ext cx="10515600" cy="228600"/>
+          </a:xfrm>
+          <a:prstGeom prst="rect">
+            <a:avLst/>
+          </a:prstGeom>
+          <a:noFill/>
+        </p:spPr>
+        <p:txBody>
+          <a:bodyPr wrap="square" lIns="0" rIns="0" tIns="0" bIns="0">
+            <a:spAutoFit/>
+          </a:bodyPr>
+          <a:lstStyle/>
+          <a:p>
+            <a:pPr algn="l"/>
+            <a:r>
+              <a:rPr sz="900" b="0" i="0">
+                <a:solidFill>
+                  <a:srgbClr val="5C6B7E"/>
+                </a:solidFill>
+                <a:latin typeface="Arial"/>
+              </a:rPr>
+              <a:t>Line ledger: first-seen –3 (Aug 18) → now –5.5 · opened –3 · CLV +2.5 · market ML 66% UNLV</a:t>
+            </a:r>
+          </a:p>
+        </p:txBody>
+      </p:sp>
+      <p:sp>
+        <p:nvSpPr>
+          <p:cNvPr id="33" name="TextBox 32"/>
           <p:cNvSpPr txBox="1"/>
           <p:nvPr/>
         </p:nvSpPr>
@@ -7969,7 +8039,7 @@
                 </a:solidFill>
                 <a:latin typeface="Arial"/>
               </a:rPr>
-              <a:t>NDSU –2.7   ·   –10 → –7</a:t>
+              <a:t>NDSU –2.7   ·   –7 / –7</a:t>
             </a:r>
           </a:p>
         </p:txBody>
@@ -9209,7 +9279,7 @@
                 </a:solidFill>
                 <a:latin typeface="Arial"/>
               </a:rPr>
-              <a:t>STRUCTURAL DISAGREEMENT: moneyline says TCU ~71%, machine says 54% — a 17-pt gap, not a spread quibble</a:t>
+              <a:t>STRUCTURAL DISAGREEMENT: moneyline says TCU ~73%, machine says 54% — an 18-pt gap, not a spread quibble</a:t>
             </a:r>
           </a:p>
         </p:txBody>
@@ -9778,6 +9848,76 @@
       <p:sp>
         <p:nvSpPr>
           <p:cNvPr id="31" name="TextBox 30"/>
+          <p:cNvSpPr txBox="1"/>
+          <p:nvPr/>
+        </p:nvSpPr>
+        <p:spPr>
+          <a:xfrm>
+            <a:off x="8046720" y="5532120"/>
+            <a:ext cx="3017520" cy="274320"/>
+          </a:xfrm>
+          <a:prstGeom prst="rect">
+            <a:avLst/>
+          </a:prstGeom>
+          <a:noFill/>
+        </p:spPr>
+        <p:txBody>
+          <a:bodyPr wrap="square" lIns="0" rIns="0" tIns="0" bIns="0">
+            <a:spAutoFit/>
+          </a:bodyPr>
+          <a:lstStyle/>
+          <a:p>
+            <a:pPr algn="l"/>
+            <a:r>
+              <a:rPr sz="950" b="1" i="0">
+                <a:solidFill>
+                  <a:srgbClr val="F47321"/>
+                </a:solidFill>
+                <a:latin typeface="Arial"/>
+              </a:rPr>
+              <a:t>FLAGS  YEL · STRUCT</a:t>
+            </a:r>
+          </a:p>
+        </p:txBody>
+      </p:sp>
+      <p:sp>
+        <p:nvSpPr>
+          <p:cNvPr id="32" name="TextBox 31"/>
+          <p:cNvSpPr txBox="1"/>
+          <p:nvPr/>
+        </p:nvSpPr>
+        <p:spPr>
+          <a:xfrm>
+            <a:off x="822960" y="6053328"/>
+            <a:ext cx="10515600" cy="228600"/>
+          </a:xfrm>
+          <a:prstGeom prst="rect">
+            <a:avLst/>
+          </a:prstGeom>
+          <a:noFill/>
+        </p:spPr>
+        <p:txBody>
+          <a:bodyPr wrap="square" lIns="0" rIns="0" tIns="0" bIns="0">
+            <a:spAutoFit/>
+          </a:bodyPr>
+          <a:lstStyle/>
+          <a:p>
+            <a:pPr algn="l"/>
+            <a:r>
+              <a:rPr sz="900" b="0" i="0">
+                <a:solidFill>
+                  <a:srgbClr val="5C6B7E"/>
+                </a:solidFill>
+                <a:latin typeface="Arial"/>
+              </a:rPr>
+              <a:t>Line ledger: first-seen –6.5 (Aug 18) → now –7.5 · opened –7.5 · CLV -1 · market ML 73% TCU</a:t>
+            </a:r>
+          </a:p>
+        </p:txBody>
+      </p:sp>
+      <p:sp>
+        <p:nvSpPr>
+          <p:cNvPr id="33" name="TextBox 32"/>
           <p:cNvSpPr txBox="1"/>
           <p:nvPr/>
         </p:nvSpPr>
@@ -11677,7 +11817,7 @@
           <a:p>
             <a:pPr algn="l"/>
             <a:r>
-              <a:rPr sz="1600" b="1" i="0">
+              <a:rPr sz="1250" b="1" i="0">
                 <a:solidFill>
                   <a:srgbClr val="F47321"/>
                 </a:solidFill>
@@ -11919,6 +12059,76 @@
       <p:sp>
         <p:nvSpPr>
           <p:cNvPr id="31" name="TextBox 30"/>
+          <p:cNvSpPr txBox="1"/>
+          <p:nvPr/>
+        </p:nvSpPr>
+        <p:spPr>
+          <a:xfrm>
+            <a:off x="8046720" y="5532120"/>
+            <a:ext cx="3017520" cy="274320"/>
+          </a:xfrm>
+          <a:prstGeom prst="rect">
+            <a:avLst/>
+          </a:prstGeom>
+          <a:noFill/>
+        </p:spPr>
+        <p:txBody>
+          <a:bodyPr wrap="square" lIns="0" rIns="0" tIns="0" bIns="0">
+            <a:spAutoFit/>
+          </a:bodyPr>
+          <a:lstStyle/>
+          <a:p>
+            <a:pPr algn="l"/>
+            <a:r>
+              <a:rPr sz="950" b="1" i="0">
+                <a:solidFill>
+                  <a:srgbClr val="F47321"/>
+                </a:solidFill>
+                <a:latin typeface="Arial"/>
+              </a:rPr>
+              <a:t>FLAGS  EDGE_GONE · CLV+2.5</a:t>
+            </a:r>
+          </a:p>
+        </p:txBody>
+      </p:sp>
+      <p:sp>
+        <p:nvSpPr>
+          <p:cNvPr id="32" name="TextBox 31"/>
+          <p:cNvSpPr txBox="1"/>
+          <p:nvPr/>
+        </p:nvSpPr>
+        <p:spPr>
+          <a:xfrm>
+            <a:off x="822960" y="6053328"/>
+            <a:ext cx="10515600" cy="228600"/>
+          </a:xfrm>
+          <a:prstGeom prst="rect">
+            <a:avLst/>
+          </a:prstGeom>
+          <a:noFill/>
+        </p:spPr>
+        <p:txBody>
+          <a:bodyPr wrap="square" lIns="0" rIns="0" tIns="0" bIns="0">
+            <a:spAutoFit/>
+          </a:bodyPr>
+          <a:lstStyle/>
+          <a:p>
+            <a:pPr algn="l"/>
+            <a:r>
+              <a:rPr sz="900" b="0" i="0">
+                <a:solidFill>
+                  <a:srgbClr val="5C6B7E"/>
+                </a:solidFill>
+                <a:latin typeface="Arial"/>
+              </a:rPr>
+              <a:t>Line ledger: first-seen –3 (Aug 18) → now –5.5 · opened –3.5 · CLV +2.5 · market ML 66% UVA</a:t>
+            </a:r>
+          </a:p>
+        </p:txBody>
+      </p:sp>
+      <p:sp>
+        <p:nvSpPr>
+          <p:cNvPr id="33" name="TextBox 32"/>
           <p:cNvSpPr txBox="1"/>
           <p:nvPr/>
         </p:nvSpPr>
@@ -13754,7 +13964,7 @@
                 </a:solidFill>
                 <a:latin typeface="Arial"/>
               </a:rPr>
-              <a:t>–10 → –7</a:t>
+              <a:t>–7 / –7</a:t>
             </a:r>
           </a:p>
         </p:txBody>
@@ -14060,6 +14270,76 @@
       <p:sp>
         <p:nvSpPr>
           <p:cNvPr id="31" name="TextBox 30"/>
+          <p:cNvSpPr txBox="1"/>
+          <p:nvPr/>
+        </p:nvSpPr>
+        <p:spPr>
+          <a:xfrm>
+            <a:off x="8046720" y="5532120"/>
+            <a:ext cx="3017520" cy="274320"/>
+          </a:xfrm>
+          <a:prstGeom prst="rect">
+            <a:avLst/>
+          </a:prstGeom>
+          <a:noFill/>
+        </p:spPr>
+        <p:txBody>
+          <a:bodyPr wrap="square" lIns="0" rIns="0" tIns="0" bIns="0">
+            <a:spAutoFit/>
+          </a:bodyPr>
+          <a:lstStyle/>
+          <a:p>
+            <a:pPr algn="l"/>
+            <a:r>
+              <a:rPr sz="950" b="1" i="0">
+                <a:solidFill>
+                  <a:srgbClr val="F47321"/>
+                </a:solidFill>
+                <a:latin typeface="Arial"/>
+              </a:rPr>
+              <a:t>FLAGS  CLV+3</a:t>
+            </a:r>
+          </a:p>
+        </p:txBody>
+      </p:sp>
+      <p:sp>
+        <p:nvSpPr>
+          <p:cNvPr id="32" name="TextBox 31"/>
+          <p:cNvSpPr txBox="1"/>
+          <p:nvPr/>
+        </p:nvSpPr>
+        <p:spPr>
+          <a:xfrm>
+            <a:off x="822960" y="6053328"/>
+            <a:ext cx="10515600" cy="228600"/>
+          </a:xfrm>
+          <a:prstGeom prst="rect">
+            <a:avLst/>
+          </a:prstGeom>
+          <a:noFill/>
+        </p:spPr>
+        <p:txBody>
+          <a:bodyPr wrap="square" lIns="0" rIns="0" tIns="0" bIns="0">
+            <a:spAutoFit/>
+          </a:bodyPr>
+          <a:lstStyle/>
+          <a:p>
+            <a:pPr algn="l"/>
+            <a:r>
+              <a:rPr sz="900" b="0" i="0">
+                <a:solidFill>
+                  <a:srgbClr val="5C6B7E"/>
+                </a:solidFill>
+                <a:latin typeface="Arial"/>
+              </a:rPr>
+              <a:t>Line ledger: first-seen –10 (Jul 14) → now –7 · opened –10 · CLV +3 · market ML 70% NDSU</a:t>
+            </a:r>
+          </a:p>
+        </p:txBody>
+      </p:sp>
+      <p:sp>
+        <p:nvSpPr>
+          <p:cNvPr id="33" name="TextBox 32"/>
           <p:cNvSpPr txBox="1"/>
           <p:nvPr/>
         </p:nvSpPr>
@@ -16201,6 +16481,76 @@
       <p:sp>
         <p:nvSpPr>
           <p:cNvPr id="31" name="TextBox 30"/>
+          <p:cNvSpPr txBox="1"/>
+          <p:nvPr/>
+        </p:nvSpPr>
+        <p:spPr>
+          <a:xfrm>
+            <a:off x="8046720" y="5532120"/>
+            <a:ext cx="3017520" cy="274320"/>
+          </a:xfrm>
+          <a:prstGeom prst="rect">
+            <a:avLst/>
+          </a:prstGeom>
+          <a:noFill/>
+        </p:spPr>
+        <p:txBody>
+          <a:bodyPr wrap="square" lIns="0" rIns="0" tIns="0" bIns="0">
+            <a:spAutoFit/>
+          </a:bodyPr>
+          <a:lstStyle/>
+          <a:p>
+            <a:pPr algn="l"/>
+            <a:r>
+              <a:rPr sz="950" b="1" i="0">
+                <a:solidFill>
+                  <a:srgbClr val="F47321"/>
+                </a:solidFill>
+                <a:latin typeface="Arial"/>
+              </a:rPr>
+              <a:t>FLAGS  CLV-2.5</a:t>
+            </a:r>
+          </a:p>
+        </p:txBody>
+      </p:sp>
+      <p:sp>
+        <p:nvSpPr>
+          <p:cNvPr id="32" name="TextBox 31"/>
+          <p:cNvSpPr txBox="1"/>
+          <p:nvPr/>
+        </p:nvSpPr>
+        <p:spPr>
+          <a:xfrm>
+            <a:off x="822960" y="6053328"/>
+            <a:ext cx="10515600" cy="228600"/>
+          </a:xfrm>
+          <a:prstGeom prst="rect">
+            <a:avLst/>
+          </a:prstGeom>
+          <a:noFill/>
+        </p:spPr>
+        <p:txBody>
+          <a:bodyPr wrap="square" lIns="0" rIns="0" tIns="0" bIns="0">
+            <a:spAutoFit/>
+          </a:bodyPr>
+          <a:lstStyle/>
+          <a:p>
+            <a:pPr algn="l"/>
+            <a:r>
+              <a:rPr sz="900" b="0" i="0">
+                <a:solidFill>
+                  <a:srgbClr val="5C6B7E"/>
+                </a:solidFill>
+                <a:latin typeface="Arial"/>
+              </a:rPr>
+              <a:t>Line ledger: first-seen –3 (Aug 18) → now –5.5 · opened –3 · CLV -2.5 · market ML 66% STAN</a:t>
+            </a:r>
+          </a:p>
+        </p:txBody>
+      </p:sp>
+      <p:sp>
+        <p:nvSpPr>
+          <p:cNvPr id="33" name="TextBox 32"/>
           <p:cNvSpPr txBox="1"/>
           <p:nvPr/>
         </p:nvSpPr>

</xml_diff>

<commit_message>
Deck: book-style machine line, fair no-vig odds, projected score; D sidecar hook
THE NUMBER now shows the model line at a half-point, fair moneylines both
sides from model_p_home, projected score = model margin over the market
total (labelled: no totals model), market spreads + MLs per book. Player
panels render cards/week1_flags.json when present (qualitative overlay,
displayed not priced). Slides v8 imported into the existing shared file
(stable URL for Corey).

Co-Authored-By: Claude Fable 5 <noreply@anthropic.com>
</commit_message>
<xml_diff>
--- a/decks/2026_Week0_Episode1.pptx
+++ b/decks/2026_Week0_Episode1.pptx
@@ -3777,7 +3777,7 @@
                 </a:solidFill>
                 <a:latin typeface="Arial"/>
               </a:rPr>
-              <a:t>UVA –6.7</a:t>
+              <a:t>UVA –6.5</a:t>
             </a:r>
           </a:p>
         </p:txBody>
@@ -4097,7 +4097,7 @@
                 </a:solidFill>
                 <a:latin typeface="Arial"/>
               </a:rPr>
-              <a:t>NDSU –2.7</a:t>
+              <a:t>NDSU –2.5</a:t>
             </a:r>
           </a:p>
         </p:txBody>
@@ -4417,7 +4417,7 @@
                 </a:solidFill>
                 <a:latin typeface="Arial"/>
               </a:rPr>
-              <a:t>Stanford –1.6</a:t>
+              <a:t>Stanford –1.5</a:t>
             </a:r>
           </a:p>
         </p:txBody>
@@ -4737,7 +4737,7 @@
                 </a:solidFill>
                 <a:latin typeface="Arial"/>
               </a:rPr>
-              <a:t>UNLV –6.2</a:t>
+              <a:t>UNLV –6</a:t>
             </a:r>
           </a:p>
         </p:txBody>
@@ -5429,8 +5429,8 @@
         </p:nvSpPr>
         <p:spPr>
           <a:xfrm>
-            <a:off x="7772400" y="1600200"/>
-            <a:ext cx="3566160" cy="4206240"/>
+            <a:off x="7772400" y="1554480"/>
+            <a:ext cx="3566160" cy="4370832"/>
           </a:xfrm>
           <a:prstGeom prst="roundRect">
             <a:avLst/>
@@ -5473,7 +5473,287 @@
         </p:nvSpPr>
         <p:spPr>
           <a:xfrm>
-            <a:off x="8046720" y="1828800"/>
+            <a:off x="8046720" y="1737360"/>
+            <a:ext cx="3017520" cy="274320"/>
+          </a:xfrm>
+          <a:prstGeom prst="rect">
+            <a:avLst/>
+          </a:prstGeom>
+          <a:noFill/>
+        </p:spPr>
+        <p:txBody>
+          <a:bodyPr wrap="square" lIns="0" rIns="0" tIns="0" bIns="0">
+            <a:spAutoFit/>
+          </a:bodyPr>
+          <a:lstStyle/>
+          <a:p>
+            <a:pPr algn="l"/>
+            <a:r>
+              <a:rPr sz="1200" b="1" i="0">
+                <a:solidFill>
+                  <a:srgbClr val="F47321"/>
+                </a:solidFill>
+                <a:latin typeface="Arial"/>
+              </a:rPr>
+              <a:t>THE NUMBER</a:t>
+            </a:r>
+          </a:p>
+        </p:txBody>
+      </p:sp>
+      <p:sp>
+        <p:nvSpPr>
+          <p:cNvPr id="20" name="TextBox 19"/>
+          <p:cNvSpPr txBox="1"/>
+          <p:nvPr/>
+        </p:nvSpPr>
+        <p:spPr>
+          <a:xfrm>
+            <a:off x="8046720" y="2011680"/>
+            <a:ext cx="3017520" cy="457200"/>
+          </a:xfrm>
+          <a:prstGeom prst="rect">
+            <a:avLst/>
+          </a:prstGeom>
+          <a:noFill/>
+        </p:spPr>
+        <p:txBody>
+          <a:bodyPr wrap="square" lIns="0" rIns="0" tIns="0" bIns="0">
+            <a:spAutoFit/>
+          </a:bodyPr>
+          <a:lstStyle/>
+          <a:p>
+            <a:pPr algn="l"/>
+            <a:r>
+              <a:rPr sz="2600" b="1" i="0">
+                <a:solidFill>
+                  <a:srgbClr val="FFFFFF"/>
+                </a:solidFill>
+                <a:latin typeface="Arial"/>
+              </a:rPr>
+              <a:t>UNLV –6</a:t>
+            </a:r>
+          </a:p>
+        </p:txBody>
+      </p:sp>
+      <p:sp>
+        <p:nvSpPr>
+          <p:cNvPr id="21" name="TextBox 20"/>
+          <p:cNvSpPr txBox="1"/>
+          <p:nvPr/>
+        </p:nvSpPr>
+        <p:spPr>
+          <a:xfrm>
+            <a:off x="8046720" y="2450592"/>
+            <a:ext cx="3017520" cy="274320"/>
+          </a:xfrm>
+          <a:prstGeom prst="rect">
+            <a:avLst/>
+          </a:prstGeom>
+          <a:noFill/>
+        </p:spPr>
+        <p:txBody>
+          <a:bodyPr wrap="square" lIns="0" rIns="0" tIns="0" bIns="0">
+            <a:spAutoFit/>
+          </a:bodyPr>
+          <a:lstStyle/>
+          <a:p>
+            <a:pPr algn="l"/>
+            <a:r>
+              <a:rPr sz="1150" b="1" i="0">
+                <a:solidFill>
+                  <a:srgbClr val="FFFFFF"/>
+                </a:solidFill>
+                <a:latin typeface="Arial"/>
+              </a:rPr>
+              <a:t>UNLV –179 · MEM +179</a:t>
+            </a:r>
+          </a:p>
+        </p:txBody>
+      </p:sp>
+      <p:sp>
+        <p:nvSpPr>
+          <p:cNvPr id="22" name="TextBox 21"/>
+          <p:cNvSpPr txBox="1"/>
+          <p:nvPr/>
+        </p:nvSpPr>
+        <p:spPr>
+          <a:xfrm>
+            <a:off x="8046720" y="2688336"/>
+            <a:ext cx="3017520" cy="256032"/>
+          </a:xfrm>
+          <a:prstGeom prst="rect">
+            <a:avLst/>
+          </a:prstGeom>
+          <a:noFill/>
+        </p:spPr>
+        <p:txBody>
+          <a:bodyPr wrap="square" lIns="0" rIns="0" tIns="0" bIns="0">
+            <a:spAutoFit/>
+          </a:bodyPr>
+          <a:lstStyle/>
+          <a:p>
+            <a:pPr algn="l"/>
+            <a:r>
+              <a:rPr sz="850" b="0" i="0">
+                <a:solidFill>
+                  <a:srgbClr val="CADCFC"/>
+                </a:solidFill>
+                <a:latin typeface="Arial"/>
+              </a:rPr>
+              <a:t>machine line · fair odds, no vig · raw margin UNLV +6.2</a:t>
+            </a:r>
+          </a:p>
+        </p:txBody>
+      </p:sp>
+      <p:sp>
+        <p:nvSpPr>
+          <p:cNvPr id="23" name="TextBox 22"/>
+          <p:cNvSpPr txBox="1"/>
+          <p:nvPr/>
+        </p:nvSpPr>
+        <p:spPr>
+          <a:xfrm>
+            <a:off x="8046720" y="3017520"/>
+            <a:ext cx="3017520" cy="365760"/>
+          </a:xfrm>
+          <a:prstGeom prst="rect">
+            <a:avLst/>
+          </a:prstGeom>
+          <a:noFill/>
+        </p:spPr>
+        <p:txBody>
+          <a:bodyPr wrap="square" lIns="0" rIns="0" tIns="0" bIns="0">
+            <a:spAutoFit/>
+          </a:bodyPr>
+          <a:lstStyle/>
+          <a:p>
+            <a:pPr algn="l"/>
+            <a:r>
+              <a:rPr sz="1700" b="1" i="0">
+                <a:solidFill>
+                  <a:srgbClr val="FFFFFF"/>
+                </a:solidFill>
+                <a:latin typeface="Arial"/>
+              </a:rPr>
+              <a:t>UNLV 32 – MEM 26</a:t>
+            </a:r>
+          </a:p>
+        </p:txBody>
+      </p:sp>
+      <p:sp>
+        <p:nvSpPr>
+          <p:cNvPr id="24" name="TextBox 23"/>
+          <p:cNvSpPr txBox="1"/>
+          <p:nvPr/>
+        </p:nvSpPr>
+        <p:spPr>
+          <a:xfrm>
+            <a:off x="8046720" y="3328416"/>
+            <a:ext cx="3017520" cy="256032"/>
+          </a:xfrm>
+          <a:prstGeom prst="rect">
+            <a:avLst/>
+          </a:prstGeom>
+          <a:noFill/>
+        </p:spPr>
+        <p:txBody>
+          <a:bodyPr wrap="square" lIns="0" rIns="0" tIns="0" bIns="0">
+            <a:spAutoFit/>
+          </a:bodyPr>
+          <a:lstStyle/>
+          <a:p>
+            <a:pPr algn="l"/>
+            <a:r>
+              <a:rPr sz="850" b="0" i="0">
+                <a:solidFill>
+                  <a:srgbClr val="CADCFC"/>
+                </a:solidFill>
+                <a:latin typeface="Arial"/>
+              </a:rPr>
+              <a:t>projected score · machine margin on the 57.5 market total</a:t>
+            </a:r>
+          </a:p>
+        </p:txBody>
+      </p:sp>
+      <p:sp>
+        <p:nvSpPr>
+          <p:cNvPr id="25" name="TextBox 24"/>
+          <p:cNvSpPr txBox="1"/>
+          <p:nvPr/>
+        </p:nvSpPr>
+        <p:spPr>
+          <a:xfrm>
+            <a:off x="8046720" y="3639312"/>
+            <a:ext cx="3017520" cy="365760"/>
+          </a:xfrm>
+          <a:prstGeom prst="rect">
+            <a:avLst/>
+          </a:prstGeom>
+          <a:noFill/>
+        </p:spPr>
+        <p:txBody>
+          <a:bodyPr wrap="square" lIns="0" rIns="0" tIns="0" bIns="0">
+            <a:spAutoFit/>
+          </a:bodyPr>
+          <a:lstStyle/>
+          <a:p>
+            <a:pPr algn="l"/>
+            <a:r>
+              <a:rPr sz="1700" b="1" i="0">
+                <a:solidFill>
+                  <a:srgbClr val="FFFFFF"/>
+                </a:solidFill>
+                <a:latin typeface="Arial"/>
+              </a:rPr>
+              <a:t>–5.5 / –5.5</a:t>
+            </a:r>
+          </a:p>
+        </p:txBody>
+      </p:sp>
+      <p:sp>
+        <p:nvSpPr>
+          <p:cNvPr id="26" name="TextBox 25"/>
+          <p:cNvSpPr txBox="1"/>
+          <p:nvPr/>
+        </p:nvSpPr>
+        <p:spPr>
+          <a:xfrm>
+            <a:off x="8046720" y="3950208"/>
+            <a:ext cx="3017520" cy="365760"/>
+          </a:xfrm>
+          <a:prstGeom prst="rect">
+            <a:avLst/>
+          </a:prstGeom>
+          <a:noFill/>
+        </p:spPr>
+        <p:txBody>
+          <a:bodyPr wrap="square" lIns="0" rIns="0" tIns="0" bIns="0">
+            <a:spAutoFit/>
+          </a:bodyPr>
+          <a:lstStyle/>
+          <a:p>
+            <a:pPr algn="l"/>
+            <a:r>
+              <a:rPr sz="850" b="0" i="0">
+                <a:solidFill>
+                  <a:srgbClr val="CADCFC"/>
+                </a:solidFill>
+                <a:latin typeface="Arial"/>
+              </a:rPr>
+              <a:t>market (DK / Bovada) · DK UNLV -225 / MEM +185 · Bov UNLV -170 / MEM +145</a:t>
+            </a:r>
+          </a:p>
+        </p:txBody>
+      </p:sp>
+      <p:sp>
+        <p:nvSpPr>
+          <p:cNvPr id="27" name="TextBox 26"/>
+          <p:cNvSpPr txBox="1"/>
+          <p:nvPr/>
+        </p:nvSpPr>
+        <p:spPr>
+          <a:xfrm>
+            <a:off x="8046720" y="4315968"/>
             <a:ext cx="3017520" cy="320040"/>
           </a:xfrm>
           <a:prstGeom prst="rect">
@@ -5489,222 +5769,47 @@
           <a:p>
             <a:pPr algn="l"/>
             <a:r>
-              <a:rPr sz="1200" b="1" i="0">
+              <a:rPr sz="1150" b="1" i="0">
                 <a:solidFill>
                   <a:srgbClr val="F47321"/>
                 </a:solidFill>
                 <a:latin typeface="Arial"/>
               </a:rPr>
-              <a:t>THE NUMBER</a:t>
-            </a:r>
-          </a:p>
-        </p:txBody>
-      </p:sp>
-      <p:sp>
-        <p:nvSpPr>
-          <p:cNvPr id="20" name="TextBox 19"/>
-          <p:cNvSpPr txBox="1"/>
-          <p:nvPr/>
-        </p:nvSpPr>
-        <p:spPr>
-          <a:xfrm>
-            <a:off x="8046720" y="2194560"/>
-            <a:ext cx="3017520" cy="640080"/>
-          </a:xfrm>
-          <a:prstGeom prst="rect">
-            <a:avLst/>
-          </a:prstGeom>
-          <a:noFill/>
-        </p:spPr>
-        <p:txBody>
-          <a:bodyPr wrap="square" lIns="0" rIns="0" tIns="0" bIns="0">
-            <a:spAutoFit/>
-          </a:bodyPr>
-          <a:lstStyle/>
-          <a:p>
-            <a:pPr algn="l"/>
-            <a:r>
-              <a:rPr sz="3000" b="1" i="0">
-                <a:solidFill>
-                  <a:srgbClr val="FFFFFF"/>
-                </a:solidFill>
-                <a:latin typeface="Arial"/>
-              </a:rPr>
-              <a:t>UNLV –6.2</a:t>
-            </a:r>
-          </a:p>
-        </p:txBody>
-      </p:sp>
-      <p:sp>
-        <p:nvSpPr>
-          <p:cNvPr id="21" name="TextBox 20"/>
-          <p:cNvSpPr txBox="1"/>
-          <p:nvPr/>
-        </p:nvSpPr>
-        <p:spPr>
-          <a:xfrm>
-            <a:off x="8046720" y="2788920"/>
-            <a:ext cx="3017520" cy="274320"/>
-          </a:xfrm>
-          <a:prstGeom prst="rect">
-            <a:avLst/>
-          </a:prstGeom>
-          <a:noFill/>
-        </p:spPr>
-        <p:txBody>
-          <a:bodyPr wrap="square" lIns="0" rIns="0" tIns="0" bIns="0">
-            <a:spAutoFit/>
-          </a:bodyPr>
-          <a:lstStyle/>
-          <a:p>
-            <a:pPr algn="l"/>
-            <a:r>
-              <a:rPr sz="1000" b="0" i="0">
+              <a:t>market came to us: –3 → –5.5</a:t>
+            </a:r>
+          </a:p>
+        </p:txBody>
+      </p:sp>
+      <p:sp>
+        <p:nvSpPr>
+          <p:cNvPr id="28" name="TextBox 27"/>
+          <p:cNvSpPr txBox="1"/>
+          <p:nvPr/>
+        </p:nvSpPr>
+        <p:spPr>
+          <a:xfrm>
+            <a:off x="8046720" y="4590288"/>
+            <a:ext cx="3017520" cy="228600"/>
+          </a:xfrm>
+          <a:prstGeom prst="rect">
+            <a:avLst/>
+          </a:prstGeom>
+          <a:noFill/>
+        </p:spPr>
+        <p:txBody>
+          <a:bodyPr wrap="square" lIns="0" rIns="0" tIns="0" bIns="0">
+            <a:spAutoFit/>
+          </a:bodyPr>
+          <a:lstStyle/>
+          <a:p>
+            <a:pPr algn="l"/>
+            <a:r>
+              <a:rPr sz="850" b="0" i="0">
                 <a:solidFill>
                   <a:srgbClr val="CADCFC"/>
                 </a:solidFill>
                 <a:latin typeface="Arial"/>
               </a:rPr>
-              <a:t>machine</a:t>
-            </a:r>
-          </a:p>
-        </p:txBody>
-      </p:sp>
-      <p:sp>
-        <p:nvSpPr>
-          <p:cNvPr id="22" name="TextBox 21"/>
-          <p:cNvSpPr txBox="1"/>
-          <p:nvPr/>
-        </p:nvSpPr>
-        <p:spPr>
-          <a:xfrm>
-            <a:off x="8046720" y="3154680"/>
-            <a:ext cx="3017520" cy="502920"/>
-          </a:xfrm>
-          <a:prstGeom prst="rect">
-            <a:avLst/>
-          </a:prstGeom>
-          <a:noFill/>
-        </p:spPr>
-        <p:txBody>
-          <a:bodyPr wrap="square" lIns="0" rIns="0" tIns="0" bIns="0">
-            <a:spAutoFit/>
-          </a:bodyPr>
-          <a:lstStyle/>
-          <a:p>
-            <a:pPr algn="l"/>
-            <a:r>
-              <a:rPr sz="2200" b="1" i="0">
-                <a:solidFill>
-                  <a:srgbClr val="FFFFFF"/>
-                </a:solidFill>
-                <a:latin typeface="Arial"/>
-              </a:rPr>
-              <a:t>–5.5 / –5.5</a:t>
-            </a:r>
-          </a:p>
-        </p:txBody>
-      </p:sp>
-      <p:sp>
-        <p:nvSpPr>
-          <p:cNvPr id="23" name="TextBox 22"/>
-          <p:cNvSpPr txBox="1"/>
-          <p:nvPr/>
-        </p:nvSpPr>
-        <p:spPr>
-          <a:xfrm>
-            <a:off x="8046720" y="3611880"/>
-            <a:ext cx="3017520" cy="274320"/>
-          </a:xfrm>
-          <a:prstGeom prst="rect">
-            <a:avLst/>
-          </a:prstGeom>
-          <a:noFill/>
-        </p:spPr>
-        <p:txBody>
-          <a:bodyPr wrap="square" lIns="0" rIns="0" tIns="0" bIns="0">
-            <a:spAutoFit/>
-          </a:bodyPr>
-          <a:lstStyle/>
-          <a:p>
-            <a:pPr algn="l"/>
-            <a:r>
-              <a:rPr sz="1000" b="0" i="0">
-                <a:solidFill>
-                  <a:srgbClr val="CADCFC"/>
-                </a:solidFill>
-                <a:latin typeface="Arial"/>
-              </a:rPr>
-              <a:t>market (DK / Bovada)</a:t>
-            </a:r>
-          </a:p>
-        </p:txBody>
-      </p:sp>
-      <p:sp>
-        <p:nvSpPr>
-          <p:cNvPr id="24" name="TextBox 23"/>
-          <p:cNvSpPr txBox="1"/>
-          <p:nvPr/>
-        </p:nvSpPr>
-        <p:spPr>
-          <a:xfrm>
-            <a:off x="8046720" y="3977639"/>
-            <a:ext cx="3017520" cy="411480"/>
-          </a:xfrm>
-          <a:prstGeom prst="rect">
-            <a:avLst/>
-          </a:prstGeom>
-          <a:noFill/>
-        </p:spPr>
-        <p:txBody>
-          <a:bodyPr wrap="square" lIns="0" rIns="0" tIns="0" bIns="0">
-            <a:spAutoFit/>
-          </a:bodyPr>
-          <a:lstStyle/>
-          <a:p>
-            <a:pPr algn="l"/>
-            <a:r>
-              <a:rPr sz="1250" b="1" i="0">
-                <a:solidFill>
-                  <a:srgbClr val="F47321"/>
-                </a:solidFill>
-                <a:latin typeface="Arial"/>
-              </a:rPr>
-              <a:t>market came to us: –3 → –5.5</a:t>
-            </a:r>
-          </a:p>
-        </p:txBody>
-      </p:sp>
-      <p:sp>
-        <p:nvSpPr>
-          <p:cNvPr id="25" name="TextBox 24"/>
-          <p:cNvSpPr txBox="1"/>
-          <p:nvPr/>
-        </p:nvSpPr>
-        <p:spPr>
-          <a:xfrm>
-            <a:off x="8046720" y="4370832"/>
-            <a:ext cx="3017520" cy="274320"/>
-          </a:xfrm>
-          <a:prstGeom prst="rect">
-            <a:avLst/>
-          </a:prstGeom>
-          <a:noFill/>
-        </p:spPr>
-        <p:txBody>
-          <a:bodyPr wrap="square" lIns="0" rIns="0" tIns="0" bIns="0">
-            <a:spAutoFit/>
-          </a:bodyPr>
-          <a:lstStyle/>
-          <a:p>
-            <a:pPr algn="l"/>
-            <a:r>
-              <a:rPr sz="1000" b="0" i="0">
-                <a:solidFill>
-                  <a:srgbClr val="CADCFC"/>
-                </a:solidFill>
-                <a:latin typeface="Arial"/>
-              </a:rPr>
               <a:t>the gap</a:t>
             </a:r>
           </a:p>
@@ -5712,14 +5817,14 @@
       </p:sp>
       <p:sp>
         <p:nvSpPr>
-          <p:cNvPr id="26" name="Rounded Rectangle 25"/>
+          <p:cNvPr id="29" name="Rounded Rectangle 28"/>
           <p:cNvSpPr/>
           <p:nvPr/>
         </p:nvSpPr>
         <p:spPr>
           <a:xfrm>
-            <a:off x="8046720" y="4892040"/>
-            <a:ext cx="3017520" cy="384048"/>
+            <a:off x="8046720" y="4882896"/>
+            <a:ext cx="3017520" cy="365760"/>
           </a:xfrm>
           <a:prstGeom prst="roundRect">
             <a:avLst/>
@@ -5756,14 +5861,14 @@
       </p:sp>
       <p:sp>
         <p:nvSpPr>
-          <p:cNvPr id="27" name="Rounded Rectangle 26"/>
+          <p:cNvPr id="30" name="Rounded Rectangle 29"/>
           <p:cNvSpPr/>
           <p:nvPr/>
         </p:nvSpPr>
         <p:spPr>
           <a:xfrm>
-            <a:off x="8046720" y="4892040"/>
-            <a:ext cx="1931212" cy="384048"/>
+            <a:off x="8046720" y="4882896"/>
+            <a:ext cx="1931212" cy="365760"/>
           </a:xfrm>
           <a:prstGeom prst="roundRect">
             <a:avLst/>
@@ -5800,13 +5905,13 @@
       </p:sp>
       <p:sp>
         <p:nvSpPr>
-          <p:cNvPr id="28" name="TextBox 27"/>
-          <p:cNvSpPr txBox="1"/>
-          <p:nvPr/>
-        </p:nvSpPr>
-        <p:spPr>
-          <a:xfrm>
-            <a:off x="8119872" y="4983479"/>
+          <p:cNvPr id="31" name="TextBox 30"/>
+          <p:cNvSpPr txBox="1"/>
+          <p:nvPr/>
+        </p:nvSpPr>
+        <p:spPr>
+          <a:xfrm>
+            <a:off x="8119872" y="4965192"/>
             <a:ext cx="2194560" cy="228600"/>
           </a:xfrm>
           <a:prstGeom prst="rect">
@@ -5835,13 +5940,13 @@
       </p:sp>
       <p:sp>
         <p:nvSpPr>
-          <p:cNvPr id="29" name="TextBox 28"/>
-          <p:cNvSpPr txBox="1"/>
-          <p:nvPr/>
-        </p:nvSpPr>
-        <p:spPr>
-          <a:xfrm>
-            <a:off x="8796528" y="4983479"/>
+          <p:cNvPr id="32" name="TextBox 31"/>
+          <p:cNvSpPr txBox="1"/>
+          <p:nvPr/>
+        </p:nvSpPr>
+        <p:spPr>
+          <a:xfrm>
+            <a:off x="8796528" y="4965192"/>
             <a:ext cx="2194560" cy="228600"/>
           </a:xfrm>
           <a:prstGeom prst="rect">
@@ -5870,13 +5975,48 @@
       </p:sp>
       <p:sp>
         <p:nvSpPr>
-          <p:cNvPr id="30" name="TextBox 29"/>
-          <p:cNvSpPr txBox="1"/>
-          <p:nvPr/>
-        </p:nvSpPr>
-        <p:spPr>
-          <a:xfrm>
-            <a:off x="8046720" y="5349240"/>
+          <p:cNvPr id="33" name="TextBox 32"/>
+          <p:cNvSpPr txBox="1"/>
+          <p:nvPr/>
+        </p:nvSpPr>
+        <p:spPr>
+          <a:xfrm>
+            <a:off x="8046720" y="5303520"/>
+            <a:ext cx="3017520" cy="228600"/>
+          </a:xfrm>
+          <a:prstGeom prst="rect">
+            <a:avLst/>
+          </a:prstGeom>
+          <a:noFill/>
+        </p:spPr>
+        <p:txBody>
+          <a:bodyPr wrap="square" lIns="0" rIns="0" tIns="0" bIns="0">
+            <a:spAutoFit/>
+          </a:bodyPr>
+          <a:lstStyle/>
+          <a:p>
+            <a:pPr algn="l"/>
+            <a:r>
+              <a:rPr sz="850" b="0" i="0">
+                <a:solidFill>
+                  <a:srgbClr val="CADCFC"/>
+                </a:solidFill>
+                <a:latin typeface="Arial"/>
+              </a:rPr>
+              <a:t>win probability (machine)</a:t>
+            </a:r>
+          </a:p>
+        </p:txBody>
+      </p:sp>
+      <p:sp>
+        <p:nvSpPr>
+          <p:cNvPr id="34" name="TextBox 33"/>
+          <p:cNvSpPr txBox="1"/>
+          <p:nvPr/>
+        </p:nvSpPr>
+        <p:spPr>
+          <a:xfrm>
+            <a:off x="8046720" y="5550408"/>
             <a:ext cx="3017520" cy="274320"/>
           </a:xfrm>
           <a:prstGeom prst="rect">
@@ -5892,41 +6032,6 @@
           <a:p>
             <a:pPr algn="l"/>
             <a:r>
-              <a:rPr sz="950" b="0" i="0">
-                <a:solidFill>
-                  <a:srgbClr val="CADCFC"/>
-                </a:solidFill>
-                <a:latin typeface="Arial"/>
-              </a:rPr>
-              <a:t>win probability (machine)</a:t>
-            </a:r>
-          </a:p>
-        </p:txBody>
-      </p:sp>
-      <p:sp>
-        <p:nvSpPr>
-          <p:cNvPr id="31" name="TextBox 30"/>
-          <p:cNvSpPr txBox="1"/>
-          <p:nvPr/>
-        </p:nvSpPr>
-        <p:spPr>
-          <a:xfrm>
-            <a:off x="8046720" y="5532120"/>
-            <a:ext cx="3017520" cy="274320"/>
-          </a:xfrm>
-          <a:prstGeom prst="rect">
-            <a:avLst/>
-          </a:prstGeom>
-          <a:noFill/>
-        </p:spPr>
-        <p:txBody>
-          <a:bodyPr wrap="square" lIns="0" rIns="0" tIns="0" bIns="0">
-            <a:spAutoFit/>
-          </a:bodyPr>
-          <a:lstStyle/>
-          <a:p>
-            <a:pPr algn="l"/>
-            <a:r>
               <a:rPr sz="950" b="1" i="0">
                 <a:solidFill>
                   <a:srgbClr val="F47321"/>
@@ -5940,7 +6045,7 @@
       </p:sp>
       <p:sp>
         <p:nvSpPr>
-          <p:cNvPr id="32" name="TextBox 31"/>
+          <p:cNvPr id="35" name="TextBox 34"/>
           <p:cNvSpPr txBox="1"/>
           <p:nvPr/>
         </p:nvSpPr>
@@ -5975,7 +6080,7 @@
       </p:sp>
       <p:sp>
         <p:nvSpPr>
-          <p:cNvPr id="33" name="TextBox 32"/>
+          <p:cNvPr id="36" name="TextBox 35"/>
           <p:cNvSpPr txBox="1"/>
           <p:nvPr/>
         </p:nvSpPr>
@@ -7719,7 +7824,7 @@
                 </a:solidFill>
                 <a:latin typeface="Arial"/>
               </a:rPr>
-              <a:t>UVA –6.7   ·   –5.5 / –5.5</a:t>
+              <a:t>UVA –6.5   ·   –5.5 / –5.5</a:t>
             </a:r>
           </a:p>
         </p:txBody>
@@ -8039,7 +8144,7 @@
                 </a:solidFill>
                 <a:latin typeface="Arial"/>
               </a:rPr>
-              <a:t>NDSU –2.7   ·   –7 / –7</a:t>
+              <a:t>NDSU –2.5   ·   –7 / –7</a:t>
             </a:r>
           </a:p>
         </p:txBody>
@@ -8359,7 +8464,7 @@
                 </a:solidFill>
                 <a:latin typeface="Arial"/>
               </a:rPr>
-              <a:t>Stanford –1.6   ·   –5.5 / –5.5</a:t>
+              <a:t>Stanford –1.5   ·   –5.5 / –5.5</a:t>
             </a:r>
           </a:p>
         </p:txBody>
@@ -8679,7 +8784,7 @@
                 </a:solidFill>
                 <a:latin typeface="Arial"/>
               </a:rPr>
-              <a:t>UNLV –6.2   ·   –5.5 / –5.5</a:t>
+              <a:t>UNLV –6   ·   –5.5 / –5.5</a:t>
             </a:r>
           </a:p>
         </p:txBody>
@@ -9371,8 +9476,8 @@
         </p:nvSpPr>
         <p:spPr>
           <a:xfrm>
-            <a:off x="7772400" y="1600200"/>
-            <a:ext cx="3566160" cy="4206240"/>
+            <a:off x="7772400" y="1554480"/>
+            <a:ext cx="3566160" cy="4370832"/>
           </a:xfrm>
           <a:prstGeom prst="roundRect">
             <a:avLst/>
@@ -9415,7 +9520,287 @@
         </p:nvSpPr>
         <p:spPr>
           <a:xfrm>
-            <a:off x="8046720" y="1828800"/>
+            <a:off x="8046720" y="1737360"/>
+            <a:ext cx="3017520" cy="274320"/>
+          </a:xfrm>
+          <a:prstGeom prst="rect">
+            <a:avLst/>
+          </a:prstGeom>
+          <a:noFill/>
+        </p:spPr>
+        <p:txBody>
+          <a:bodyPr wrap="square" lIns="0" rIns="0" tIns="0" bIns="0">
+            <a:spAutoFit/>
+          </a:bodyPr>
+          <a:lstStyle/>
+          <a:p>
+            <a:pPr algn="l"/>
+            <a:r>
+              <a:rPr sz="1200" b="1" i="0">
+                <a:solidFill>
+                  <a:srgbClr val="F47321"/>
+                </a:solidFill>
+                <a:latin typeface="Arial"/>
+              </a:rPr>
+              <a:t>THE NUMBER</a:t>
+            </a:r>
+          </a:p>
+        </p:txBody>
+      </p:sp>
+      <p:sp>
+        <p:nvSpPr>
+          <p:cNvPr id="20" name="TextBox 19"/>
+          <p:cNvSpPr txBox="1"/>
+          <p:nvPr/>
+        </p:nvSpPr>
+        <p:spPr>
+          <a:xfrm>
+            <a:off x="8046720" y="2011680"/>
+            <a:ext cx="3017520" cy="457200"/>
+          </a:xfrm>
+          <a:prstGeom prst="rect">
+            <a:avLst/>
+          </a:prstGeom>
+          <a:noFill/>
+        </p:spPr>
+        <p:txBody>
+          <a:bodyPr wrap="square" lIns="0" rIns="0" tIns="0" bIns="0">
+            <a:spAutoFit/>
+          </a:bodyPr>
+          <a:lstStyle/>
+          <a:p>
+            <a:pPr algn="l"/>
+            <a:r>
+              <a:rPr sz="2600" b="1" i="0">
+                <a:solidFill>
+                  <a:srgbClr val="FFFFFF"/>
+                </a:solidFill>
+                <a:latin typeface="Arial"/>
+              </a:rPr>
+              <a:t>TCU –1.5</a:t>
+            </a:r>
+          </a:p>
+        </p:txBody>
+      </p:sp>
+      <p:sp>
+        <p:nvSpPr>
+          <p:cNvPr id="21" name="TextBox 20"/>
+          <p:cNvSpPr txBox="1"/>
+          <p:nvPr/>
+        </p:nvSpPr>
+        <p:spPr>
+          <a:xfrm>
+            <a:off x="8046720" y="2450592"/>
+            <a:ext cx="3017520" cy="274320"/>
+          </a:xfrm>
+          <a:prstGeom prst="rect">
+            <a:avLst/>
+          </a:prstGeom>
+          <a:noFill/>
+        </p:spPr>
+        <p:txBody>
+          <a:bodyPr wrap="square" lIns="0" rIns="0" tIns="0" bIns="0">
+            <a:spAutoFit/>
+          </a:bodyPr>
+          <a:lstStyle/>
+          <a:p>
+            <a:pPr algn="l"/>
+            <a:r>
+              <a:rPr sz="1150" b="1" i="0">
+                <a:solidFill>
+                  <a:srgbClr val="FFFFFF"/>
+                </a:solidFill>
+                <a:latin typeface="Arial"/>
+              </a:rPr>
+              <a:t>TCU –118 · UNC +118</a:t>
+            </a:r>
+          </a:p>
+        </p:txBody>
+      </p:sp>
+      <p:sp>
+        <p:nvSpPr>
+          <p:cNvPr id="22" name="TextBox 21"/>
+          <p:cNvSpPr txBox="1"/>
+          <p:nvPr/>
+        </p:nvSpPr>
+        <p:spPr>
+          <a:xfrm>
+            <a:off x="8046720" y="2688336"/>
+            <a:ext cx="3017520" cy="256032"/>
+          </a:xfrm>
+          <a:prstGeom prst="rect">
+            <a:avLst/>
+          </a:prstGeom>
+          <a:noFill/>
+        </p:spPr>
+        <p:txBody>
+          <a:bodyPr wrap="square" lIns="0" rIns="0" tIns="0" bIns="0">
+            <a:spAutoFit/>
+          </a:bodyPr>
+          <a:lstStyle/>
+          <a:p>
+            <a:pPr algn="l"/>
+            <a:r>
+              <a:rPr sz="850" b="0" i="0">
+                <a:solidFill>
+                  <a:srgbClr val="CADCFC"/>
+                </a:solidFill>
+                <a:latin typeface="Arial"/>
+              </a:rPr>
+              <a:t>machine line · fair odds, no vig · raw margin TCU +1.5</a:t>
+            </a:r>
+          </a:p>
+        </p:txBody>
+      </p:sp>
+      <p:sp>
+        <p:nvSpPr>
+          <p:cNvPr id="23" name="TextBox 22"/>
+          <p:cNvSpPr txBox="1"/>
+          <p:nvPr/>
+        </p:nvSpPr>
+        <p:spPr>
+          <a:xfrm>
+            <a:off x="8046720" y="3017520"/>
+            <a:ext cx="3017520" cy="365760"/>
+          </a:xfrm>
+          <a:prstGeom prst="rect">
+            <a:avLst/>
+          </a:prstGeom>
+          <a:noFill/>
+        </p:spPr>
+        <p:txBody>
+          <a:bodyPr wrap="square" lIns="0" rIns="0" tIns="0" bIns="0">
+            <a:spAutoFit/>
+          </a:bodyPr>
+          <a:lstStyle/>
+          <a:p>
+            <a:pPr algn="l"/>
+            <a:r>
+              <a:rPr sz="1700" b="1" i="0">
+                <a:solidFill>
+                  <a:srgbClr val="FFFFFF"/>
+                </a:solidFill>
+                <a:latin typeface="Arial"/>
+              </a:rPr>
+              <a:t>TCU 24 – UNC 23</a:t>
+            </a:r>
+          </a:p>
+        </p:txBody>
+      </p:sp>
+      <p:sp>
+        <p:nvSpPr>
+          <p:cNvPr id="24" name="TextBox 23"/>
+          <p:cNvSpPr txBox="1"/>
+          <p:nvPr/>
+        </p:nvSpPr>
+        <p:spPr>
+          <a:xfrm>
+            <a:off x="8046720" y="3328416"/>
+            <a:ext cx="3017520" cy="256032"/>
+          </a:xfrm>
+          <a:prstGeom prst="rect">
+            <a:avLst/>
+          </a:prstGeom>
+          <a:noFill/>
+        </p:spPr>
+        <p:txBody>
+          <a:bodyPr wrap="square" lIns="0" rIns="0" tIns="0" bIns="0">
+            <a:spAutoFit/>
+          </a:bodyPr>
+          <a:lstStyle/>
+          <a:p>
+            <a:pPr algn="l"/>
+            <a:r>
+              <a:rPr sz="850" b="0" i="0">
+                <a:solidFill>
+                  <a:srgbClr val="CADCFC"/>
+                </a:solidFill>
+                <a:latin typeface="Arial"/>
+              </a:rPr>
+              <a:t>projected score · machine margin on the 47.5 market total</a:t>
+            </a:r>
+          </a:p>
+        </p:txBody>
+      </p:sp>
+      <p:sp>
+        <p:nvSpPr>
+          <p:cNvPr id="25" name="TextBox 24"/>
+          <p:cNvSpPr txBox="1"/>
+          <p:nvPr/>
+        </p:nvSpPr>
+        <p:spPr>
+          <a:xfrm>
+            <a:off x="8046720" y="3639312"/>
+            <a:ext cx="3017520" cy="365760"/>
+          </a:xfrm>
+          <a:prstGeom prst="rect">
+            <a:avLst/>
+          </a:prstGeom>
+          <a:noFill/>
+        </p:spPr>
+        <p:txBody>
+          <a:bodyPr wrap="square" lIns="0" rIns="0" tIns="0" bIns="0">
+            <a:spAutoFit/>
+          </a:bodyPr>
+          <a:lstStyle/>
+          <a:p>
+            <a:pPr algn="l"/>
+            <a:r>
+              <a:rPr sz="1700" b="1" i="0">
+                <a:solidFill>
+                  <a:srgbClr val="FFFFFF"/>
+                </a:solidFill>
+                <a:latin typeface="Arial"/>
+              </a:rPr>
+              <a:t>–7.5 / –8</a:t>
+            </a:r>
+          </a:p>
+        </p:txBody>
+      </p:sp>
+      <p:sp>
+        <p:nvSpPr>
+          <p:cNvPr id="26" name="TextBox 25"/>
+          <p:cNvSpPr txBox="1"/>
+          <p:nvPr/>
+        </p:nvSpPr>
+        <p:spPr>
+          <a:xfrm>
+            <a:off x="8046720" y="3950208"/>
+            <a:ext cx="3017520" cy="365760"/>
+          </a:xfrm>
+          <a:prstGeom prst="rect">
+            <a:avLst/>
+          </a:prstGeom>
+          <a:noFill/>
+        </p:spPr>
+        <p:txBody>
+          <a:bodyPr wrap="square" lIns="0" rIns="0" tIns="0" bIns="0">
+            <a:spAutoFit/>
+          </a:bodyPr>
+          <a:lstStyle/>
+          <a:p>
+            <a:pPr algn="l"/>
+            <a:r>
+              <a:rPr sz="850" b="0" i="0">
+                <a:solidFill>
+                  <a:srgbClr val="CADCFC"/>
+                </a:solidFill>
+                <a:latin typeface="Arial"/>
+              </a:rPr>
+              <a:t>market (DK / Bovada) · DK TCU -310 / UNC +250 · Bov TCU -235 / UNC +195</a:t>
+            </a:r>
+          </a:p>
+        </p:txBody>
+      </p:sp>
+      <p:sp>
+        <p:nvSpPr>
+          <p:cNvPr id="27" name="TextBox 26"/>
+          <p:cNvSpPr txBox="1"/>
+          <p:nvPr/>
+        </p:nvSpPr>
+        <p:spPr>
+          <a:xfrm>
+            <a:off x="8046720" y="4315968"/>
             <a:ext cx="3017520" cy="320040"/>
           </a:xfrm>
           <a:prstGeom prst="rect">
@@ -9431,222 +9816,47 @@
           <a:p>
             <a:pPr algn="l"/>
             <a:r>
-              <a:rPr sz="1200" b="1" i="0">
+              <a:rPr sz="1400" b="1" i="0">
                 <a:solidFill>
                   <a:srgbClr val="F47321"/>
                 </a:solidFill>
                 <a:latin typeface="Arial"/>
               </a:rPr>
-              <a:t>THE NUMBER</a:t>
-            </a:r>
-          </a:p>
-        </p:txBody>
-      </p:sp>
-      <p:sp>
-        <p:nvSpPr>
-          <p:cNvPr id="20" name="TextBox 19"/>
-          <p:cNvSpPr txBox="1"/>
-          <p:nvPr/>
-        </p:nvSpPr>
-        <p:spPr>
-          <a:xfrm>
-            <a:off x="8046720" y="2194560"/>
-            <a:ext cx="3017520" cy="640080"/>
-          </a:xfrm>
-          <a:prstGeom prst="rect">
-            <a:avLst/>
-          </a:prstGeom>
-          <a:noFill/>
-        </p:spPr>
-        <p:txBody>
-          <a:bodyPr wrap="square" lIns="0" rIns="0" tIns="0" bIns="0">
-            <a:spAutoFit/>
-          </a:bodyPr>
-          <a:lstStyle/>
-          <a:p>
-            <a:pPr algn="l"/>
-            <a:r>
-              <a:rPr sz="3000" b="1" i="0">
-                <a:solidFill>
-                  <a:srgbClr val="FFFFFF"/>
-                </a:solidFill>
-                <a:latin typeface="Arial"/>
-              </a:rPr>
-              <a:t>TCU –1.5</a:t>
-            </a:r>
-          </a:p>
-        </p:txBody>
-      </p:sp>
-      <p:sp>
-        <p:nvSpPr>
-          <p:cNvPr id="21" name="TextBox 20"/>
-          <p:cNvSpPr txBox="1"/>
-          <p:nvPr/>
-        </p:nvSpPr>
-        <p:spPr>
-          <a:xfrm>
-            <a:off x="8046720" y="2788920"/>
-            <a:ext cx="3017520" cy="274320"/>
-          </a:xfrm>
-          <a:prstGeom prst="rect">
-            <a:avLst/>
-          </a:prstGeom>
-          <a:noFill/>
-        </p:spPr>
-        <p:txBody>
-          <a:bodyPr wrap="square" lIns="0" rIns="0" tIns="0" bIns="0">
-            <a:spAutoFit/>
-          </a:bodyPr>
-          <a:lstStyle/>
-          <a:p>
-            <a:pPr algn="l"/>
-            <a:r>
-              <a:rPr sz="1000" b="0" i="0">
+              <a:t>6–6.5 pts on UNC</a:t>
+            </a:r>
+          </a:p>
+        </p:txBody>
+      </p:sp>
+      <p:sp>
+        <p:nvSpPr>
+          <p:cNvPr id="28" name="TextBox 27"/>
+          <p:cNvSpPr txBox="1"/>
+          <p:nvPr/>
+        </p:nvSpPr>
+        <p:spPr>
+          <a:xfrm>
+            <a:off x="8046720" y="4590288"/>
+            <a:ext cx="3017520" cy="228600"/>
+          </a:xfrm>
+          <a:prstGeom prst="rect">
+            <a:avLst/>
+          </a:prstGeom>
+          <a:noFill/>
+        </p:spPr>
+        <p:txBody>
+          <a:bodyPr wrap="square" lIns="0" rIns="0" tIns="0" bIns="0">
+            <a:spAutoFit/>
+          </a:bodyPr>
+          <a:lstStyle/>
+          <a:p>
+            <a:pPr algn="l"/>
+            <a:r>
+              <a:rPr sz="850" b="0" i="0">
                 <a:solidFill>
                   <a:srgbClr val="CADCFC"/>
                 </a:solidFill>
                 <a:latin typeface="Arial"/>
               </a:rPr>
-              <a:t>machine</a:t>
-            </a:r>
-          </a:p>
-        </p:txBody>
-      </p:sp>
-      <p:sp>
-        <p:nvSpPr>
-          <p:cNvPr id="22" name="TextBox 21"/>
-          <p:cNvSpPr txBox="1"/>
-          <p:nvPr/>
-        </p:nvSpPr>
-        <p:spPr>
-          <a:xfrm>
-            <a:off x="8046720" y="3154680"/>
-            <a:ext cx="3017520" cy="502920"/>
-          </a:xfrm>
-          <a:prstGeom prst="rect">
-            <a:avLst/>
-          </a:prstGeom>
-          <a:noFill/>
-        </p:spPr>
-        <p:txBody>
-          <a:bodyPr wrap="square" lIns="0" rIns="0" tIns="0" bIns="0">
-            <a:spAutoFit/>
-          </a:bodyPr>
-          <a:lstStyle/>
-          <a:p>
-            <a:pPr algn="l"/>
-            <a:r>
-              <a:rPr sz="2200" b="1" i="0">
-                <a:solidFill>
-                  <a:srgbClr val="FFFFFF"/>
-                </a:solidFill>
-                <a:latin typeface="Arial"/>
-              </a:rPr>
-              <a:t>–7.5 / –8</a:t>
-            </a:r>
-          </a:p>
-        </p:txBody>
-      </p:sp>
-      <p:sp>
-        <p:nvSpPr>
-          <p:cNvPr id="23" name="TextBox 22"/>
-          <p:cNvSpPr txBox="1"/>
-          <p:nvPr/>
-        </p:nvSpPr>
-        <p:spPr>
-          <a:xfrm>
-            <a:off x="8046720" y="3611880"/>
-            <a:ext cx="3017520" cy="274320"/>
-          </a:xfrm>
-          <a:prstGeom prst="rect">
-            <a:avLst/>
-          </a:prstGeom>
-          <a:noFill/>
-        </p:spPr>
-        <p:txBody>
-          <a:bodyPr wrap="square" lIns="0" rIns="0" tIns="0" bIns="0">
-            <a:spAutoFit/>
-          </a:bodyPr>
-          <a:lstStyle/>
-          <a:p>
-            <a:pPr algn="l"/>
-            <a:r>
-              <a:rPr sz="1000" b="0" i="0">
-                <a:solidFill>
-                  <a:srgbClr val="CADCFC"/>
-                </a:solidFill>
-                <a:latin typeface="Arial"/>
-              </a:rPr>
-              <a:t>market (DK / Bovada)</a:t>
-            </a:r>
-          </a:p>
-        </p:txBody>
-      </p:sp>
-      <p:sp>
-        <p:nvSpPr>
-          <p:cNvPr id="24" name="TextBox 23"/>
-          <p:cNvSpPr txBox="1"/>
-          <p:nvPr/>
-        </p:nvSpPr>
-        <p:spPr>
-          <a:xfrm>
-            <a:off x="8046720" y="3977639"/>
-            <a:ext cx="3017520" cy="411480"/>
-          </a:xfrm>
-          <a:prstGeom prst="rect">
-            <a:avLst/>
-          </a:prstGeom>
-          <a:noFill/>
-        </p:spPr>
-        <p:txBody>
-          <a:bodyPr wrap="square" lIns="0" rIns="0" tIns="0" bIns="0">
-            <a:spAutoFit/>
-          </a:bodyPr>
-          <a:lstStyle/>
-          <a:p>
-            <a:pPr algn="l"/>
-            <a:r>
-              <a:rPr sz="1600" b="1" i="0">
-                <a:solidFill>
-                  <a:srgbClr val="F47321"/>
-                </a:solidFill>
-                <a:latin typeface="Arial"/>
-              </a:rPr>
-              <a:t>6–6.5 pts on UNC</a:t>
-            </a:r>
-          </a:p>
-        </p:txBody>
-      </p:sp>
-      <p:sp>
-        <p:nvSpPr>
-          <p:cNvPr id="25" name="TextBox 24"/>
-          <p:cNvSpPr txBox="1"/>
-          <p:nvPr/>
-        </p:nvSpPr>
-        <p:spPr>
-          <a:xfrm>
-            <a:off x="8046720" y="4370832"/>
-            <a:ext cx="3017520" cy="274320"/>
-          </a:xfrm>
-          <a:prstGeom prst="rect">
-            <a:avLst/>
-          </a:prstGeom>
-          <a:noFill/>
-        </p:spPr>
-        <p:txBody>
-          <a:bodyPr wrap="square" lIns="0" rIns="0" tIns="0" bIns="0">
-            <a:spAutoFit/>
-          </a:bodyPr>
-          <a:lstStyle/>
-          <a:p>
-            <a:pPr algn="l"/>
-            <a:r>
-              <a:rPr sz="1000" b="0" i="0">
-                <a:solidFill>
-                  <a:srgbClr val="CADCFC"/>
-                </a:solidFill>
-                <a:latin typeface="Arial"/>
-              </a:rPr>
               <a:t>the gap</a:t>
             </a:r>
           </a:p>
@@ -9654,14 +9864,14 @@
       </p:sp>
       <p:sp>
         <p:nvSpPr>
-          <p:cNvPr id="26" name="Rounded Rectangle 25"/>
+          <p:cNvPr id="29" name="Rounded Rectangle 28"/>
           <p:cNvSpPr/>
           <p:nvPr/>
         </p:nvSpPr>
         <p:spPr>
           <a:xfrm>
-            <a:off x="8046720" y="4892040"/>
-            <a:ext cx="3017520" cy="384048"/>
+            <a:off x="8046720" y="4882896"/>
+            <a:ext cx="3017520" cy="365760"/>
           </a:xfrm>
           <a:prstGeom prst="roundRect">
             <a:avLst/>
@@ -9698,14 +9908,14 @@
       </p:sp>
       <p:sp>
         <p:nvSpPr>
-          <p:cNvPr id="27" name="Rounded Rectangle 26"/>
+          <p:cNvPr id="30" name="Rounded Rectangle 29"/>
           <p:cNvSpPr/>
           <p:nvPr/>
         </p:nvSpPr>
         <p:spPr>
           <a:xfrm>
-            <a:off x="8046720" y="4892040"/>
-            <a:ext cx="1629460" cy="384048"/>
+            <a:off x="8046720" y="4882896"/>
+            <a:ext cx="1629460" cy="365760"/>
           </a:xfrm>
           <a:prstGeom prst="roundRect">
             <a:avLst/>
@@ -9742,13 +9952,13 @@
       </p:sp>
       <p:sp>
         <p:nvSpPr>
-          <p:cNvPr id="28" name="TextBox 27"/>
-          <p:cNvSpPr txBox="1"/>
-          <p:nvPr/>
-        </p:nvSpPr>
-        <p:spPr>
-          <a:xfrm>
-            <a:off x="8119872" y="4983479"/>
+          <p:cNvPr id="31" name="TextBox 30"/>
+          <p:cNvSpPr txBox="1"/>
+          <p:nvPr/>
+        </p:nvSpPr>
+        <p:spPr>
+          <a:xfrm>
+            <a:off x="8119872" y="4965192"/>
             <a:ext cx="2194560" cy="228600"/>
           </a:xfrm>
           <a:prstGeom prst="rect">
@@ -9777,13 +9987,13 @@
       </p:sp>
       <p:sp>
         <p:nvSpPr>
-          <p:cNvPr id="29" name="TextBox 28"/>
-          <p:cNvSpPr txBox="1"/>
-          <p:nvPr/>
-        </p:nvSpPr>
-        <p:spPr>
-          <a:xfrm>
-            <a:off x="8796528" y="4983479"/>
+          <p:cNvPr id="32" name="TextBox 31"/>
+          <p:cNvSpPr txBox="1"/>
+          <p:nvPr/>
+        </p:nvSpPr>
+        <p:spPr>
+          <a:xfrm>
+            <a:off x="8796528" y="4965192"/>
             <a:ext cx="2194560" cy="228600"/>
           </a:xfrm>
           <a:prstGeom prst="rect">
@@ -9812,13 +10022,48 @@
       </p:sp>
       <p:sp>
         <p:nvSpPr>
-          <p:cNvPr id="30" name="TextBox 29"/>
-          <p:cNvSpPr txBox="1"/>
-          <p:nvPr/>
-        </p:nvSpPr>
-        <p:spPr>
-          <a:xfrm>
-            <a:off x="8046720" y="5349240"/>
+          <p:cNvPr id="33" name="TextBox 32"/>
+          <p:cNvSpPr txBox="1"/>
+          <p:nvPr/>
+        </p:nvSpPr>
+        <p:spPr>
+          <a:xfrm>
+            <a:off x="8046720" y="5303520"/>
+            <a:ext cx="3017520" cy="228600"/>
+          </a:xfrm>
+          <a:prstGeom prst="rect">
+            <a:avLst/>
+          </a:prstGeom>
+          <a:noFill/>
+        </p:spPr>
+        <p:txBody>
+          <a:bodyPr wrap="square" lIns="0" rIns="0" tIns="0" bIns="0">
+            <a:spAutoFit/>
+          </a:bodyPr>
+          <a:lstStyle/>
+          <a:p>
+            <a:pPr algn="l"/>
+            <a:r>
+              <a:rPr sz="850" b="0" i="0">
+                <a:solidFill>
+                  <a:srgbClr val="CADCFC"/>
+                </a:solidFill>
+                <a:latin typeface="Arial"/>
+              </a:rPr>
+              <a:t>win probability (machine)</a:t>
+            </a:r>
+          </a:p>
+        </p:txBody>
+      </p:sp>
+      <p:sp>
+        <p:nvSpPr>
+          <p:cNvPr id="34" name="TextBox 33"/>
+          <p:cNvSpPr txBox="1"/>
+          <p:nvPr/>
+        </p:nvSpPr>
+        <p:spPr>
+          <a:xfrm>
+            <a:off x="8046720" y="5550408"/>
             <a:ext cx="3017520" cy="274320"/>
           </a:xfrm>
           <a:prstGeom prst="rect">
@@ -9834,41 +10079,6 @@
           <a:p>
             <a:pPr algn="l"/>
             <a:r>
-              <a:rPr sz="950" b="0" i="0">
-                <a:solidFill>
-                  <a:srgbClr val="CADCFC"/>
-                </a:solidFill>
-                <a:latin typeface="Arial"/>
-              </a:rPr>
-              <a:t>win probability (machine)</a:t>
-            </a:r>
-          </a:p>
-        </p:txBody>
-      </p:sp>
-      <p:sp>
-        <p:nvSpPr>
-          <p:cNvPr id="31" name="TextBox 30"/>
-          <p:cNvSpPr txBox="1"/>
-          <p:nvPr/>
-        </p:nvSpPr>
-        <p:spPr>
-          <a:xfrm>
-            <a:off x="8046720" y="5532120"/>
-            <a:ext cx="3017520" cy="274320"/>
-          </a:xfrm>
-          <a:prstGeom prst="rect">
-            <a:avLst/>
-          </a:prstGeom>
-          <a:noFill/>
-        </p:spPr>
-        <p:txBody>
-          <a:bodyPr wrap="square" lIns="0" rIns="0" tIns="0" bIns="0">
-            <a:spAutoFit/>
-          </a:bodyPr>
-          <a:lstStyle/>
-          <a:p>
-            <a:pPr algn="l"/>
-            <a:r>
               <a:rPr sz="950" b="1" i="0">
                 <a:solidFill>
                   <a:srgbClr val="F47321"/>
@@ -9882,7 +10092,7 @@
       </p:sp>
       <p:sp>
         <p:nvSpPr>
-          <p:cNvPr id="32" name="TextBox 31"/>
+          <p:cNvPr id="35" name="TextBox 34"/>
           <p:cNvSpPr txBox="1"/>
           <p:nvPr/>
         </p:nvSpPr>
@@ -9917,7 +10127,7 @@
       </p:sp>
       <p:sp>
         <p:nvSpPr>
-          <p:cNvPr id="33" name="TextBox 32"/>
+          <p:cNvPr id="36" name="TextBox 35"/>
           <p:cNvSpPr txBox="1"/>
           <p:nvPr/>
         </p:nvSpPr>
@@ -11582,8 +11792,8 @@
         </p:nvSpPr>
         <p:spPr>
           <a:xfrm>
-            <a:off x="7772400" y="1600200"/>
-            <a:ext cx="3566160" cy="4206240"/>
+            <a:off x="7772400" y="1554480"/>
+            <a:ext cx="3566160" cy="4370832"/>
           </a:xfrm>
           <a:prstGeom prst="roundRect">
             <a:avLst/>
@@ -11626,7 +11836,287 @@
         </p:nvSpPr>
         <p:spPr>
           <a:xfrm>
-            <a:off x="8046720" y="1828800"/>
+            <a:off x="8046720" y="1737360"/>
+            <a:ext cx="3017520" cy="274320"/>
+          </a:xfrm>
+          <a:prstGeom prst="rect">
+            <a:avLst/>
+          </a:prstGeom>
+          <a:noFill/>
+        </p:spPr>
+        <p:txBody>
+          <a:bodyPr wrap="square" lIns="0" rIns="0" tIns="0" bIns="0">
+            <a:spAutoFit/>
+          </a:bodyPr>
+          <a:lstStyle/>
+          <a:p>
+            <a:pPr algn="l"/>
+            <a:r>
+              <a:rPr sz="1200" b="1" i="0">
+                <a:solidFill>
+                  <a:srgbClr val="F47321"/>
+                </a:solidFill>
+                <a:latin typeface="Arial"/>
+              </a:rPr>
+              <a:t>THE NUMBER</a:t>
+            </a:r>
+          </a:p>
+        </p:txBody>
+      </p:sp>
+      <p:sp>
+        <p:nvSpPr>
+          <p:cNvPr id="20" name="TextBox 19"/>
+          <p:cNvSpPr txBox="1"/>
+          <p:nvPr/>
+        </p:nvSpPr>
+        <p:spPr>
+          <a:xfrm>
+            <a:off x="8046720" y="2011680"/>
+            <a:ext cx="3017520" cy="457200"/>
+          </a:xfrm>
+          <a:prstGeom prst="rect">
+            <a:avLst/>
+          </a:prstGeom>
+          <a:noFill/>
+        </p:spPr>
+        <p:txBody>
+          <a:bodyPr wrap="square" lIns="0" rIns="0" tIns="0" bIns="0">
+            <a:spAutoFit/>
+          </a:bodyPr>
+          <a:lstStyle/>
+          <a:p>
+            <a:pPr algn="l"/>
+            <a:r>
+              <a:rPr sz="2600" b="1" i="0">
+                <a:solidFill>
+                  <a:srgbClr val="FFFFFF"/>
+                </a:solidFill>
+                <a:latin typeface="Arial"/>
+              </a:rPr>
+              <a:t>UVA –6.5</a:t>
+            </a:r>
+          </a:p>
+        </p:txBody>
+      </p:sp>
+      <p:sp>
+        <p:nvSpPr>
+          <p:cNvPr id="21" name="TextBox 20"/>
+          <p:cNvSpPr txBox="1"/>
+          <p:nvPr/>
+        </p:nvSpPr>
+        <p:spPr>
+          <a:xfrm>
+            <a:off x="8046720" y="2450592"/>
+            <a:ext cx="3017520" cy="274320"/>
+          </a:xfrm>
+          <a:prstGeom prst="rect">
+            <a:avLst/>
+          </a:prstGeom>
+          <a:noFill/>
+        </p:spPr>
+        <p:txBody>
+          <a:bodyPr wrap="square" lIns="0" rIns="0" tIns="0" bIns="0">
+            <a:spAutoFit/>
+          </a:bodyPr>
+          <a:lstStyle/>
+          <a:p>
+            <a:pPr algn="l"/>
+            <a:r>
+              <a:rPr sz="1150" b="1" i="0">
+                <a:solidFill>
+                  <a:srgbClr val="FFFFFF"/>
+                </a:solidFill>
+                <a:latin typeface="Arial"/>
+              </a:rPr>
+              <a:t>UVA –187 · NCSU +187</a:t>
+            </a:r>
+          </a:p>
+        </p:txBody>
+      </p:sp>
+      <p:sp>
+        <p:nvSpPr>
+          <p:cNvPr id="22" name="TextBox 21"/>
+          <p:cNvSpPr txBox="1"/>
+          <p:nvPr/>
+        </p:nvSpPr>
+        <p:spPr>
+          <a:xfrm>
+            <a:off x="8046720" y="2688336"/>
+            <a:ext cx="3017520" cy="256032"/>
+          </a:xfrm>
+          <a:prstGeom prst="rect">
+            <a:avLst/>
+          </a:prstGeom>
+          <a:noFill/>
+        </p:spPr>
+        <p:txBody>
+          <a:bodyPr wrap="square" lIns="0" rIns="0" tIns="0" bIns="0">
+            <a:spAutoFit/>
+          </a:bodyPr>
+          <a:lstStyle/>
+          <a:p>
+            <a:pPr algn="l"/>
+            <a:r>
+              <a:rPr sz="850" b="0" i="0">
+                <a:solidFill>
+                  <a:srgbClr val="CADCFC"/>
+                </a:solidFill>
+                <a:latin typeface="Arial"/>
+              </a:rPr>
+              <a:t>machine line · fair odds, no vig · raw margin UVA +6.7</a:t>
+            </a:r>
+          </a:p>
+        </p:txBody>
+      </p:sp>
+      <p:sp>
+        <p:nvSpPr>
+          <p:cNvPr id="23" name="TextBox 22"/>
+          <p:cNvSpPr txBox="1"/>
+          <p:nvPr/>
+        </p:nvSpPr>
+        <p:spPr>
+          <a:xfrm>
+            <a:off x="8046720" y="3017520"/>
+            <a:ext cx="3017520" cy="365760"/>
+          </a:xfrm>
+          <a:prstGeom prst="rect">
+            <a:avLst/>
+          </a:prstGeom>
+          <a:noFill/>
+        </p:spPr>
+        <p:txBody>
+          <a:bodyPr wrap="square" lIns="0" rIns="0" tIns="0" bIns="0">
+            <a:spAutoFit/>
+          </a:bodyPr>
+          <a:lstStyle/>
+          <a:p>
+            <a:pPr algn="l"/>
+            <a:r>
+              <a:rPr sz="1700" b="1" i="0">
+                <a:solidFill>
+                  <a:srgbClr val="FFFFFF"/>
+                </a:solidFill>
+                <a:latin typeface="Arial"/>
+              </a:rPr>
+              <a:t>UVA 30 – NCSU 23</a:t>
+            </a:r>
+          </a:p>
+        </p:txBody>
+      </p:sp>
+      <p:sp>
+        <p:nvSpPr>
+          <p:cNvPr id="24" name="TextBox 23"/>
+          <p:cNvSpPr txBox="1"/>
+          <p:nvPr/>
+        </p:nvSpPr>
+        <p:spPr>
+          <a:xfrm>
+            <a:off x="8046720" y="3328416"/>
+            <a:ext cx="3017520" cy="256032"/>
+          </a:xfrm>
+          <a:prstGeom prst="rect">
+            <a:avLst/>
+          </a:prstGeom>
+          <a:noFill/>
+        </p:spPr>
+        <p:txBody>
+          <a:bodyPr wrap="square" lIns="0" rIns="0" tIns="0" bIns="0">
+            <a:spAutoFit/>
+          </a:bodyPr>
+          <a:lstStyle/>
+          <a:p>
+            <a:pPr algn="l"/>
+            <a:r>
+              <a:rPr sz="850" b="0" i="0">
+                <a:solidFill>
+                  <a:srgbClr val="CADCFC"/>
+                </a:solidFill>
+                <a:latin typeface="Arial"/>
+              </a:rPr>
+              <a:t>projected score · machine margin on the 53.5 market total</a:t>
+            </a:r>
+          </a:p>
+        </p:txBody>
+      </p:sp>
+      <p:sp>
+        <p:nvSpPr>
+          <p:cNvPr id="25" name="TextBox 24"/>
+          <p:cNvSpPr txBox="1"/>
+          <p:nvPr/>
+        </p:nvSpPr>
+        <p:spPr>
+          <a:xfrm>
+            <a:off x="8046720" y="3639312"/>
+            <a:ext cx="3017520" cy="365760"/>
+          </a:xfrm>
+          <a:prstGeom prst="rect">
+            <a:avLst/>
+          </a:prstGeom>
+          <a:noFill/>
+        </p:spPr>
+        <p:txBody>
+          <a:bodyPr wrap="square" lIns="0" rIns="0" tIns="0" bIns="0">
+            <a:spAutoFit/>
+          </a:bodyPr>
+          <a:lstStyle/>
+          <a:p>
+            <a:pPr algn="l"/>
+            <a:r>
+              <a:rPr sz="1700" b="1" i="0">
+                <a:solidFill>
+                  <a:srgbClr val="FFFFFF"/>
+                </a:solidFill>
+                <a:latin typeface="Arial"/>
+              </a:rPr>
+              <a:t>–5.5 / –5.5</a:t>
+            </a:r>
+          </a:p>
+        </p:txBody>
+      </p:sp>
+      <p:sp>
+        <p:nvSpPr>
+          <p:cNvPr id="26" name="TextBox 25"/>
+          <p:cNvSpPr txBox="1"/>
+          <p:nvPr/>
+        </p:nvSpPr>
+        <p:spPr>
+          <a:xfrm>
+            <a:off x="8046720" y="3950208"/>
+            <a:ext cx="3017520" cy="365760"/>
+          </a:xfrm>
+          <a:prstGeom prst="rect">
+            <a:avLst/>
+          </a:prstGeom>
+          <a:noFill/>
+        </p:spPr>
+        <p:txBody>
+          <a:bodyPr wrap="square" lIns="0" rIns="0" tIns="0" bIns="0">
+            <a:spAutoFit/>
+          </a:bodyPr>
+          <a:lstStyle/>
+          <a:p>
+            <a:pPr algn="l"/>
+            <a:r>
+              <a:rPr sz="850" b="0" i="0">
+                <a:solidFill>
+                  <a:srgbClr val="CADCFC"/>
+                </a:solidFill>
+                <a:latin typeface="Arial"/>
+              </a:rPr>
+              <a:t>market (DK / Bovada) · DK UVA -218 / NCSU +180 · Bov UVA -145 / NCSU +125</a:t>
+            </a:r>
+          </a:p>
+        </p:txBody>
+      </p:sp>
+      <p:sp>
+        <p:nvSpPr>
+          <p:cNvPr id="27" name="TextBox 26"/>
+          <p:cNvSpPr txBox="1"/>
+          <p:nvPr/>
+        </p:nvSpPr>
+        <p:spPr>
+          <a:xfrm>
+            <a:off x="8046720" y="4315968"/>
             <a:ext cx="3017520" cy="320040"/>
           </a:xfrm>
           <a:prstGeom prst="rect">
@@ -11642,222 +12132,47 @@
           <a:p>
             <a:pPr algn="l"/>
             <a:r>
-              <a:rPr sz="1200" b="1" i="0">
+              <a:rPr sz="1150" b="1" i="0">
                 <a:solidFill>
                   <a:srgbClr val="F47321"/>
                 </a:solidFill>
                 <a:latin typeface="Arial"/>
               </a:rPr>
-              <a:t>THE NUMBER</a:t>
-            </a:r>
-          </a:p>
-        </p:txBody>
-      </p:sp>
-      <p:sp>
-        <p:nvSpPr>
-          <p:cNvPr id="20" name="TextBox 19"/>
-          <p:cNvSpPr txBox="1"/>
-          <p:nvPr/>
-        </p:nvSpPr>
-        <p:spPr>
-          <a:xfrm>
-            <a:off x="8046720" y="2194560"/>
-            <a:ext cx="3017520" cy="640080"/>
-          </a:xfrm>
-          <a:prstGeom prst="rect">
-            <a:avLst/>
-          </a:prstGeom>
-          <a:noFill/>
-        </p:spPr>
-        <p:txBody>
-          <a:bodyPr wrap="square" lIns="0" rIns="0" tIns="0" bIns="0">
-            <a:spAutoFit/>
-          </a:bodyPr>
-          <a:lstStyle/>
-          <a:p>
-            <a:pPr algn="l"/>
-            <a:r>
-              <a:rPr sz="3000" b="1" i="0">
-                <a:solidFill>
-                  <a:srgbClr val="FFFFFF"/>
-                </a:solidFill>
-                <a:latin typeface="Arial"/>
-              </a:rPr>
-              <a:t>UVA –6.7</a:t>
-            </a:r>
-          </a:p>
-        </p:txBody>
-      </p:sp>
-      <p:sp>
-        <p:nvSpPr>
-          <p:cNvPr id="21" name="TextBox 20"/>
-          <p:cNvSpPr txBox="1"/>
-          <p:nvPr/>
-        </p:nvSpPr>
-        <p:spPr>
-          <a:xfrm>
-            <a:off x="8046720" y="2788920"/>
-            <a:ext cx="3017520" cy="274320"/>
-          </a:xfrm>
-          <a:prstGeom prst="rect">
-            <a:avLst/>
-          </a:prstGeom>
-          <a:noFill/>
-        </p:spPr>
-        <p:txBody>
-          <a:bodyPr wrap="square" lIns="0" rIns="0" tIns="0" bIns="0">
-            <a:spAutoFit/>
-          </a:bodyPr>
-          <a:lstStyle/>
-          <a:p>
-            <a:pPr algn="l"/>
-            <a:r>
-              <a:rPr sz="1000" b="0" i="0">
+              <a:t>EDGE GONE — market converged</a:t>
+            </a:r>
+          </a:p>
+        </p:txBody>
+      </p:sp>
+      <p:sp>
+        <p:nvSpPr>
+          <p:cNvPr id="28" name="TextBox 27"/>
+          <p:cNvSpPr txBox="1"/>
+          <p:nvPr/>
+        </p:nvSpPr>
+        <p:spPr>
+          <a:xfrm>
+            <a:off x="8046720" y="4590288"/>
+            <a:ext cx="3017520" cy="228600"/>
+          </a:xfrm>
+          <a:prstGeom prst="rect">
+            <a:avLst/>
+          </a:prstGeom>
+          <a:noFill/>
+        </p:spPr>
+        <p:txBody>
+          <a:bodyPr wrap="square" lIns="0" rIns="0" tIns="0" bIns="0">
+            <a:spAutoFit/>
+          </a:bodyPr>
+          <a:lstStyle/>
+          <a:p>
+            <a:pPr algn="l"/>
+            <a:r>
+              <a:rPr sz="850" b="0" i="0">
                 <a:solidFill>
                   <a:srgbClr val="CADCFC"/>
                 </a:solidFill>
                 <a:latin typeface="Arial"/>
               </a:rPr>
-              <a:t>machine</a:t>
-            </a:r>
-          </a:p>
-        </p:txBody>
-      </p:sp>
-      <p:sp>
-        <p:nvSpPr>
-          <p:cNvPr id="22" name="TextBox 21"/>
-          <p:cNvSpPr txBox="1"/>
-          <p:nvPr/>
-        </p:nvSpPr>
-        <p:spPr>
-          <a:xfrm>
-            <a:off x="8046720" y="3154680"/>
-            <a:ext cx="3017520" cy="502920"/>
-          </a:xfrm>
-          <a:prstGeom prst="rect">
-            <a:avLst/>
-          </a:prstGeom>
-          <a:noFill/>
-        </p:spPr>
-        <p:txBody>
-          <a:bodyPr wrap="square" lIns="0" rIns="0" tIns="0" bIns="0">
-            <a:spAutoFit/>
-          </a:bodyPr>
-          <a:lstStyle/>
-          <a:p>
-            <a:pPr algn="l"/>
-            <a:r>
-              <a:rPr sz="2200" b="1" i="0">
-                <a:solidFill>
-                  <a:srgbClr val="FFFFFF"/>
-                </a:solidFill>
-                <a:latin typeface="Arial"/>
-              </a:rPr>
-              <a:t>–5.5 / –5.5</a:t>
-            </a:r>
-          </a:p>
-        </p:txBody>
-      </p:sp>
-      <p:sp>
-        <p:nvSpPr>
-          <p:cNvPr id="23" name="TextBox 22"/>
-          <p:cNvSpPr txBox="1"/>
-          <p:nvPr/>
-        </p:nvSpPr>
-        <p:spPr>
-          <a:xfrm>
-            <a:off x="8046720" y="3611880"/>
-            <a:ext cx="3017520" cy="274320"/>
-          </a:xfrm>
-          <a:prstGeom prst="rect">
-            <a:avLst/>
-          </a:prstGeom>
-          <a:noFill/>
-        </p:spPr>
-        <p:txBody>
-          <a:bodyPr wrap="square" lIns="0" rIns="0" tIns="0" bIns="0">
-            <a:spAutoFit/>
-          </a:bodyPr>
-          <a:lstStyle/>
-          <a:p>
-            <a:pPr algn="l"/>
-            <a:r>
-              <a:rPr sz="1000" b="0" i="0">
-                <a:solidFill>
-                  <a:srgbClr val="CADCFC"/>
-                </a:solidFill>
-                <a:latin typeface="Arial"/>
-              </a:rPr>
-              <a:t>market (DK / Bovada)</a:t>
-            </a:r>
-          </a:p>
-        </p:txBody>
-      </p:sp>
-      <p:sp>
-        <p:nvSpPr>
-          <p:cNvPr id="24" name="TextBox 23"/>
-          <p:cNvSpPr txBox="1"/>
-          <p:nvPr/>
-        </p:nvSpPr>
-        <p:spPr>
-          <a:xfrm>
-            <a:off x="8046720" y="3977639"/>
-            <a:ext cx="3017520" cy="411480"/>
-          </a:xfrm>
-          <a:prstGeom prst="rect">
-            <a:avLst/>
-          </a:prstGeom>
-          <a:noFill/>
-        </p:spPr>
-        <p:txBody>
-          <a:bodyPr wrap="square" lIns="0" rIns="0" tIns="0" bIns="0">
-            <a:spAutoFit/>
-          </a:bodyPr>
-          <a:lstStyle/>
-          <a:p>
-            <a:pPr algn="l"/>
-            <a:r>
-              <a:rPr sz="1250" b="1" i="0">
-                <a:solidFill>
-                  <a:srgbClr val="F47321"/>
-                </a:solidFill>
-                <a:latin typeface="Arial"/>
-              </a:rPr>
-              <a:t>EDGE GONE — market converged</a:t>
-            </a:r>
-          </a:p>
-        </p:txBody>
-      </p:sp>
-      <p:sp>
-        <p:nvSpPr>
-          <p:cNvPr id="25" name="TextBox 24"/>
-          <p:cNvSpPr txBox="1"/>
-          <p:nvPr/>
-        </p:nvSpPr>
-        <p:spPr>
-          <a:xfrm>
-            <a:off x="8046720" y="4370832"/>
-            <a:ext cx="3017520" cy="274320"/>
-          </a:xfrm>
-          <a:prstGeom prst="rect">
-            <a:avLst/>
-          </a:prstGeom>
-          <a:noFill/>
-        </p:spPr>
-        <p:txBody>
-          <a:bodyPr wrap="square" lIns="0" rIns="0" tIns="0" bIns="0">
-            <a:spAutoFit/>
-          </a:bodyPr>
-          <a:lstStyle/>
-          <a:p>
-            <a:pPr algn="l"/>
-            <a:r>
-              <a:rPr sz="1000" b="0" i="0">
-                <a:solidFill>
-                  <a:srgbClr val="CADCFC"/>
-                </a:solidFill>
-                <a:latin typeface="Arial"/>
-              </a:rPr>
               <a:t>the gap</a:t>
             </a:r>
           </a:p>
@@ -11865,14 +12180,14 @@
       </p:sp>
       <p:sp>
         <p:nvSpPr>
-          <p:cNvPr id="26" name="Rounded Rectangle 25"/>
+          <p:cNvPr id="29" name="Rounded Rectangle 28"/>
           <p:cNvSpPr/>
           <p:nvPr/>
         </p:nvSpPr>
         <p:spPr>
           <a:xfrm>
-            <a:off x="8046720" y="4892040"/>
-            <a:ext cx="3017520" cy="384048"/>
+            <a:off x="8046720" y="4882896"/>
+            <a:ext cx="3017520" cy="365760"/>
           </a:xfrm>
           <a:prstGeom prst="roundRect">
             <a:avLst/>
@@ -11909,14 +12224,14 @@
       </p:sp>
       <p:sp>
         <p:nvSpPr>
-          <p:cNvPr id="27" name="Rounded Rectangle 26"/>
+          <p:cNvPr id="30" name="Rounded Rectangle 29"/>
           <p:cNvSpPr/>
           <p:nvPr/>
         </p:nvSpPr>
         <p:spPr>
           <a:xfrm>
-            <a:off x="8046720" y="4892040"/>
-            <a:ext cx="1961388" cy="384048"/>
+            <a:off x="8046720" y="4882896"/>
+            <a:ext cx="1961388" cy="365760"/>
           </a:xfrm>
           <a:prstGeom prst="roundRect">
             <a:avLst/>
@@ -11953,13 +12268,13 @@
       </p:sp>
       <p:sp>
         <p:nvSpPr>
-          <p:cNvPr id="28" name="TextBox 27"/>
-          <p:cNvSpPr txBox="1"/>
-          <p:nvPr/>
-        </p:nvSpPr>
-        <p:spPr>
-          <a:xfrm>
-            <a:off x="8119872" y="4983479"/>
+          <p:cNvPr id="31" name="TextBox 30"/>
+          <p:cNvSpPr txBox="1"/>
+          <p:nvPr/>
+        </p:nvSpPr>
+        <p:spPr>
+          <a:xfrm>
+            <a:off x="8119872" y="4965192"/>
             <a:ext cx="2194560" cy="228600"/>
           </a:xfrm>
           <a:prstGeom prst="rect">
@@ -11988,13 +12303,13 @@
       </p:sp>
       <p:sp>
         <p:nvSpPr>
-          <p:cNvPr id="29" name="TextBox 28"/>
-          <p:cNvSpPr txBox="1"/>
-          <p:nvPr/>
-        </p:nvSpPr>
-        <p:spPr>
-          <a:xfrm>
-            <a:off x="8796528" y="4983479"/>
+          <p:cNvPr id="32" name="TextBox 31"/>
+          <p:cNvSpPr txBox="1"/>
+          <p:nvPr/>
+        </p:nvSpPr>
+        <p:spPr>
+          <a:xfrm>
+            <a:off x="8796528" y="4965192"/>
             <a:ext cx="2194560" cy="228600"/>
           </a:xfrm>
           <a:prstGeom prst="rect">
@@ -12023,13 +12338,48 @@
       </p:sp>
       <p:sp>
         <p:nvSpPr>
-          <p:cNvPr id="30" name="TextBox 29"/>
-          <p:cNvSpPr txBox="1"/>
-          <p:nvPr/>
-        </p:nvSpPr>
-        <p:spPr>
-          <a:xfrm>
-            <a:off x="8046720" y="5349240"/>
+          <p:cNvPr id="33" name="TextBox 32"/>
+          <p:cNvSpPr txBox="1"/>
+          <p:nvPr/>
+        </p:nvSpPr>
+        <p:spPr>
+          <a:xfrm>
+            <a:off x="8046720" y="5303520"/>
+            <a:ext cx="3017520" cy="228600"/>
+          </a:xfrm>
+          <a:prstGeom prst="rect">
+            <a:avLst/>
+          </a:prstGeom>
+          <a:noFill/>
+        </p:spPr>
+        <p:txBody>
+          <a:bodyPr wrap="square" lIns="0" rIns="0" tIns="0" bIns="0">
+            <a:spAutoFit/>
+          </a:bodyPr>
+          <a:lstStyle/>
+          <a:p>
+            <a:pPr algn="l"/>
+            <a:r>
+              <a:rPr sz="850" b="0" i="0">
+                <a:solidFill>
+                  <a:srgbClr val="CADCFC"/>
+                </a:solidFill>
+                <a:latin typeface="Arial"/>
+              </a:rPr>
+              <a:t>win probability (machine)</a:t>
+            </a:r>
+          </a:p>
+        </p:txBody>
+      </p:sp>
+      <p:sp>
+        <p:nvSpPr>
+          <p:cNvPr id="34" name="TextBox 33"/>
+          <p:cNvSpPr txBox="1"/>
+          <p:nvPr/>
+        </p:nvSpPr>
+        <p:spPr>
+          <a:xfrm>
+            <a:off x="8046720" y="5550408"/>
             <a:ext cx="3017520" cy="274320"/>
           </a:xfrm>
           <a:prstGeom prst="rect">
@@ -12045,41 +12395,6 @@
           <a:p>
             <a:pPr algn="l"/>
             <a:r>
-              <a:rPr sz="950" b="0" i="0">
-                <a:solidFill>
-                  <a:srgbClr val="CADCFC"/>
-                </a:solidFill>
-                <a:latin typeface="Arial"/>
-              </a:rPr>
-              <a:t>win probability (machine)</a:t>
-            </a:r>
-          </a:p>
-        </p:txBody>
-      </p:sp>
-      <p:sp>
-        <p:nvSpPr>
-          <p:cNvPr id="31" name="TextBox 30"/>
-          <p:cNvSpPr txBox="1"/>
-          <p:nvPr/>
-        </p:nvSpPr>
-        <p:spPr>
-          <a:xfrm>
-            <a:off x="8046720" y="5532120"/>
-            <a:ext cx="3017520" cy="274320"/>
-          </a:xfrm>
-          <a:prstGeom prst="rect">
-            <a:avLst/>
-          </a:prstGeom>
-          <a:noFill/>
-        </p:spPr>
-        <p:txBody>
-          <a:bodyPr wrap="square" lIns="0" rIns="0" tIns="0" bIns="0">
-            <a:spAutoFit/>
-          </a:bodyPr>
-          <a:lstStyle/>
-          <a:p>
-            <a:pPr algn="l"/>
-            <a:r>
               <a:rPr sz="950" b="1" i="0">
                 <a:solidFill>
                   <a:srgbClr val="F47321"/>
@@ -12093,7 +12408,7 @@
       </p:sp>
       <p:sp>
         <p:nvSpPr>
-          <p:cNvPr id="32" name="TextBox 31"/>
+          <p:cNvPr id="35" name="TextBox 34"/>
           <p:cNvSpPr txBox="1"/>
           <p:nvPr/>
         </p:nvSpPr>
@@ -12128,7 +12443,7 @@
       </p:sp>
       <p:sp>
         <p:nvSpPr>
-          <p:cNvPr id="33" name="TextBox 32"/>
+          <p:cNvPr id="36" name="TextBox 35"/>
           <p:cNvSpPr txBox="1"/>
           <p:nvPr/>
         </p:nvSpPr>
@@ -13793,8 +14108,8 @@
         </p:nvSpPr>
         <p:spPr>
           <a:xfrm>
-            <a:off x="7772400" y="1600200"/>
-            <a:ext cx="3566160" cy="4206240"/>
+            <a:off x="7772400" y="1554480"/>
+            <a:ext cx="3566160" cy="4370832"/>
           </a:xfrm>
           <a:prstGeom prst="roundRect">
             <a:avLst/>
@@ -13837,7 +14152,287 @@
         </p:nvSpPr>
         <p:spPr>
           <a:xfrm>
-            <a:off x="8046720" y="1828800"/>
+            <a:off x="8046720" y="1737360"/>
+            <a:ext cx="3017520" cy="274320"/>
+          </a:xfrm>
+          <a:prstGeom prst="rect">
+            <a:avLst/>
+          </a:prstGeom>
+          <a:noFill/>
+        </p:spPr>
+        <p:txBody>
+          <a:bodyPr wrap="square" lIns="0" rIns="0" tIns="0" bIns="0">
+            <a:spAutoFit/>
+          </a:bodyPr>
+          <a:lstStyle/>
+          <a:p>
+            <a:pPr algn="l"/>
+            <a:r>
+              <a:rPr sz="1200" b="1" i="0">
+                <a:solidFill>
+                  <a:srgbClr val="F47321"/>
+                </a:solidFill>
+                <a:latin typeface="Arial"/>
+              </a:rPr>
+              <a:t>THE NUMBER</a:t>
+            </a:r>
+          </a:p>
+        </p:txBody>
+      </p:sp>
+      <p:sp>
+        <p:nvSpPr>
+          <p:cNvPr id="20" name="TextBox 19"/>
+          <p:cNvSpPr txBox="1"/>
+          <p:nvPr/>
+        </p:nvSpPr>
+        <p:spPr>
+          <a:xfrm>
+            <a:off x="8046720" y="2011680"/>
+            <a:ext cx="3017520" cy="457200"/>
+          </a:xfrm>
+          <a:prstGeom prst="rect">
+            <a:avLst/>
+          </a:prstGeom>
+          <a:noFill/>
+        </p:spPr>
+        <p:txBody>
+          <a:bodyPr wrap="square" lIns="0" rIns="0" tIns="0" bIns="0">
+            <a:spAutoFit/>
+          </a:bodyPr>
+          <a:lstStyle/>
+          <a:p>
+            <a:pPr algn="l"/>
+            <a:r>
+              <a:rPr sz="2600" b="1" i="0">
+                <a:solidFill>
+                  <a:srgbClr val="FFFFFF"/>
+                </a:solidFill>
+                <a:latin typeface="Arial"/>
+              </a:rPr>
+              <a:t>NDSU –2.5</a:t>
+            </a:r>
+          </a:p>
+        </p:txBody>
+      </p:sp>
+      <p:sp>
+        <p:nvSpPr>
+          <p:cNvPr id="21" name="TextBox 20"/>
+          <p:cNvSpPr txBox="1"/>
+          <p:nvPr/>
+        </p:nvSpPr>
+        <p:spPr>
+          <a:xfrm>
+            <a:off x="8046720" y="2450592"/>
+            <a:ext cx="3017520" cy="274320"/>
+          </a:xfrm>
+          <a:prstGeom prst="rect">
+            <a:avLst/>
+          </a:prstGeom>
+          <a:noFill/>
+        </p:spPr>
+        <p:txBody>
+          <a:bodyPr wrap="square" lIns="0" rIns="0" tIns="0" bIns="0">
+            <a:spAutoFit/>
+          </a:bodyPr>
+          <a:lstStyle/>
+          <a:p>
+            <a:pPr algn="l"/>
+            <a:r>
+              <a:rPr sz="1150" b="1" i="0">
+                <a:solidFill>
+                  <a:srgbClr val="FFFFFF"/>
+                </a:solidFill>
+                <a:latin typeface="Arial"/>
+              </a:rPr>
+              <a:t>NDSU –131 · JSU +131</a:t>
+            </a:r>
+          </a:p>
+        </p:txBody>
+      </p:sp>
+      <p:sp>
+        <p:nvSpPr>
+          <p:cNvPr id="22" name="TextBox 21"/>
+          <p:cNvSpPr txBox="1"/>
+          <p:nvPr/>
+        </p:nvSpPr>
+        <p:spPr>
+          <a:xfrm>
+            <a:off x="8046720" y="2688336"/>
+            <a:ext cx="3017520" cy="256032"/>
+          </a:xfrm>
+          <a:prstGeom prst="rect">
+            <a:avLst/>
+          </a:prstGeom>
+          <a:noFill/>
+        </p:spPr>
+        <p:txBody>
+          <a:bodyPr wrap="square" lIns="0" rIns="0" tIns="0" bIns="0">
+            <a:spAutoFit/>
+          </a:bodyPr>
+          <a:lstStyle/>
+          <a:p>
+            <a:pPr algn="l"/>
+            <a:r>
+              <a:rPr sz="850" b="0" i="0">
+                <a:solidFill>
+                  <a:srgbClr val="CADCFC"/>
+                </a:solidFill>
+                <a:latin typeface="Arial"/>
+              </a:rPr>
+              <a:t>machine line · fair odds, no vig · raw margin NDSU +2.7</a:t>
+            </a:r>
+          </a:p>
+        </p:txBody>
+      </p:sp>
+      <p:sp>
+        <p:nvSpPr>
+          <p:cNvPr id="23" name="TextBox 22"/>
+          <p:cNvSpPr txBox="1"/>
+          <p:nvPr/>
+        </p:nvSpPr>
+        <p:spPr>
+          <a:xfrm>
+            <a:off x="8046720" y="3017520"/>
+            <a:ext cx="3017520" cy="365760"/>
+          </a:xfrm>
+          <a:prstGeom prst="rect">
+            <a:avLst/>
+          </a:prstGeom>
+          <a:noFill/>
+        </p:spPr>
+        <p:txBody>
+          <a:bodyPr wrap="square" lIns="0" rIns="0" tIns="0" bIns="0">
+            <a:spAutoFit/>
+          </a:bodyPr>
+          <a:lstStyle/>
+          <a:p>
+            <a:pPr algn="l"/>
+            <a:r>
+              <a:rPr sz="1700" b="1" i="0">
+                <a:solidFill>
+                  <a:srgbClr val="FFFFFF"/>
+                </a:solidFill>
+                <a:latin typeface="Arial"/>
+              </a:rPr>
+              <a:t>NDSU 25 – JSU 22</a:t>
+            </a:r>
+          </a:p>
+        </p:txBody>
+      </p:sp>
+      <p:sp>
+        <p:nvSpPr>
+          <p:cNvPr id="24" name="TextBox 23"/>
+          <p:cNvSpPr txBox="1"/>
+          <p:nvPr/>
+        </p:nvSpPr>
+        <p:spPr>
+          <a:xfrm>
+            <a:off x="8046720" y="3328416"/>
+            <a:ext cx="3017520" cy="256032"/>
+          </a:xfrm>
+          <a:prstGeom prst="rect">
+            <a:avLst/>
+          </a:prstGeom>
+          <a:noFill/>
+        </p:spPr>
+        <p:txBody>
+          <a:bodyPr wrap="square" lIns="0" rIns="0" tIns="0" bIns="0">
+            <a:spAutoFit/>
+          </a:bodyPr>
+          <a:lstStyle/>
+          <a:p>
+            <a:pPr algn="l"/>
+            <a:r>
+              <a:rPr sz="850" b="0" i="0">
+                <a:solidFill>
+                  <a:srgbClr val="CADCFC"/>
+                </a:solidFill>
+                <a:latin typeface="Arial"/>
+              </a:rPr>
+              <a:t>projected score · machine margin on the 46.5 market total</a:t>
+            </a:r>
+          </a:p>
+        </p:txBody>
+      </p:sp>
+      <p:sp>
+        <p:nvSpPr>
+          <p:cNvPr id="25" name="TextBox 24"/>
+          <p:cNvSpPr txBox="1"/>
+          <p:nvPr/>
+        </p:nvSpPr>
+        <p:spPr>
+          <a:xfrm>
+            <a:off x="8046720" y="3639312"/>
+            <a:ext cx="3017520" cy="365760"/>
+          </a:xfrm>
+          <a:prstGeom prst="rect">
+            <a:avLst/>
+          </a:prstGeom>
+          <a:noFill/>
+        </p:spPr>
+        <p:txBody>
+          <a:bodyPr wrap="square" lIns="0" rIns="0" tIns="0" bIns="0">
+            <a:spAutoFit/>
+          </a:bodyPr>
+          <a:lstStyle/>
+          <a:p>
+            <a:pPr algn="l"/>
+            <a:r>
+              <a:rPr sz="1700" b="1" i="0">
+                <a:solidFill>
+                  <a:srgbClr val="FFFFFF"/>
+                </a:solidFill>
+                <a:latin typeface="Arial"/>
+              </a:rPr>
+              <a:t>–7 / –7</a:t>
+            </a:r>
+          </a:p>
+        </p:txBody>
+      </p:sp>
+      <p:sp>
+        <p:nvSpPr>
+          <p:cNvPr id="26" name="TextBox 25"/>
+          <p:cNvSpPr txBox="1"/>
+          <p:nvPr/>
+        </p:nvSpPr>
+        <p:spPr>
+          <a:xfrm>
+            <a:off x="8046720" y="3950208"/>
+            <a:ext cx="3017520" cy="365760"/>
+          </a:xfrm>
+          <a:prstGeom prst="rect">
+            <a:avLst/>
+          </a:prstGeom>
+          <a:noFill/>
+        </p:spPr>
+        <p:txBody>
+          <a:bodyPr wrap="square" lIns="0" rIns="0" tIns="0" bIns="0">
+            <a:spAutoFit/>
+          </a:bodyPr>
+          <a:lstStyle/>
+          <a:p>
+            <a:pPr algn="l"/>
+            <a:r>
+              <a:rPr sz="850" b="0" i="0">
+                <a:solidFill>
+                  <a:srgbClr val="CADCFC"/>
+                </a:solidFill>
+                <a:latin typeface="Arial"/>
+              </a:rPr>
+              <a:t>market (DK / Bovada) · DK NDSU -270 / JSU +220 · Bov NDSU -330 / JSU +265</a:t>
+            </a:r>
+          </a:p>
+        </p:txBody>
+      </p:sp>
+      <p:sp>
+        <p:nvSpPr>
+          <p:cNvPr id="27" name="TextBox 26"/>
+          <p:cNvSpPr txBox="1"/>
+          <p:nvPr/>
+        </p:nvSpPr>
+        <p:spPr>
+          <a:xfrm>
+            <a:off x="8046720" y="4315968"/>
             <a:ext cx="3017520" cy="320040"/>
           </a:xfrm>
           <a:prstGeom prst="rect">
@@ -13853,222 +14448,47 @@
           <a:p>
             <a:pPr algn="l"/>
             <a:r>
-              <a:rPr sz="1200" b="1" i="0">
+              <a:rPr sz="1400" b="1" i="0">
                 <a:solidFill>
                   <a:srgbClr val="F47321"/>
                 </a:solidFill>
                 <a:latin typeface="Arial"/>
               </a:rPr>
-              <a:t>THE NUMBER</a:t>
-            </a:r>
-          </a:p>
-        </p:txBody>
-      </p:sp>
-      <p:sp>
-        <p:nvSpPr>
-          <p:cNvPr id="20" name="TextBox 19"/>
-          <p:cNvSpPr txBox="1"/>
-          <p:nvPr/>
-        </p:nvSpPr>
-        <p:spPr>
-          <a:xfrm>
-            <a:off x="8046720" y="2194560"/>
-            <a:ext cx="3017520" cy="640080"/>
-          </a:xfrm>
-          <a:prstGeom prst="rect">
-            <a:avLst/>
-          </a:prstGeom>
-          <a:noFill/>
-        </p:spPr>
-        <p:txBody>
-          <a:bodyPr wrap="square" lIns="0" rIns="0" tIns="0" bIns="0">
-            <a:spAutoFit/>
-          </a:bodyPr>
-          <a:lstStyle/>
-          <a:p>
-            <a:pPr algn="l"/>
-            <a:r>
-              <a:rPr sz="3000" b="1" i="0">
-                <a:solidFill>
-                  <a:srgbClr val="FFFFFF"/>
-                </a:solidFill>
-                <a:latin typeface="Arial"/>
-              </a:rPr>
-              <a:t>NDSU –2.7</a:t>
-            </a:r>
-          </a:p>
-        </p:txBody>
-      </p:sp>
-      <p:sp>
-        <p:nvSpPr>
-          <p:cNvPr id="21" name="TextBox 20"/>
-          <p:cNvSpPr txBox="1"/>
-          <p:nvPr/>
-        </p:nvSpPr>
-        <p:spPr>
-          <a:xfrm>
-            <a:off x="8046720" y="2788920"/>
-            <a:ext cx="3017520" cy="274320"/>
-          </a:xfrm>
-          <a:prstGeom prst="rect">
-            <a:avLst/>
-          </a:prstGeom>
-          <a:noFill/>
-        </p:spPr>
-        <p:txBody>
-          <a:bodyPr wrap="square" lIns="0" rIns="0" tIns="0" bIns="0">
-            <a:spAutoFit/>
-          </a:bodyPr>
-          <a:lstStyle/>
-          <a:p>
-            <a:pPr algn="l"/>
-            <a:r>
-              <a:rPr sz="1000" b="0" i="0">
+              <a:t>+3 CLV banked</a:t>
+            </a:r>
+          </a:p>
+        </p:txBody>
+      </p:sp>
+      <p:sp>
+        <p:nvSpPr>
+          <p:cNvPr id="28" name="TextBox 27"/>
+          <p:cNvSpPr txBox="1"/>
+          <p:nvPr/>
+        </p:nvSpPr>
+        <p:spPr>
+          <a:xfrm>
+            <a:off x="8046720" y="4590288"/>
+            <a:ext cx="3017520" cy="228600"/>
+          </a:xfrm>
+          <a:prstGeom prst="rect">
+            <a:avLst/>
+          </a:prstGeom>
+          <a:noFill/>
+        </p:spPr>
+        <p:txBody>
+          <a:bodyPr wrap="square" lIns="0" rIns="0" tIns="0" bIns="0">
+            <a:spAutoFit/>
+          </a:bodyPr>
+          <a:lstStyle/>
+          <a:p>
+            <a:pPr algn="l"/>
+            <a:r>
+              <a:rPr sz="850" b="0" i="0">
                 <a:solidFill>
                   <a:srgbClr val="CADCFC"/>
                 </a:solidFill>
                 <a:latin typeface="Arial"/>
               </a:rPr>
-              <a:t>machine</a:t>
-            </a:r>
-          </a:p>
-        </p:txBody>
-      </p:sp>
-      <p:sp>
-        <p:nvSpPr>
-          <p:cNvPr id="22" name="TextBox 21"/>
-          <p:cNvSpPr txBox="1"/>
-          <p:nvPr/>
-        </p:nvSpPr>
-        <p:spPr>
-          <a:xfrm>
-            <a:off x="8046720" y="3154680"/>
-            <a:ext cx="3017520" cy="502920"/>
-          </a:xfrm>
-          <a:prstGeom prst="rect">
-            <a:avLst/>
-          </a:prstGeom>
-          <a:noFill/>
-        </p:spPr>
-        <p:txBody>
-          <a:bodyPr wrap="square" lIns="0" rIns="0" tIns="0" bIns="0">
-            <a:spAutoFit/>
-          </a:bodyPr>
-          <a:lstStyle/>
-          <a:p>
-            <a:pPr algn="l"/>
-            <a:r>
-              <a:rPr sz="2200" b="1" i="0">
-                <a:solidFill>
-                  <a:srgbClr val="FFFFFF"/>
-                </a:solidFill>
-                <a:latin typeface="Arial"/>
-              </a:rPr>
-              <a:t>–7 / –7</a:t>
-            </a:r>
-          </a:p>
-        </p:txBody>
-      </p:sp>
-      <p:sp>
-        <p:nvSpPr>
-          <p:cNvPr id="23" name="TextBox 22"/>
-          <p:cNvSpPr txBox="1"/>
-          <p:nvPr/>
-        </p:nvSpPr>
-        <p:spPr>
-          <a:xfrm>
-            <a:off x="8046720" y="3611880"/>
-            <a:ext cx="3017520" cy="274320"/>
-          </a:xfrm>
-          <a:prstGeom prst="rect">
-            <a:avLst/>
-          </a:prstGeom>
-          <a:noFill/>
-        </p:spPr>
-        <p:txBody>
-          <a:bodyPr wrap="square" lIns="0" rIns="0" tIns="0" bIns="0">
-            <a:spAutoFit/>
-          </a:bodyPr>
-          <a:lstStyle/>
-          <a:p>
-            <a:pPr algn="l"/>
-            <a:r>
-              <a:rPr sz="1000" b="0" i="0">
-                <a:solidFill>
-                  <a:srgbClr val="CADCFC"/>
-                </a:solidFill>
-                <a:latin typeface="Arial"/>
-              </a:rPr>
-              <a:t>market (DK / Bovada)</a:t>
-            </a:r>
-          </a:p>
-        </p:txBody>
-      </p:sp>
-      <p:sp>
-        <p:nvSpPr>
-          <p:cNvPr id="24" name="TextBox 23"/>
-          <p:cNvSpPr txBox="1"/>
-          <p:nvPr/>
-        </p:nvSpPr>
-        <p:spPr>
-          <a:xfrm>
-            <a:off x="8046720" y="3977639"/>
-            <a:ext cx="3017520" cy="411480"/>
-          </a:xfrm>
-          <a:prstGeom prst="rect">
-            <a:avLst/>
-          </a:prstGeom>
-          <a:noFill/>
-        </p:spPr>
-        <p:txBody>
-          <a:bodyPr wrap="square" lIns="0" rIns="0" tIns="0" bIns="0">
-            <a:spAutoFit/>
-          </a:bodyPr>
-          <a:lstStyle/>
-          <a:p>
-            <a:pPr algn="l"/>
-            <a:r>
-              <a:rPr sz="1600" b="1" i="0">
-                <a:solidFill>
-                  <a:srgbClr val="F47321"/>
-                </a:solidFill>
-                <a:latin typeface="Arial"/>
-              </a:rPr>
-              <a:t>+3 CLV banked</a:t>
-            </a:r>
-          </a:p>
-        </p:txBody>
-      </p:sp>
-      <p:sp>
-        <p:nvSpPr>
-          <p:cNvPr id="25" name="TextBox 24"/>
-          <p:cNvSpPr txBox="1"/>
-          <p:nvPr/>
-        </p:nvSpPr>
-        <p:spPr>
-          <a:xfrm>
-            <a:off x="8046720" y="4370832"/>
-            <a:ext cx="3017520" cy="274320"/>
-          </a:xfrm>
-          <a:prstGeom prst="rect">
-            <a:avLst/>
-          </a:prstGeom>
-          <a:noFill/>
-        </p:spPr>
-        <p:txBody>
-          <a:bodyPr wrap="square" lIns="0" rIns="0" tIns="0" bIns="0">
-            <a:spAutoFit/>
-          </a:bodyPr>
-          <a:lstStyle/>
-          <a:p>
-            <a:pPr algn="l"/>
-            <a:r>
-              <a:rPr sz="1000" b="0" i="0">
-                <a:solidFill>
-                  <a:srgbClr val="CADCFC"/>
-                </a:solidFill>
-                <a:latin typeface="Arial"/>
-              </a:rPr>
               <a:t>the gap</a:t>
             </a:r>
           </a:p>
@@ -14076,14 +14496,14 @@
       </p:sp>
       <p:sp>
         <p:nvSpPr>
-          <p:cNvPr id="26" name="Rounded Rectangle 25"/>
+          <p:cNvPr id="29" name="Rounded Rectangle 28"/>
           <p:cNvSpPr/>
           <p:nvPr/>
         </p:nvSpPr>
         <p:spPr>
           <a:xfrm>
-            <a:off x="8046720" y="4892040"/>
-            <a:ext cx="3017520" cy="384048"/>
+            <a:off x="8046720" y="4882896"/>
+            <a:ext cx="3017520" cy="365760"/>
           </a:xfrm>
           <a:prstGeom prst="roundRect">
             <a:avLst/>
@@ -14120,14 +14540,14 @@
       </p:sp>
       <p:sp>
         <p:nvSpPr>
-          <p:cNvPr id="27" name="Rounded Rectangle 26"/>
+          <p:cNvPr id="30" name="Rounded Rectangle 29"/>
           <p:cNvSpPr/>
           <p:nvPr/>
         </p:nvSpPr>
         <p:spPr>
           <a:xfrm>
-            <a:off x="8046720" y="4892040"/>
-            <a:ext cx="1719986" cy="384048"/>
+            <a:off x="8046720" y="4882896"/>
+            <a:ext cx="1719986" cy="365760"/>
           </a:xfrm>
           <a:prstGeom prst="roundRect">
             <a:avLst/>
@@ -14164,13 +14584,13 @@
       </p:sp>
       <p:sp>
         <p:nvSpPr>
-          <p:cNvPr id="28" name="TextBox 27"/>
-          <p:cNvSpPr txBox="1"/>
-          <p:nvPr/>
-        </p:nvSpPr>
-        <p:spPr>
-          <a:xfrm>
-            <a:off x="8119872" y="4983479"/>
+          <p:cNvPr id="31" name="TextBox 30"/>
+          <p:cNvSpPr txBox="1"/>
+          <p:nvPr/>
+        </p:nvSpPr>
+        <p:spPr>
+          <a:xfrm>
+            <a:off x="8119872" y="4965192"/>
             <a:ext cx="2194560" cy="228600"/>
           </a:xfrm>
           <a:prstGeom prst="rect">
@@ -14199,13 +14619,13 @@
       </p:sp>
       <p:sp>
         <p:nvSpPr>
-          <p:cNvPr id="29" name="TextBox 28"/>
-          <p:cNvSpPr txBox="1"/>
-          <p:nvPr/>
-        </p:nvSpPr>
-        <p:spPr>
-          <a:xfrm>
-            <a:off x="8796528" y="4983479"/>
+          <p:cNvPr id="32" name="TextBox 31"/>
+          <p:cNvSpPr txBox="1"/>
+          <p:nvPr/>
+        </p:nvSpPr>
+        <p:spPr>
+          <a:xfrm>
+            <a:off x="8796528" y="4965192"/>
             <a:ext cx="2194560" cy="228600"/>
           </a:xfrm>
           <a:prstGeom prst="rect">
@@ -14234,13 +14654,48 @@
       </p:sp>
       <p:sp>
         <p:nvSpPr>
-          <p:cNvPr id="30" name="TextBox 29"/>
-          <p:cNvSpPr txBox="1"/>
-          <p:nvPr/>
-        </p:nvSpPr>
-        <p:spPr>
-          <a:xfrm>
-            <a:off x="8046720" y="5349240"/>
+          <p:cNvPr id="33" name="TextBox 32"/>
+          <p:cNvSpPr txBox="1"/>
+          <p:nvPr/>
+        </p:nvSpPr>
+        <p:spPr>
+          <a:xfrm>
+            <a:off x="8046720" y="5303520"/>
+            <a:ext cx="3017520" cy="228600"/>
+          </a:xfrm>
+          <a:prstGeom prst="rect">
+            <a:avLst/>
+          </a:prstGeom>
+          <a:noFill/>
+        </p:spPr>
+        <p:txBody>
+          <a:bodyPr wrap="square" lIns="0" rIns="0" tIns="0" bIns="0">
+            <a:spAutoFit/>
+          </a:bodyPr>
+          <a:lstStyle/>
+          <a:p>
+            <a:pPr algn="l"/>
+            <a:r>
+              <a:rPr sz="850" b="0" i="0">
+                <a:solidFill>
+                  <a:srgbClr val="CADCFC"/>
+                </a:solidFill>
+                <a:latin typeface="Arial"/>
+              </a:rPr>
+              <a:t>win probability (machine)</a:t>
+            </a:r>
+          </a:p>
+        </p:txBody>
+      </p:sp>
+      <p:sp>
+        <p:nvSpPr>
+          <p:cNvPr id="34" name="TextBox 33"/>
+          <p:cNvSpPr txBox="1"/>
+          <p:nvPr/>
+        </p:nvSpPr>
+        <p:spPr>
+          <a:xfrm>
+            <a:off x="8046720" y="5550408"/>
             <a:ext cx="3017520" cy="274320"/>
           </a:xfrm>
           <a:prstGeom prst="rect">
@@ -14256,41 +14711,6 @@
           <a:p>
             <a:pPr algn="l"/>
             <a:r>
-              <a:rPr sz="950" b="0" i="0">
-                <a:solidFill>
-                  <a:srgbClr val="CADCFC"/>
-                </a:solidFill>
-                <a:latin typeface="Arial"/>
-              </a:rPr>
-              <a:t>win probability (machine)</a:t>
-            </a:r>
-          </a:p>
-        </p:txBody>
-      </p:sp>
-      <p:sp>
-        <p:nvSpPr>
-          <p:cNvPr id="31" name="TextBox 30"/>
-          <p:cNvSpPr txBox="1"/>
-          <p:nvPr/>
-        </p:nvSpPr>
-        <p:spPr>
-          <a:xfrm>
-            <a:off x="8046720" y="5532120"/>
-            <a:ext cx="3017520" cy="274320"/>
-          </a:xfrm>
-          <a:prstGeom prst="rect">
-            <a:avLst/>
-          </a:prstGeom>
-          <a:noFill/>
-        </p:spPr>
-        <p:txBody>
-          <a:bodyPr wrap="square" lIns="0" rIns="0" tIns="0" bIns="0">
-            <a:spAutoFit/>
-          </a:bodyPr>
-          <a:lstStyle/>
-          <a:p>
-            <a:pPr algn="l"/>
-            <a:r>
               <a:rPr sz="950" b="1" i="0">
                 <a:solidFill>
                   <a:srgbClr val="F47321"/>
@@ -14304,7 +14724,7 @@
       </p:sp>
       <p:sp>
         <p:nvSpPr>
-          <p:cNvPr id="32" name="TextBox 31"/>
+          <p:cNvPr id="35" name="TextBox 34"/>
           <p:cNvSpPr txBox="1"/>
           <p:nvPr/>
         </p:nvSpPr>
@@ -14339,7 +14759,7 @@
       </p:sp>
       <p:sp>
         <p:nvSpPr>
-          <p:cNvPr id="33" name="TextBox 32"/>
+          <p:cNvPr id="36" name="TextBox 35"/>
           <p:cNvSpPr txBox="1"/>
           <p:nvPr/>
         </p:nvSpPr>
@@ -16004,8 +16424,8 @@
         </p:nvSpPr>
         <p:spPr>
           <a:xfrm>
-            <a:off x="7772400" y="1600200"/>
-            <a:ext cx="3566160" cy="4206240"/>
+            <a:off x="7772400" y="1554480"/>
+            <a:ext cx="3566160" cy="4370832"/>
           </a:xfrm>
           <a:prstGeom prst="roundRect">
             <a:avLst/>
@@ -16048,7 +16468,287 @@
         </p:nvSpPr>
         <p:spPr>
           <a:xfrm>
-            <a:off x="8046720" y="1828800"/>
+            <a:off x="8046720" y="1737360"/>
+            <a:ext cx="3017520" cy="274320"/>
+          </a:xfrm>
+          <a:prstGeom prst="rect">
+            <a:avLst/>
+          </a:prstGeom>
+          <a:noFill/>
+        </p:spPr>
+        <p:txBody>
+          <a:bodyPr wrap="square" lIns="0" rIns="0" tIns="0" bIns="0">
+            <a:spAutoFit/>
+          </a:bodyPr>
+          <a:lstStyle/>
+          <a:p>
+            <a:pPr algn="l"/>
+            <a:r>
+              <a:rPr sz="1200" b="1" i="0">
+                <a:solidFill>
+                  <a:srgbClr val="F47321"/>
+                </a:solidFill>
+                <a:latin typeface="Arial"/>
+              </a:rPr>
+              <a:t>THE NUMBER</a:t>
+            </a:r>
+          </a:p>
+        </p:txBody>
+      </p:sp>
+      <p:sp>
+        <p:nvSpPr>
+          <p:cNvPr id="20" name="TextBox 19"/>
+          <p:cNvSpPr txBox="1"/>
+          <p:nvPr/>
+        </p:nvSpPr>
+        <p:spPr>
+          <a:xfrm>
+            <a:off x="8046720" y="2011680"/>
+            <a:ext cx="3017520" cy="457200"/>
+          </a:xfrm>
+          <a:prstGeom prst="rect">
+            <a:avLst/>
+          </a:prstGeom>
+          <a:noFill/>
+        </p:spPr>
+        <p:txBody>
+          <a:bodyPr wrap="square" lIns="0" rIns="0" tIns="0" bIns="0">
+            <a:spAutoFit/>
+          </a:bodyPr>
+          <a:lstStyle/>
+          <a:p>
+            <a:pPr algn="l"/>
+            <a:r>
+              <a:rPr sz="2600" b="1" i="0">
+                <a:solidFill>
+                  <a:srgbClr val="FFFFFF"/>
+                </a:solidFill>
+                <a:latin typeface="Arial"/>
+              </a:rPr>
+              <a:t>Stanford –1.5</a:t>
+            </a:r>
+          </a:p>
+        </p:txBody>
+      </p:sp>
+      <p:sp>
+        <p:nvSpPr>
+          <p:cNvPr id="21" name="TextBox 20"/>
+          <p:cNvSpPr txBox="1"/>
+          <p:nvPr/>
+        </p:nvSpPr>
+        <p:spPr>
+          <a:xfrm>
+            <a:off x="8046720" y="2450592"/>
+            <a:ext cx="3017520" cy="274320"/>
+          </a:xfrm>
+          <a:prstGeom prst="rect">
+            <a:avLst/>
+          </a:prstGeom>
+          <a:noFill/>
+        </p:spPr>
+        <p:txBody>
+          <a:bodyPr wrap="square" lIns="0" rIns="0" tIns="0" bIns="0">
+            <a:spAutoFit/>
+          </a:bodyPr>
+          <a:lstStyle/>
+          <a:p>
+            <a:pPr algn="l"/>
+            <a:r>
+              <a:rPr sz="1150" b="1" i="0">
+                <a:solidFill>
+                  <a:srgbClr val="FFFFFF"/>
+                </a:solidFill>
+                <a:latin typeface="Arial"/>
+              </a:rPr>
+              <a:t>Stanford –119 · HAW +119</a:t>
+            </a:r>
+          </a:p>
+        </p:txBody>
+      </p:sp>
+      <p:sp>
+        <p:nvSpPr>
+          <p:cNvPr id="22" name="TextBox 21"/>
+          <p:cNvSpPr txBox="1"/>
+          <p:nvPr/>
+        </p:nvSpPr>
+        <p:spPr>
+          <a:xfrm>
+            <a:off x="8046720" y="2688336"/>
+            <a:ext cx="3017520" cy="256032"/>
+          </a:xfrm>
+          <a:prstGeom prst="rect">
+            <a:avLst/>
+          </a:prstGeom>
+          <a:noFill/>
+        </p:spPr>
+        <p:txBody>
+          <a:bodyPr wrap="square" lIns="0" rIns="0" tIns="0" bIns="0">
+            <a:spAutoFit/>
+          </a:bodyPr>
+          <a:lstStyle/>
+          <a:p>
+            <a:pPr algn="l"/>
+            <a:r>
+              <a:rPr sz="850" b="0" i="0">
+                <a:solidFill>
+                  <a:srgbClr val="CADCFC"/>
+                </a:solidFill>
+                <a:latin typeface="Arial"/>
+              </a:rPr>
+              <a:t>machine line · fair odds, no vig · raw margin Stanford +1.6</a:t>
+            </a:r>
+          </a:p>
+        </p:txBody>
+      </p:sp>
+      <p:sp>
+        <p:nvSpPr>
+          <p:cNvPr id="23" name="TextBox 22"/>
+          <p:cNvSpPr txBox="1"/>
+          <p:nvPr/>
+        </p:nvSpPr>
+        <p:spPr>
+          <a:xfrm>
+            <a:off x="8046720" y="3017520"/>
+            <a:ext cx="3017520" cy="365760"/>
+          </a:xfrm>
+          <a:prstGeom prst="rect">
+            <a:avLst/>
+          </a:prstGeom>
+          <a:noFill/>
+        </p:spPr>
+        <p:txBody>
+          <a:bodyPr wrap="square" lIns="0" rIns="0" tIns="0" bIns="0">
+            <a:spAutoFit/>
+          </a:bodyPr>
+          <a:lstStyle/>
+          <a:p>
+            <a:pPr algn="l"/>
+            <a:r>
+              <a:rPr sz="1700" b="1" i="0">
+                <a:solidFill>
+                  <a:srgbClr val="FFFFFF"/>
+                </a:solidFill>
+                <a:latin typeface="Arial"/>
+              </a:rPr>
+              <a:t>Stanford 26 – HAW 24</a:t>
+            </a:r>
+          </a:p>
+        </p:txBody>
+      </p:sp>
+      <p:sp>
+        <p:nvSpPr>
+          <p:cNvPr id="24" name="TextBox 23"/>
+          <p:cNvSpPr txBox="1"/>
+          <p:nvPr/>
+        </p:nvSpPr>
+        <p:spPr>
+          <a:xfrm>
+            <a:off x="8046720" y="3328416"/>
+            <a:ext cx="3017520" cy="256032"/>
+          </a:xfrm>
+          <a:prstGeom prst="rect">
+            <a:avLst/>
+          </a:prstGeom>
+          <a:noFill/>
+        </p:spPr>
+        <p:txBody>
+          <a:bodyPr wrap="square" lIns="0" rIns="0" tIns="0" bIns="0">
+            <a:spAutoFit/>
+          </a:bodyPr>
+          <a:lstStyle/>
+          <a:p>
+            <a:pPr algn="l"/>
+            <a:r>
+              <a:rPr sz="850" b="0" i="0">
+                <a:solidFill>
+                  <a:srgbClr val="CADCFC"/>
+                </a:solidFill>
+                <a:latin typeface="Arial"/>
+              </a:rPr>
+              <a:t>projected score · machine margin on the 49.5 market total</a:t>
+            </a:r>
+          </a:p>
+        </p:txBody>
+      </p:sp>
+      <p:sp>
+        <p:nvSpPr>
+          <p:cNvPr id="25" name="TextBox 24"/>
+          <p:cNvSpPr txBox="1"/>
+          <p:nvPr/>
+        </p:nvSpPr>
+        <p:spPr>
+          <a:xfrm>
+            <a:off x="8046720" y="3639312"/>
+            <a:ext cx="3017520" cy="365760"/>
+          </a:xfrm>
+          <a:prstGeom prst="rect">
+            <a:avLst/>
+          </a:prstGeom>
+          <a:noFill/>
+        </p:spPr>
+        <p:txBody>
+          <a:bodyPr wrap="square" lIns="0" rIns="0" tIns="0" bIns="0">
+            <a:spAutoFit/>
+          </a:bodyPr>
+          <a:lstStyle/>
+          <a:p>
+            <a:pPr algn="l"/>
+            <a:r>
+              <a:rPr sz="1700" b="1" i="0">
+                <a:solidFill>
+                  <a:srgbClr val="FFFFFF"/>
+                </a:solidFill>
+                <a:latin typeface="Arial"/>
+              </a:rPr>
+              <a:t>–5.5 / –5.5</a:t>
+            </a:r>
+          </a:p>
+        </p:txBody>
+      </p:sp>
+      <p:sp>
+        <p:nvSpPr>
+          <p:cNvPr id="26" name="TextBox 25"/>
+          <p:cNvSpPr txBox="1"/>
+          <p:nvPr/>
+        </p:nvSpPr>
+        <p:spPr>
+          <a:xfrm>
+            <a:off x="8046720" y="3950208"/>
+            <a:ext cx="3017520" cy="365760"/>
+          </a:xfrm>
+          <a:prstGeom prst="rect">
+            <a:avLst/>
+          </a:prstGeom>
+          <a:noFill/>
+        </p:spPr>
+        <p:txBody>
+          <a:bodyPr wrap="square" lIns="0" rIns="0" tIns="0" bIns="0">
+            <a:spAutoFit/>
+          </a:bodyPr>
+          <a:lstStyle/>
+          <a:p>
+            <a:pPr algn="l"/>
+            <a:r>
+              <a:rPr sz="850" b="0" i="0">
+                <a:solidFill>
+                  <a:srgbClr val="CADCFC"/>
+                </a:solidFill>
+                <a:latin typeface="Arial"/>
+              </a:rPr>
+              <a:t>market (DK / Bovada) · DK Stanford -218 / HAW +180 · Bov Stanford -170 / HAW +145</a:t>
+            </a:r>
+          </a:p>
+        </p:txBody>
+      </p:sp>
+      <p:sp>
+        <p:nvSpPr>
+          <p:cNvPr id="27" name="TextBox 26"/>
+          <p:cNvSpPr txBox="1"/>
+          <p:nvPr/>
+        </p:nvSpPr>
+        <p:spPr>
+          <a:xfrm>
+            <a:off x="8046720" y="4315968"/>
             <a:ext cx="3017520" cy="320040"/>
           </a:xfrm>
           <a:prstGeom prst="rect">
@@ -16064,222 +16764,47 @@
           <a:p>
             <a:pPr algn="l"/>
             <a:r>
-              <a:rPr sz="1200" b="1" i="0">
+              <a:rPr sz="1400" b="1" i="0">
                 <a:solidFill>
                   <a:srgbClr val="F47321"/>
                 </a:solidFill>
                 <a:latin typeface="Arial"/>
               </a:rPr>
-              <a:t>THE NUMBER</a:t>
-            </a:r>
-          </a:p>
-        </p:txBody>
-      </p:sp>
-      <p:sp>
-        <p:nvSpPr>
-          <p:cNvPr id="20" name="TextBox 19"/>
-          <p:cNvSpPr txBox="1"/>
-          <p:nvPr/>
-        </p:nvSpPr>
-        <p:spPr>
-          <a:xfrm>
-            <a:off x="8046720" y="2194560"/>
-            <a:ext cx="3017520" cy="640080"/>
-          </a:xfrm>
-          <a:prstGeom prst="rect">
-            <a:avLst/>
-          </a:prstGeom>
-          <a:noFill/>
-        </p:spPr>
-        <p:txBody>
-          <a:bodyPr wrap="square" lIns="0" rIns="0" tIns="0" bIns="0">
-            <a:spAutoFit/>
-          </a:bodyPr>
-          <a:lstStyle/>
-          <a:p>
-            <a:pPr algn="l"/>
-            <a:r>
-              <a:rPr sz="3000" b="1" i="0">
-                <a:solidFill>
-                  <a:srgbClr val="FFFFFF"/>
-                </a:solidFill>
-                <a:latin typeface="Arial"/>
-              </a:rPr>
-              <a:t>Stanford –1.6</a:t>
-            </a:r>
-          </a:p>
-        </p:txBody>
-      </p:sp>
-      <p:sp>
-        <p:nvSpPr>
-          <p:cNvPr id="21" name="TextBox 20"/>
-          <p:cNvSpPr txBox="1"/>
-          <p:nvPr/>
-        </p:nvSpPr>
-        <p:spPr>
-          <a:xfrm>
-            <a:off x="8046720" y="2788920"/>
-            <a:ext cx="3017520" cy="274320"/>
-          </a:xfrm>
-          <a:prstGeom prst="rect">
-            <a:avLst/>
-          </a:prstGeom>
-          <a:noFill/>
-        </p:spPr>
-        <p:txBody>
-          <a:bodyPr wrap="square" lIns="0" rIns="0" tIns="0" bIns="0">
-            <a:spAutoFit/>
-          </a:bodyPr>
-          <a:lstStyle/>
-          <a:p>
-            <a:pPr algn="l"/>
-            <a:r>
-              <a:rPr sz="1000" b="0" i="0">
+              <a:t>3.9 pts on Hawai'i</a:t>
+            </a:r>
+          </a:p>
+        </p:txBody>
+      </p:sp>
+      <p:sp>
+        <p:nvSpPr>
+          <p:cNvPr id="28" name="TextBox 27"/>
+          <p:cNvSpPr txBox="1"/>
+          <p:nvPr/>
+        </p:nvSpPr>
+        <p:spPr>
+          <a:xfrm>
+            <a:off x="8046720" y="4590288"/>
+            <a:ext cx="3017520" cy="228600"/>
+          </a:xfrm>
+          <a:prstGeom prst="rect">
+            <a:avLst/>
+          </a:prstGeom>
+          <a:noFill/>
+        </p:spPr>
+        <p:txBody>
+          <a:bodyPr wrap="square" lIns="0" rIns="0" tIns="0" bIns="0">
+            <a:spAutoFit/>
+          </a:bodyPr>
+          <a:lstStyle/>
+          <a:p>
+            <a:pPr algn="l"/>
+            <a:r>
+              <a:rPr sz="850" b="0" i="0">
                 <a:solidFill>
                   <a:srgbClr val="CADCFC"/>
                 </a:solidFill>
                 <a:latin typeface="Arial"/>
               </a:rPr>
-              <a:t>machine</a:t>
-            </a:r>
-          </a:p>
-        </p:txBody>
-      </p:sp>
-      <p:sp>
-        <p:nvSpPr>
-          <p:cNvPr id="22" name="TextBox 21"/>
-          <p:cNvSpPr txBox="1"/>
-          <p:nvPr/>
-        </p:nvSpPr>
-        <p:spPr>
-          <a:xfrm>
-            <a:off x="8046720" y="3154680"/>
-            <a:ext cx="3017520" cy="502920"/>
-          </a:xfrm>
-          <a:prstGeom prst="rect">
-            <a:avLst/>
-          </a:prstGeom>
-          <a:noFill/>
-        </p:spPr>
-        <p:txBody>
-          <a:bodyPr wrap="square" lIns="0" rIns="0" tIns="0" bIns="0">
-            <a:spAutoFit/>
-          </a:bodyPr>
-          <a:lstStyle/>
-          <a:p>
-            <a:pPr algn="l"/>
-            <a:r>
-              <a:rPr sz="2200" b="1" i="0">
-                <a:solidFill>
-                  <a:srgbClr val="FFFFFF"/>
-                </a:solidFill>
-                <a:latin typeface="Arial"/>
-              </a:rPr>
-              <a:t>–5.5 / –5.5</a:t>
-            </a:r>
-          </a:p>
-        </p:txBody>
-      </p:sp>
-      <p:sp>
-        <p:nvSpPr>
-          <p:cNvPr id="23" name="TextBox 22"/>
-          <p:cNvSpPr txBox="1"/>
-          <p:nvPr/>
-        </p:nvSpPr>
-        <p:spPr>
-          <a:xfrm>
-            <a:off x="8046720" y="3611880"/>
-            <a:ext cx="3017520" cy="274320"/>
-          </a:xfrm>
-          <a:prstGeom prst="rect">
-            <a:avLst/>
-          </a:prstGeom>
-          <a:noFill/>
-        </p:spPr>
-        <p:txBody>
-          <a:bodyPr wrap="square" lIns="0" rIns="0" tIns="0" bIns="0">
-            <a:spAutoFit/>
-          </a:bodyPr>
-          <a:lstStyle/>
-          <a:p>
-            <a:pPr algn="l"/>
-            <a:r>
-              <a:rPr sz="1000" b="0" i="0">
-                <a:solidFill>
-                  <a:srgbClr val="CADCFC"/>
-                </a:solidFill>
-                <a:latin typeface="Arial"/>
-              </a:rPr>
-              <a:t>market (DK / Bovada)</a:t>
-            </a:r>
-          </a:p>
-        </p:txBody>
-      </p:sp>
-      <p:sp>
-        <p:nvSpPr>
-          <p:cNvPr id="24" name="TextBox 23"/>
-          <p:cNvSpPr txBox="1"/>
-          <p:nvPr/>
-        </p:nvSpPr>
-        <p:spPr>
-          <a:xfrm>
-            <a:off x="8046720" y="3977639"/>
-            <a:ext cx="3017520" cy="411480"/>
-          </a:xfrm>
-          <a:prstGeom prst="rect">
-            <a:avLst/>
-          </a:prstGeom>
-          <a:noFill/>
-        </p:spPr>
-        <p:txBody>
-          <a:bodyPr wrap="square" lIns="0" rIns="0" tIns="0" bIns="0">
-            <a:spAutoFit/>
-          </a:bodyPr>
-          <a:lstStyle/>
-          <a:p>
-            <a:pPr algn="l"/>
-            <a:r>
-              <a:rPr sz="1600" b="1" i="0">
-                <a:solidFill>
-                  <a:srgbClr val="F47321"/>
-                </a:solidFill>
-                <a:latin typeface="Arial"/>
-              </a:rPr>
-              <a:t>3.9 pts on Hawai'i</a:t>
-            </a:r>
-          </a:p>
-        </p:txBody>
-      </p:sp>
-      <p:sp>
-        <p:nvSpPr>
-          <p:cNvPr id="25" name="TextBox 24"/>
-          <p:cNvSpPr txBox="1"/>
-          <p:nvPr/>
-        </p:nvSpPr>
-        <p:spPr>
-          <a:xfrm>
-            <a:off x="8046720" y="4370832"/>
-            <a:ext cx="3017520" cy="274320"/>
-          </a:xfrm>
-          <a:prstGeom prst="rect">
-            <a:avLst/>
-          </a:prstGeom>
-          <a:noFill/>
-        </p:spPr>
-        <p:txBody>
-          <a:bodyPr wrap="square" lIns="0" rIns="0" tIns="0" bIns="0">
-            <a:spAutoFit/>
-          </a:bodyPr>
-          <a:lstStyle/>
-          <a:p>
-            <a:pPr algn="l"/>
-            <a:r>
-              <a:rPr sz="1000" b="0" i="0">
-                <a:solidFill>
-                  <a:srgbClr val="CADCFC"/>
-                </a:solidFill>
-                <a:latin typeface="Arial"/>
-              </a:rPr>
               <a:t>the gap</a:t>
             </a:r>
           </a:p>
@@ -16287,14 +16812,14 @@
       </p:sp>
       <p:sp>
         <p:nvSpPr>
-          <p:cNvPr id="26" name="Rounded Rectangle 25"/>
+          <p:cNvPr id="29" name="Rounded Rectangle 28"/>
           <p:cNvSpPr/>
           <p:nvPr/>
         </p:nvSpPr>
         <p:spPr>
           <a:xfrm>
-            <a:off x="8046720" y="4892040"/>
-            <a:ext cx="3017520" cy="384048"/>
+            <a:off x="8046720" y="4882896"/>
+            <a:ext cx="3017520" cy="365760"/>
           </a:xfrm>
           <a:prstGeom prst="roundRect">
             <a:avLst/>
@@ -16331,14 +16856,14 @@
       </p:sp>
       <p:sp>
         <p:nvSpPr>
-          <p:cNvPr id="27" name="Rounded Rectangle 26"/>
+          <p:cNvPr id="30" name="Rounded Rectangle 29"/>
           <p:cNvSpPr/>
           <p:nvPr/>
         </p:nvSpPr>
         <p:spPr>
           <a:xfrm>
-            <a:off x="8046720" y="4892040"/>
-            <a:ext cx="1629460" cy="384048"/>
+            <a:off x="8046720" y="4882896"/>
+            <a:ext cx="1629460" cy="365760"/>
           </a:xfrm>
           <a:prstGeom prst="roundRect">
             <a:avLst/>
@@ -16375,13 +16900,13 @@
       </p:sp>
       <p:sp>
         <p:nvSpPr>
-          <p:cNvPr id="28" name="TextBox 27"/>
-          <p:cNvSpPr txBox="1"/>
-          <p:nvPr/>
-        </p:nvSpPr>
-        <p:spPr>
-          <a:xfrm>
-            <a:off x="8119872" y="4983479"/>
+          <p:cNvPr id="31" name="TextBox 30"/>
+          <p:cNvSpPr txBox="1"/>
+          <p:nvPr/>
+        </p:nvSpPr>
+        <p:spPr>
+          <a:xfrm>
+            <a:off x="8119872" y="4965192"/>
             <a:ext cx="2194560" cy="228600"/>
           </a:xfrm>
           <a:prstGeom prst="rect">
@@ -16410,13 +16935,13 @@
       </p:sp>
       <p:sp>
         <p:nvSpPr>
-          <p:cNvPr id="29" name="TextBox 28"/>
-          <p:cNvSpPr txBox="1"/>
-          <p:nvPr/>
-        </p:nvSpPr>
-        <p:spPr>
-          <a:xfrm>
-            <a:off x="8796528" y="4983479"/>
+          <p:cNvPr id="32" name="TextBox 31"/>
+          <p:cNvSpPr txBox="1"/>
+          <p:nvPr/>
+        </p:nvSpPr>
+        <p:spPr>
+          <a:xfrm>
+            <a:off x="8796528" y="4965192"/>
             <a:ext cx="2194560" cy="228600"/>
           </a:xfrm>
           <a:prstGeom prst="rect">
@@ -16445,13 +16970,48 @@
       </p:sp>
       <p:sp>
         <p:nvSpPr>
-          <p:cNvPr id="30" name="TextBox 29"/>
-          <p:cNvSpPr txBox="1"/>
-          <p:nvPr/>
-        </p:nvSpPr>
-        <p:spPr>
-          <a:xfrm>
-            <a:off x="8046720" y="5349240"/>
+          <p:cNvPr id="33" name="TextBox 32"/>
+          <p:cNvSpPr txBox="1"/>
+          <p:nvPr/>
+        </p:nvSpPr>
+        <p:spPr>
+          <a:xfrm>
+            <a:off x="8046720" y="5303520"/>
+            <a:ext cx="3017520" cy="228600"/>
+          </a:xfrm>
+          <a:prstGeom prst="rect">
+            <a:avLst/>
+          </a:prstGeom>
+          <a:noFill/>
+        </p:spPr>
+        <p:txBody>
+          <a:bodyPr wrap="square" lIns="0" rIns="0" tIns="0" bIns="0">
+            <a:spAutoFit/>
+          </a:bodyPr>
+          <a:lstStyle/>
+          <a:p>
+            <a:pPr algn="l"/>
+            <a:r>
+              <a:rPr sz="850" b="0" i="0">
+                <a:solidFill>
+                  <a:srgbClr val="CADCFC"/>
+                </a:solidFill>
+                <a:latin typeface="Arial"/>
+              </a:rPr>
+              <a:t>win probability (machine)</a:t>
+            </a:r>
+          </a:p>
+        </p:txBody>
+      </p:sp>
+      <p:sp>
+        <p:nvSpPr>
+          <p:cNvPr id="34" name="TextBox 33"/>
+          <p:cNvSpPr txBox="1"/>
+          <p:nvPr/>
+        </p:nvSpPr>
+        <p:spPr>
+          <a:xfrm>
+            <a:off x="8046720" y="5550408"/>
             <a:ext cx="3017520" cy="274320"/>
           </a:xfrm>
           <a:prstGeom prst="rect">
@@ -16467,41 +17027,6 @@
           <a:p>
             <a:pPr algn="l"/>
             <a:r>
-              <a:rPr sz="950" b="0" i="0">
-                <a:solidFill>
-                  <a:srgbClr val="CADCFC"/>
-                </a:solidFill>
-                <a:latin typeface="Arial"/>
-              </a:rPr>
-              <a:t>win probability (machine)</a:t>
-            </a:r>
-          </a:p>
-        </p:txBody>
-      </p:sp>
-      <p:sp>
-        <p:nvSpPr>
-          <p:cNvPr id="31" name="TextBox 30"/>
-          <p:cNvSpPr txBox="1"/>
-          <p:nvPr/>
-        </p:nvSpPr>
-        <p:spPr>
-          <a:xfrm>
-            <a:off x="8046720" y="5532120"/>
-            <a:ext cx="3017520" cy="274320"/>
-          </a:xfrm>
-          <a:prstGeom prst="rect">
-            <a:avLst/>
-          </a:prstGeom>
-          <a:noFill/>
-        </p:spPr>
-        <p:txBody>
-          <a:bodyPr wrap="square" lIns="0" rIns="0" tIns="0" bIns="0">
-            <a:spAutoFit/>
-          </a:bodyPr>
-          <a:lstStyle/>
-          <a:p>
-            <a:pPr algn="l"/>
-            <a:r>
               <a:rPr sz="950" b="1" i="0">
                 <a:solidFill>
                   <a:srgbClr val="F47321"/>
@@ -16515,7 +17040,7 @@
       </p:sp>
       <p:sp>
         <p:nvSpPr>
-          <p:cNvPr id="32" name="TextBox 31"/>
+          <p:cNvPr id="35" name="TextBox 34"/>
           <p:cNvSpPr txBox="1"/>
           <p:nvPr/>
         </p:nvSpPr>
@@ -16550,7 +17075,7 @@
       </p:sp>
       <p:sp>
         <p:nvSpPr>
-          <p:cNvPr id="33" name="TextBox 32"/>
+          <p:cNvPr id="36" name="TextBox 35"/>
           <p:cNvSpPr txBox="1"/>
           <p:nvPr/>
         </p:nvSpPr>

</xml_diff>

<commit_message>
Week 0 qualitative overlay (review D) + NDSU title-eligibility correction
- cards/week1_flags.json: 41 sourced flags (coaching/qb_tier/injury/
  suspension/arrest/roster) for the ten Week 0 teams; week0_ep1_background.md
  is the dated, linked research doc behind them.
- Deck renders up to 3 flags per team under the player panels (displayed,
  not priced). Pribula named-starter date corrected to Jul 15.
- TITLE_INELIGIBLE emptied: the NCAA D-I Cabinet repealed the two-year
  FCS->FBS postseason penalty on 2026-06-24; NDSU and Sac State are eligible
  for the MWC/MAC title games, bowls and the CFP (InForum, Valley News Live).
  Mechanism kept; legend now conditional.

Co-Authored-By: Claude Fable 5 <noreply@anthropic.com>
</commit_message>
<xml_diff>
--- a/decks/2026_Week0_Episode1.pptx
+++ b/decks/2026_Week0_Episode1.pptx
@@ -6266,7 +6266,7 @@
         <p:spPr>
           <a:xfrm>
             <a:off x="822960" y="1417320"/>
-            <a:ext cx="5166360" cy="4754880"/>
+            <a:ext cx="5166360" cy="5029200"/>
           </a:xfrm>
           <a:prstGeom prst="roundRect">
             <a:avLst/>
@@ -6473,7 +6473,7 @@
         </p:nvSpPr>
         <p:spPr>
           <a:xfrm>
-            <a:off x="1143000" y="3410712"/>
+            <a:off x="1143000" y="3282696"/>
             <a:ext cx="4572000" cy="320040"/>
           </a:xfrm>
           <a:prstGeom prst="rect">
@@ -6508,7 +6508,7 @@
         </p:nvSpPr>
         <p:spPr>
           <a:xfrm>
-            <a:off x="1143000" y="3721608"/>
+            <a:off x="1143000" y="3593591"/>
             <a:ext cx="4572000" cy="502920"/>
           </a:xfrm>
           <a:prstGeom prst="rect">
@@ -6543,7 +6543,7 @@
         </p:nvSpPr>
         <p:spPr>
           <a:xfrm>
-            <a:off x="1143000" y="4306824"/>
+            <a:off x="1143000" y="4050791"/>
             <a:ext cx="4572000" cy="320040"/>
           </a:xfrm>
           <a:prstGeom prst="rect">
@@ -6578,7 +6578,7 @@
         </p:nvSpPr>
         <p:spPr>
           <a:xfrm>
-            <a:off x="1143000" y="4617720"/>
+            <a:off x="1143000" y="4361688"/>
             <a:ext cx="4572000" cy="502920"/>
           </a:xfrm>
           <a:prstGeom prst="rect">
@@ -6613,7 +6613,7 @@
         </p:nvSpPr>
         <p:spPr>
           <a:xfrm>
-            <a:off x="1143000" y="5202936"/>
+            <a:off x="1143000" y="4818888"/>
             <a:ext cx="4572000" cy="320040"/>
           </a:xfrm>
           <a:prstGeom prst="rect">
@@ -6648,7 +6648,7 @@
         </p:nvSpPr>
         <p:spPr>
           <a:xfrm>
-            <a:off x="1143000" y="5513831"/>
+            <a:off x="1143000" y="5129783"/>
             <a:ext cx="4572000" cy="502920"/>
           </a:xfrm>
           <a:prstGeom prst="rect">
@@ -6677,14 +6677,93 @@
       </p:sp>
       <p:sp>
         <p:nvSpPr>
-          <p:cNvPr id="18" name="Rounded Rectangle 17"/>
+          <p:cNvPr id="18" name="Rectangle 17"/>
           <p:cNvSpPr/>
           <p:nvPr/>
         </p:nvSpPr>
         <p:spPr>
           <a:xfrm>
+            <a:off x="1143000" y="5605271"/>
+            <a:ext cx="4572000" cy="10972"/>
+          </a:xfrm>
+          <a:prstGeom prst="rect">
+            <a:avLst/>
+          </a:prstGeom>
+          <a:solidFill>
+            <a:srgbClr val="F47321"/>
+          </a:solidFill>
+          <a:ln>
+            <a:noFill/>
+          </a:ln>
+          <a:effectLst/>
+        </p:spPr>
+        <p:style>
+          <a:lnRef idx="1">
+            <a:schemeClr val="accent1"/>
+          </a:lnRef>
+          <a:fillRef idx="3">
+            <a:schemeClr val="accent1"/>
+          </a:fillRef>
+          <a:effectRef idx="2">
+            <a:schemeClr val="accent1"/>
+          </a:effectRef>
+          <a:fontRef idx="minor">
+            <a:schemeClr val="lt1"/>
+          </a:fontRef>
+        </p:style>
+        <p:txBody>
+          <a:bodyPr rtlCol="0" anchor="ctr"/>
+          <a:lstStyle/>
+          <a:p>
+            <a:pPr algn="ctr"/>
+          </a:p>
+        </p:txBody>
+      </p:sp>
+      <p:sp>
+        <p:nvSpPr>
+          <p:cNvPr id="19" name="TextBox 18"/>
+          <p:cNvSpPr txBox="1"/>
+          <p:nvPr/>
+        </p:nvSpPr>
+        <p:spPr>
+          <a:xfrm>
+            <a:off x="1143000" y="5650992"/>
+            <a:ext cx="4572000" cy="640080"/>
+          </a:xfrm>
+          <a:prstGeom prst="rect">
+            <a:avLst/>
+          </a:prstGeom>
+          <a:noFill/>
+        </p:spPr>
+        <p:txBody>
+          <a:bodyPr wrap="square" lIns="0" rIns="0" tIns="0" bIns="0">
+            <a:spAutoFit/>
+          </a:bodyPr>
+          <a:lstStyle/>
+          <a:p>
+            <a:pPr algn="l"/>
+            <a:r>
+              <a:rPr sz="950" b="1" i="0">
+                <a:solidFill>
+                  <a:srgbClr val="B64F0F"/>
+                </a:solidFill>
+                <a:latin typeface="Arial"/>
+              </a:rPr>
+              <a:t>FLAGS  Huff picks Stokes vs Noland internally Aug 23 but won't announce until kickoff · Charles Huff's first game as Memphis HC (hired Dec 8, 2025); 75 new players</a:t>
+            </a:r>
+          </a:p>
+        </p:txBody>
+      </p:sp>
+      <p:sp>
+        <p:nvSpPr>
+          <p:cNvPr id="20" name="Rounded Rectangle 19"/>
+          <p:cNvSpPr/>
+          <p:nvPr/>
+        </p:nvSpPr>
+        <p:spPr>
+          <a:xfrm>
             <a:off x="6309360" y="1417320"/>
-            <a:ext cx="5166360" cy="4754880"/>
+            <a:ext cx="5166360" cy="5029200"/>
           </a:xfrm>
           <a:prstGeom prst="roundRect">
             <a:avLst/>
@@ -6721,7 +6800,7 @@
       </p:sp>
       <p:pic>
         <p:nvPicPr>
-          <p:cNvPr id="19" name="Picture 18" descr="unlv.png"/>
+          <p:cNvPr id="21" name="Picture 20" descr="unlv.png"/>
           <p:cNvPicPr>
             <a:picLocks noChangeAspect="1"/>
           </p:cNvPicPr>
@@ -6745,7 +6824,7 @@
       </p:pic>
       <p:sp>
         <p:nvSpPr>
-          <p:cNvPr id="20" name="TextBox 19"/>
+          <p:cNvPr id="22" name="TextBox 21"/>
           <p:cNvSpPr txBox="1"/>
           <p:nvPr/>
         </p:nvSpPr>
@@ -6780,7 +6859,7 @@
       </p:sp>
       <p:sp>
         <p:nvSpPr>
-          <p:cNvPr id="21" name="TextBox 20"/>
+          <p:cNvPr id="23" name="TextBox 22"/>
           <p:cNvSpPr txBox="1"/>
           <p:nvPr/>
         </p:nvSpPr>
@@ -6815,7 +6894,7 @@
       </p:sp>
       <p:sp>
         <p:nvSpPr>
-          <p:cNvPr id="22" name="TextBox 21"/>
+          <p:cNvPr id="24" name="TextBox 23"/>
           <p:cNvSpPr txBox="1"/>
           <p:nvPr/>
         </p:nvSpPr>
@@ -6850,7 +6929,7 @@
       </p:sp>
       <p:sp>
         <p:nvSpPr>
-          <p:cNvPr id="23" name="TextBox 22"/>
+          <p:cNvPr id="25" name="TextBox 24"/>
           <p:cNvSpPr txBox="1"/>
           <p:nvPr/>
         </p:nvSpPr>
@@ -6885,13 +6964,13 @@
       </p:sp>
       <p:sp>
         <p:nvSpPr>
-          <p:cNvPr id="24" name="TextBox 23"/>
-          <p:cNvSpPr txBox="1"/>
-          <p:nvPr/>
-        </p:nvSpPr>
-        <p:spPr>
-          <a:xfrm>
-            <a:off x="6629400" y="3410712"/>
+          <p:cNvPr id="26" name="TextBox 25"/>
+          <p:cNvSpPr txBox="1"/>
+          <p:nvPr/>
+        </p:nvSpPr>
+        <p:spPr>
+          <a:xfrm>
+            <a:off x="6629400" y="3282696"/>
             <a:ext cx="4572000" cy="320040"/>
           </a:xfrm>
           <a:prstGeom prst="rect">
@@ -6920,13 +6999,13 @@
       </p:sp>
       <p:sp>
         <p:nvSpPr>
-          <p:cNvPr id="25" name="TextBox 24"/>
-          <p:cNvSpPr txBox="1"/>
-          <p:nvPr/>
-        </p:nvSpPr>
-        <p:spPr>
-          <a:xfrm>
-            <a:off x="6629400" y="3721608"/>
+          <p:cNvPr id="27" name="TextBox 26"/>
+          <p:cNvSpPr txBox="1"/>
+          <p:nvPr/>
+        </p:nvSpPr>
+        <p:spPr>
+          <a:xfrm>
+            <a:off x="6629400" y="3593591"/>
             <a:ext cx="4572000" cy="502920"/>
           </a:xfrm>
           <a:prstGeom prst="rect">
@@ -6955,13 +7034,13 @@
       </p:sp>
       <p:sp>
         <p:nvSpPr>
-          <p:cNvPr id="26" name="TextBox 25"/>
-          <p:cNvSpPr txBox="1"/>
-          <p:nvPr/>
-        </p:nvSpPr>
-        <p:spPr>
-          <a:xfrm>
-            <a:off x="6629400" y="4306824"/>
+          <p:cNvPr id="28" name="TextBox 27"/>
+          <p:cNvSpPr txBox="1"/>
+          <p:nvPr/>
+        </p:nvSpPr>
+        <p:spPr>
+          <a:xfrm>
+            <a:off x="6629400" y="4050791"/>
             <a:ext cx="4572000" cy="320040"/>
           </a:xfrm>
           <a:prstGeom prst="rect">
@@ -6990,13 +7069,13 @@
       </p:sp>
       <p:sp>
         <p:nvSpPr>
-          <p:cNvPr id="27" name="TextBox 26"/>
-          <p:cNvSpPr txBox="1"/>
-          <p:nvPr/>
-        </p:nvSpPr>
-        <p:spPr>
-          <a:xfrm>
-            <a:off x="6629400" y="4617720"/>
+          <p:cNvPr id="29" name="TextBox 28"/>
+          <p:cNvSpPr txBox="1"/>
+          <p:nvPr/>
+        </p:nvSpPr>
+        <p:spPr>
+          <a:xfrm>
+            <a:off x="6629400" y="4361688"/>
             <a:ext cx="4572000" cy="502920"/>
           </a:xfrm>
           <a:prstGeom prst="rect">
@@ -7025,13 +7104,13 @@
       </p:sp>
       <p:sp>
         <p:nvSpPr>
-          <p:cNvPr id="28" name="TextBox 27"/>
-          <p:cNvSpPr txBox="1"/>
-          <p:nvPr/>
-        </p:nvSpPr>
-        <p:spPr>
-          <a:xfrm>
-            <a:off x="6629400" y="5202936"/>
+          <p:cNvPr id="30" name="TextBox 29"/>
+          <p:cNvSpPr txBox="1"/>
+          <p:nvPr/>
+        </p:nvSpPr>
+        <p:spPr>
+          <a:xfrm>
+            <a:off x="6629400" y="4818888"/>
             <a:ext cx="4572000" cy="320040"/>
           </a:xfrm>
           <a:prstGeom prst="rect">
@@ -7060,13 +7139,13 @@
       </p:sp>
       <p:sp>
         <p:nvSpPr>
-          <p:cNvPr id="29" name="TextBox 28"/>
-          <p:cNvSpPr txBox="1"/>
-          <p:nvPr/>
-        </p:nvSpPr>
-        <p:spPr>
-          <a:xfrm>
-            <a:off x="6629400" y="5513831"/>
+          <p:cNvPr id="31" name="TextBox 30"/>
+          <p:cNvSpPr txBox="1"/>
+          <p:nvPr/>
+        </p:nvSpPr>
+        <p:spPr>
+          <a:xfrm>
+            <a:off x="6629400" y="5129783"/>
             <a:ext cx="4572000" cy="502920"/>
           </a:xfrm>
           <a:prstGeom prst="rect">
@@ -7095,29 +7174,108 @@
       </p:sp>
       <p:sp>
         <p:nvSpPr>
-          <p:cNvPr id="30" name="TextBox 29"/>
-          <p:cNvSpPr txBox="1"/>
-          <p:nvPr/>
-        </p:nvSpPr>
-        <p:spPr>
-          <a:xfrm>
-            <a:off x="822960" y="6355080"/>
-            <a:ext cx="10515600" cy="320040"/>
-          </a:xfrm>
-          <a:prstGeom prst="rect">
-            <a:avLst/>
-          </a:prstGeom>
-          <a:noFill/>
-        </p:spPr>
-        <p:txBody>
-          <a:bodyPr wrap="square" lIns="0" rIns="0" tIns="0" bIns="0">
-            <a:spAutoFit/>
-          </a:bodyPr>
-          <a:lstStyle/>
-          <a:p>
-            <a:pPr algn="l"/>
-            <a:r>
-              <a:rPr sz="950" b="0" i="0">
+          <p:cNvPr id="32" name="Rectangle 31"/>
+          <p:cNvSpPr/>
+          <p:nvPr/>
+        </p:nvSpPr>
+        <p:spPr>
+          <a:xfrm>
+            <a:off x="6629400" y="5605271"/>
+            <a:ext cx="4572000" cy="10972"/>
+          </a:xfrm>
+          <a:prstGeom prst="rect">
+            <a:avLst/>
+          </a:prstGeom>
+          <a:solidFill>
+            <a:srgbClr val="F47321"/>
+          </a:solidFill>
+          <a:ln>
+            <a:noFill/>
+          </a:ln>
+          <a:effectLst/>
+        </p:spPr>
+        <p:style>
+          <a:lnRef idx="1">
+            <a:schemeClr val="accent1"/>
+          </a:lnRef>
+          <a:fillRef idx="3">
+            <a:schemeClr val="accent1"/>
+          </a:fillRef>
+          <a:effectRef idx="2">
+            <a:schemeClr val="accent1"/>
+          </a:effectRef>
+          <a:fontRef idx="minor">
+            <a:schemeClr val="lt1"/>
+          </a:fontRef>
+        </p:style>
+        <p:txBody>
+          <a:bodyPr rtlCol="0" anchor="ctr"/>
+          <a:lstStyle/>
+          <a:p>
+            <a:pPr algn="ctr"/>
+          </a:p>
+        </p:txBody>
+      </p:sp>
+      <p:sp>
+        <p:nvSpPr>
+          <p:cNvPr id="33" name="TextBox 32"/>
+          <p:cNvSpPr txBox="1"/>
+          <p:nvPr/>
+        </p:nvSpPr>
+        <p:spPr>
+          <a:xfrm>
+            <a:off x="6629400" y="5650992"/>
+            <a:ext cx="4572000" cy="640080"/>
+          </a:xfrm>
+          <a:prstGeom prst="rect">
+            <a:avLst/>
+          </a:prstGeom>
+          <a:noFill/>
+        </p:spPr>
+        <p:txBody>
+          <a:bodyPr wrap="square" lIns="0" rIns="0" tIns="0" bIns="0">
+            <a:spAutoFit/>
+          </a:bodyPr>
+          <a:lstStyle/>
+          <a:p>
+            <a:pPr algn="l"/>
+            <a:r>
+              <a:rPr sz="950" b="1" i="0">
+                <a:solidFill>
+                  <a:srgbClr val="B64F0F"/>
+                </a:solidFill>
+                <a:latin typeface="Arial"/>
+              </a:rPr>
+              <a:t>FLAGS  Mullen: no starter named, Arnold and Orji may both play vs Memphis · DT Fuller, DB Welch, LB Spellman regained eligibility via Colorado ruling (NCAA appealing)</a:t>
+            </a:r>
+          </a:p>
+        </p:txBody>
+      </p:sp>
+      <p:sp>
+        <p:nvSpPr>
+          <p:cNvPr id="34" name="TextBox 33"/>
+          <p:cNvSpPr txBox="1"/>
+          <p:nvPr/>
+        </p:nvSpPr>
+        <p:spPr>
+          <a:xfrm>
+            <a:off x="822960" y="6519672"/>
+            <a:ext cx="10515600" cy="274320"/>
+          </a:xfrm>
+          <a:prstGeom prst="rect">
+            <a:avLst/>
+          </a:prstGeom>
+          <a:noFill/>
+        </p:spPr>
+        <p:txBody>
+          <a:bodyPr wrap="square" lIns="0" rIns="0" tIns="0" bIns="0">
+            <a:spAutoFit/>
+          </a:bodyPr>
+          <a:lstStyle/>
+          <a:p>
+            <a:pPr algn="l"/>
+            <a:r>
+              <a:rPr sz="900" b="0" i="0">
                 <a:solidFill>
                   <a:srgbClr val="5C6B7E"/>
                 </a:solidFill>
@@ -10313,7 +10471,7 @@
         <p:spPr>
           <a:xfrm>
             <a:off x="822960" y="1417320"/>
-            <a:ext cx="5166360" cy="4754880"/>
+            <a:ext cx="5166360" cy="5029200"/>
           </a:xfrm>
           <a:prstGeom prst="roundRect">
             <a:avLst/>
@@ -10520,7 +10678,7 @@
         </p:nvSpPr>
         <p:spPr>
           <a:xfrm>
-            <a:off x="1143000" y="3410712"/>
+            <a:off x="1143000" y="3282696"/>
             <a:ext cx="4572000" cy="320040"/>
           </a:xfrm>
           <a:prstGeom prst="rect">
@@ -10555,7 +10713,7 @@
         </p:nvSpPr>
         <p:spPr>
           <a:xfrm>
-            <a:off x="1143000" y="3721608"/>
+            <a:off x="1143000" y="3593591"/>
             <a:ext cx="4572000" cy="502920"/>
           </a:xfrm>
           <a:prstGeom prst="rect">
@@ -10590,7 +10748,7 @@
         </p:nvSpPr>
         <p:spPr>
           <a:xfrm>
-            <a:off x="1143000" y="4306824"/>
+            <a:off x="1143000" y="4050791"/>
             <a:ext cx="4572000" cy="320040"/>
           </a:xfrm>
           <a:prstGeom prst="rect">
@@ -10625,7 +10783,7 @@
         </p:nvSpPr>
         <p:spPr>
           <a:xfrm>
-            <a:off x="1143000" y="4617720"/>
+            <a:off x="1143000" y="4361688"/>
             <a:ext cx="4572000" cy="502920"/>
           </a:xfrm>
           <a:prstGeom prst="rect">
@@ -10660,7 +10818,7 @@
         </p:nvSpPr>
         <p:spPr>
           <a:xfrm>
-            <a:off x="1143000" y="5202936"/>
+            <a:off x="1143000" y="4818888"/>
             <a:ext cx="4572000" cy="320040"/>
           </a:xfrm>
           <a:prstGeom prst="rect">
@@ -10695,7 +10853,7 @@
         </p:nvSpPr>
         <p:spPr>
           <a:xfrm>
-            <a:off x="1143000" y="5513831"/>
+            <a:off x="1143000" y="5129783"/>
             <a:ext cx="4572000" cy="502920"/>
           </a:xfrm>
           <a:prstGeom prst="rect">
@@ -10724,14 +10882,93 @@
       </p:sp>
       <p:sp>
         <p:nvSpPr>
-          <p:cNvPr id="18" name="Rounded Rectangle 17"/>
+          <p:cNvPr id="18" name="Rectangle 17"/>
           <p:cNvSpPr/>
           <p:nvPr/>
         </p:nvSpPr>
         <p:spPr>
           <a:xfrm>
+            <a:off x="1143000" y="5605271"/>
+            <a:ext cx="4572000" cy="10972"/>
+          </a:xfrm>
+          <a:prstGeom prst="rect">
+            <a:avLst/>
+          </a:prstGeom>
+          <a:solidFill>
+            <a:srgbClr val="F47321"/>
+          </a:solidFill>
+          <a:ln>
+            <a:noFill/>
+          </a:ln>
+          <a:effectLst/>
+        </p:spPr>
+        <p:style>
+          <a:lnRef idx="1">
+            <a:schemeClr val="accent1"/>
+          </a:lnRef>
+          <a:fillRef idx="3">
+            <a:schemeClr val="accent1"/>
+          </a:fillRef>
+          <a:effectRef idx="2">
+            <a:schemeClr val="accent1"/>
+          </a:effectRef>
+          <a:fontRef idx="minor">
+            <a:schemeClr val="lt1"/>
+          </a:fontRef>
+        </p:style>
+        <p:txBody>
+          <a:bodyPr rtlCol="0" anchor="ctr"/>
+          <a:lstStyle/>
+          <a:p>
+            <a:pPr algn="ctr"/>
+          </a:p>
+        </p:txBody>
+      </p:sp>
+      <p:sp>
+        <p:nvSpPr>
+          <p:cNvPr id="19" name="TextBox 18"/>
+          <p:cNvSpPr txBox="1"/>
+          <p:nvPr/>
+        </p:nvSpPr>
+        <p:spPr>
+          <a:xfrm>
+            <a:off x="1143000" y="5650992"/>
+            <a:ext cx="4572000" cy="640080"/>
+          </a:xfrm>
+          <a:prstGeom prst="rect">
+            <a:avLst/>
+          </a:prstGeom>
+          <a:noFill/>
+        </p:spPr>
+        <p:txBody>
+          <a:bodyPr wrap="square" lIns="0" rIns="0" tIns="0" bIns="0">
+            <a:spAutoFit/>
+          </a:bodyPr>
+          <a:lstStyle/>
+          <a:p>
+            <a:pPr algn="l"/>
+            <a:r>
+              <a:rPr sz="950" b="1" i="0">
+                <a:solidFill>
+                  <a:srgbClr val="B64F0F"/>
+                </a:solidFill>
+                <a:latin typeface="Arial"/>
+              </a:rPr>
+              <a:t>FLAGS  DC Steve Belichick on indefinite medical leave since Aug 6; no return timeline · No interim DC named; Belichick says defense coached 'collectively' - play-caller unknown · GM Michael Lombardi on paid admin leave since Jul 27 (HR complaint); open-ended</a:t>
+            </a:r>
+          </a:p>
+        </p:txBody>
+      </p:sp>
+      <p:sp>
+        <p:nvSpPr>
+          <p:cNvPr id="20" name="Rounded Rectangle 19"/>
+          <p:cNvSpPr/>
+          <p:nvPr/>
+        </p:nvSpPr>
+        <p:spPr>
+          <a:xfrm>
             <a:off x="6309360" y="1417320"/>
-            <a:ext cx="5166360" cy="4754880"/>
+            <a:ext cx="5166360" cy="5029200"/>
           </a:xfrm>
           <a:prstGeom prst="roundRect">
             <a:avLst/>
@@ -10768,7 +11005,7 @@
       </p:sp>
       <p:pic>
         <p:nvPicPr>
-          <p:cNvPr id="19" name="Picture 18" descr="tcu.png"/>
+          <p:cNvPr id="21" name="Picture 20" descr="tcu.png"/>
           <p:cNvPicPr>
             <a:picLocks noChangeAspect="1"/>
           </p:cNvPicPr>
@@ -10792,7 +11029,7 @@
       </p:pic>
       <p:sp>
         <p:nvSpPr>
-          <p:cNvPr id="20" name="TextBox 19"/>
+          <p:cNvPr id="22" name="TextBox 21"/>
           <p:cNvSpPr txBox="1"/>
           <p:nvPr/>
         </p:nvSpPr>
@@ -10827,7 +11064,7 @@
       </p:sp>
       <p:sp>
         <p:nvSpPr>
-          <p:cNvPr id="21" name="TextBox 20"/>
+          <p:cNvPr id="23" name="TextBox 22"/>
           <p:cNvSpPr txBox="1"/>
           <p:nvPr/>
         </p:nvSpPr>
@@ -10862,7 +11099,7 @@
       </p:sp>
       <p:sp>
         <p:nvSpPr>
-          <p:cNvPr id="22" name="TextBox 21"/>
+          <p:cNvPr id="24" name="TextBox 23"/>
           <p:cNvSpPr txBox="1"/>
           <p:nvPr/>
         </p:nvSpPr>
@@ -10897,7 +11134,7 @@
       </p:sp>
       <p:sp>
         <p:nvSpPr>
-          <p:cNvPr id="23" name="TextBox 22"/>
+          <p:cNvPr id="25" name="TextBox 24"/>
           <p:cNvSpPr txBox="1"/>
           <p:nvPr/>
         </p:nvSpPr>
@@ -10932,13 +11169,13 @@
       </p:sp>
       <p:sp>
         <p:nvSpPr>
-          <p:cNvPr id="24" name="TextBox 23"/>
-          <p:cNvSpPr txBox="1"/>
-          <p:nvPr/>
-        </p:nvSpPr>
-        <p:spPr>
-          <a:xfrm>
-            <a:off x="6629400" y="3410712"/>
+          <p:cNvPr id="26" name="TextBox 25"/>
+          <p:cNvSpPr txBox="1"/>
+          <p:nvPr/>
+        </p:nvSpPr>
+        <p:spPr>
+          <a:xfrm>
+            <a:off x="6629400" y="3282696"/>
             <a:ext cx="4572000" cy="320040"/>
           </a:xfrm>
           <a:prstGeom prst="rect">
@@ -10967,13 +11204,13 @@
       </p:sp>
       <p:sp>
         <p:nvSpPr>
-          <p:cNvPr id="25" name="TextBox 24"/>
-          <p:cNvSpPr txBox="1"/>
-          <p:nvPr/>
-        </p:nvSpPr>
-        <p:spPr>
-          <a:xfrm>
-            <a:off x="6629400" y="3721608"/>
+          <p:cNvPr id="27" name="TextBox 26"/>
+          <p:cNvSpPr txBox="1"/>
+          <p:nvPr/>
+        </p:nvSpPr>
+        <p:spPr>
+          <a:xfrm>
+            <a:off x="6629400" y="3593591"/>
             <a:ext cx="4572000" cy="502920"/>
           </a:xfrm>
           <a:prstGeom prst="rect">
@@ -11002,13 +11239,13 @@
       </p:sp>
       <p:sp>
         <p:nvSpPr>
-          <p:cNvPr id="26" name="TextBox 25"/>
-          <p:cNvSpPr txBox="1"/>
-          <p:nvPr/>
-        </p:nvSpPr>
-        <p:spPr>
-          <a:xfrm>
-            <a:off x="6629400" y="4306824"/>
+          <p:cNvPr id="28" name="TextBox 27"/>
+          <p:cNvSpPr txBox="1"/>
+          <p:nvPr/>
+        </p:nvSpPr>
+        <p:spPr>
+          <a:xfrm>
+            <a:off x="6629400" y="4050791"/>
             <a:ext cx="4572000" cy="320040"/>
           </a:xfrm>
           <a:prstGeom prst="rect">
@@ -11037,13 +11274,13 @@
       </p:sp>
       <p:sp>
         <p:nvSpPr>
-          <p:cNvPr id="27" name="TextBox 26"/>
-          <p:cNvSpPr txBox="1"/>
-          <p:nvPr/>
-        </p:nvSpPr>
-        <p:spPr>
-          <a:xfrm>
-            <a:off x="6629400" y="4617720"/>
+          <p:cNvPr id="29" name="TextBox 28"/>
+          <p:cNvSpPr txBox="1"/>
+          <p:nvPr/>
+        </p:nvSpPr>
+        <p:spPr>
+          <a:xfrm>
+            <a:off x="6629400" y="4361688"/>
             <a:ext cx="4572000" cy="502920"/>
           </a:xfrm>
           <a:prstGeom prst="rect">
@@ -11072,13 +11309,13 @@
       </p:sp>
       <p:sp>
         <p:nvSpPr>
-          <p:cNvPr id="28" name="TextBox 27"/>
-          <p:cNvSpPr txBox="1"/>
-          <p:nvPr/>
-        </p:nvSpPr>
-        <p:spPr>
-          <a:xfrm>
-            <a:off x="6629400" y="5202936"/>
+          <p:cNvPr id="30" name="TextBox 29"/>
+          <p:cNvSpPr txBox="1"/>
+          <p:nvPr/>
+        </p:nvSpPr>
+        <p:spPr>
+          <a:xfrm>
+            <a:off x="6629400" y="4818888"/>
             <a:ext cx="4572000" cy="320040"/>
           </a:xfrm>
           <a:prstGeom prst="rect">
@@ -11107,13 +11344,13 @@
       </p:sp>
       <p:sp>
         <p:nvSpPr>
-          <p:cNvPr id="29" name="TextBox 28"/>
-          <p:cNvSpPr txBox="1"/>
-          <p:nvPr/>
-        </p:nvSpPr>
-        <p:spPr>
-          <a:xfrm>
-            <a:off x="6629400" y="5513831"/>
+          <p:cNvPr id="31" name="TextBox 30"/>
+          <p:cNvSpPr txBox="1"/>
+          <p:nvPr/>
+        </p:nvSpPr>
+        <p:spPr>
+          <a:xfrm>
+            <a:off x="6629400" y="5129783"/>
             <a:ext cx="4572000" cy="502920"/>
           </a:xfrm>
           <a:prstGeom prst="rect">
@@ -11142,29 +11379,108 @@
       </p:sp>
       <p:sp>
         <p:nvSpPr>
-          <p:cNvPr id="30" name="TextBox 29"/>
-          <p:cNvSpPr txBox="1"/>
-          <p:nvPr/>
-        </p:nvSpPr>
-        <p:spPr>
-          <a:xfrm>
-            <a:off x="822960" y="6355080"/>
-            <a:ext cx="10515600" cy="320040"/>
-          </a:xfrm>
-          <a:prstGeom prst="rect">
-            <a:avLst/>
-          </a:prstGeom>
-          <a:noFill/>
-        </p:spPr>
-        <p:txBody>
-          <a:bodyPr wrap="square" lIns="0" rIns="0" tIns="0" bIns="0">
-            <a:spAutoFit/>
-          </a:bodyPr>
-          <a:lstStyle/>
-          <a:p>
-            <a:pPr algn="l"/>
-            <a:r>
-              <a:rPr sz="950" b="0" i="0">
+          <p:cNvPr id="32" name="Rectangle 31"/>
+          <p:cNvSpPr/>
+          <p:nvPr/>
+        </p:nvSpPr>
+        <p:spPr>
+          <a:xfrm>
+            <a:off x="6629400" y="5605271"/>
+            <a:ext cx="4572000" cy="10972"/>
+          </a:xfrm>
+          <a:prstGeom prst="rect">
+            <a:avLst/>
+          </a:prstGeom>
+          <a:solidFill>
+            <a:srgbClr val="F47321"/>
+          </a:solidFill>
+          <a:ln>
+            <a:noFill/>
+          </a:ln>
+          <a:effectLst/>
+        </p:spPr>
+        <p:style>
+          <a:lnRef idx="1">
+            <a:schemeClr val="accent1"/>
+          </a:lnRef>
+          <a:fillRef idx="3">
+            <a:schemeClr val="accent1"/>
+          </a:fillRef>
+          <a:effectRef idx="2">
+            <a:schemeClr val="accent1"/>
+          </a:effectRef>
+          <a:fontRef idx="minor">
+            <a:schemeClr val="lt1"/>
+          </a:fontRef>
+        </p:style>
+        <p:txBody>
+          <a:bodyPr rtlCol="0" anchor="ctr"/>
+          <a:lstStyle/>
+          <a:p>
+            <a:pPr algn="ctr"/>
+          </a:p>
+        </p:txBody>
+      </p:sp>
+      <p:sp>
+        <p:nvSpPr>
+          <p:cNvPr id="33" name="TextBox 32"/>
+          <p:cNvSpPr txBox="1"/>
+          <p:nvPr/>
+        </p:nvSpPr>
+        <p:spPr>
+          <a:xfrm>
+            <a:off x="6629400" y="5650992"/>
+            <a:ext cx="4572000" cy="640080"/>
+          </a:xfrm>
+          <a:prstGeom prst="rect">
+            <a:avLst/>
+          </a:prstGeom>
+          <a:noFill/>
+        </p:spPr>
+        <p:txBody>
+          <a:bodyPr wrap="square" lIns="0" rIns="0" tIns="0" bIns="0">
+            <a:spAutoFit/>
+          </a:bodyPr>
+          <a:lstStyle/>
+          <a:p>
+            <a:pPr algn="l"/>
+            <a:r>
+              <a:rPr sz="950" b="1" i="0">
+                <a:solidFill>
+                  <a:srgbClr val="B64F0F"/>
+                </a:solidFill>
+                <a:latin typeface="Arial"/>
+              </a:rPr>
+              <a:t>FLAGS  Jaden Craig (Harvard, 0 FBS snaps) is working QB1; no formal Dykes announcement found · Projected starting S Jacob Fields dismissed Aug 18 (locker-room altercation Aug 13) · Jamel Johnson (5 INT in 2025) takes bigger safety role after Fields dismissal</a:t>
+            </a:r>
+          </a:p>
+        </p:txBody>
+      </p:sp>
+      <p:sp>
+        <p:nvSpPr>
+          <p:cNvPr id="34" name="TextBox 33"/>
+          <p:cNvSpPr txBox="1"/>
+          <p:nvPr/>
+        </p:nvSpPr>
+        <p:spPr>
+          <a:xfrm>
+            <a:off x="822960" y="6519672"/>
+            <a:ext cx="10515600" cy="274320"/>
+          </a:xfrm>
+          <a:prstGeom prst="rect">
+            <a:avLst/>
+          </a:prstGeom>
+          <a:noFill/>
+        </p:spPr>
+        <p:txBody>
+          <a:bodyPr wrap="square" lIns="0" rIns="0" tIns="0" bIns="0">
+            <a:spAutoFit/>
+          </a:bodyPr>
+          <a:lstStyle/>
+          <a:p>
+            <a:pPr algn="l"/>
+            <a:r>
+              <a:rPr sz="900" b="0" i="0">
                 <a:solidFill>
                   <a:srgbClr val="5C6B7E"/>
                 </a:solidFill>
@@ -12629,7 +12945,7 @@
         <p:spPr>
           <a:xfrm>
             <a:off x="822960" y="1417320"/>
-            <a:ext cx="5166360" cy="4754880"/>
+            <a:ext cx="5166360" cy="5029200"/>
           </a:xfrm>
           <a:prstGeom prst="roundRect">
             <a:avLst/>
@@ -12836,7 +13152,7 @@
         </p:nvSpPr>
         <p:spPr>
           <a:xfrm>
-            <a:off x="1143000" y="3410712"/>
+            <a:off x="1143000" y="3282696"/>
             <a:ext cx="4572000" cy="320040"/>
           </a:xfrm>
           <a:prstGeom prst="rect">
@@ -12871,7 +13187,7 @@
         </p:nvSpPr>
         <p:spPr>
           <a:xfrm>
-            <a:off x="1143000" y="3721608"/>
+            <a:off x="1143000" y="3593591"/>
             <a:ext cx="4572000" cy="502920"/>
           </a:xfrm>
           <a:prstGeom prst="rect">
@@ -12906,7 +13222,7 @@
         </p:nvSpPr>
         <p:spPr>
           <a:xfrm>
-            <a:off x="1143000" y="4306824"/>
+            <a:off x="1143000" y="4050791"/>
             <a:ext cx="4572000" cy="320040"/>
           </a:xfrm>
           <a:prstGeom prst="rect">
@@ -12941,7 +13257,7 @@
         </p:nvSpPr>
         <p:spPr>
           <a:xfrm>
-            <a:off x="1143000" y="4617720"/>
+            <a:off x="1143000" y="4361688"/>
             <a:ext cx="4572000" cy="502920"/>
           </a:xfrm>
           <a:prstGeom prst="rect">
@@ -12976,7 +13292,7 @@
         </p:nvSpPr>
         <p:spPr>
           <a:xfrm>
-            <a:off x="1143000" y="5202936"/>
+            <a:off x="1143000" y="4818888"/>
             <a:ext cx="4572000" cy="320040"/>
           </a:xfrm>
           <a:prstGeom prst="rect">
@@ -13011,7 +13327,7 @@
         </p:nvSpPr>
         <p:spPr>
           <a:xfrm>
-            <a:off x="1143000" y="5513831"/>
+            <a:off x="1143000" y="5129783"/>
             <a:ext cx="4572000" cy="502920"/>
           </a:xfrm>
           <a:prstGeom prst="rect">
@@ -13040,14 +13356,93 @@
       </p:sp>
       <p:sp>
         <p:nvSpPr>
-          <p:cNvPr id="18" name="Rounded Rectangle 17"/>
+          <p:cNvPr id="18" name="Rectangle 17"/>
           <p:cNvSpPr/>
           <p:nvPr/>
         </p:nvSpPr>
         <p:spPr>
           <a:xfrm>
+            <a:off x="1143000" y="5605271"/>
+            <a:ext cx="4572000" cy="10972"/>
+          </a:xfrm>
+          <a:prstGeom prst="rect">
+            <a:avLst/>
+          </a:prstGeom>
+          <a:solidFill>
+            <a:srgbClr val="F47321"/>
+          </a:solidFill>
+          <a:ln>
+            <a:noFill/>
+          </a:ln>
+          <a:effectLst/>
+        </p:spPr>
+        <p:style>
+          <a:lnRef idx="1">
+            <a:schemeClr val="accent1"/>
+          </a:lnRef>
+          <a:fillRef idx="3">
+            <a:schemeClr val="accent1"/>
+          </a:fillRef>
+          <a:effectRef idx="2">
+            <a:schemeClr val="accent1"/>
+          </a:effectRef>
+          <a:fontRef idx="minor">
+            <a:schemeClr val="lt1"/>
+          </a:fontRef>
+        </p:style>
+        <p:txBody>
+          <a:bodyPr rtlCol="0" anchor="ctr"/>
+          <a:lstStyle/>
+          <a:p>
+            <a:pPr algn="ctr"/>
+          </a:p>
+        </p:txBody>
+      </p:sp>
+      <p:sp>
+        <p:nvSpPr>
+          <p:cNvPr id="19" name="TextBox 18"/>
+          <p:cNvSpPr txBox="1"/>
+          <p:nvPr/>
+        </p:nvSpPr>
+        <p:spPr>
+          <a:xfrm>
+            <a:off x="1143000" y="5650992"/>
+            <a:ext cx="4572000" cy="640080"/>
+          </a:xfrm>
+          <a:prstGeom prst="rect">
+            <a:avLst/>
+          </a:prstGeom>
+          <a:noFill/>
+        </p:spPr>
+        <p:txBody>
+          <a:bodyPr wrap="square" lIns="0" rIns="0" tIns="0" bIns="0">
+            <a:spAutoFit/>
+          </a:bodyPr>
+          <a:lstStyle/>
+          <a:p>
+            <a:pPr algn="l"/>
+            <a:r>
+              <a:rPr sz="950" b="1" i="0">
+                <a:solidFill>
+                  <a:srgbClr val="B64F0F"/>
+                </a:solidFill>
+                <a:latin typeface="Arial"/>
+              </a:rPr>
+              <a:t>FLAGS  CJ Bailey (3rd-yr starter) healthy; no injury reports through camp · WR Teddy Hoffmann (top returning WR) suspended all of 2026 - PED positive · Doeren: eligibility situations pending for Jamel Johnson, KaTron Evans (details paywalled)</a:t>
+            </a:r>
+          </a:p>
+        </p:txBody>
+      </p:sp>
+      <p:sp>
+        <p:nvSpPr>
+          <p:cNvPr id="20" name="Rounded Rectangle 19"/>
+          <p:cNvSpPr/>
+          <p:nvPr/>
+        </p:nvSpPr>
+        <p:spPr>
+          <a:xfrm>
             <a:off x="6309360" y="1417320"/>
-            <a:ext cx="5166360" cy="4754880"/>
+            <a:ext cx="5166360" cy="5029200"/>
           </a:xfrm>
           <a:prstGeom prst="roundRect">
             <a:avLst/>
@@ -13084,7 +13479,7 @@
       </p:sp>
       <p:pic>
         <p:nvPicPr>
-          <p:cNvPr id="19" name="Picture 18" descr="uva.png"/>
+          <p:cNvPr id="21" name="Picture 20" descr="uva.png"/>
           <p:cNvPicPr>
             <a:picLocks noChangeAspect="1"/>
           </p:cNvPicPr>
@@ -13108,7 +13503,7 @@
       </p:pic>
       <p:sp>
         <p:nvSpPr>
-          <p:cNvPr id="20" name="TextBox 19"/>
+          <p:cNvPr id="22" name="TextBox 21"/>
           <p:cNvSpPr txBox="1"/>
           <p:nvPr/>
         </p:nvSpPr>
@@ -13143,7 +13538,7 @@
       </p:sp>
       <p:sp>
         <p:nvSpPr>
-          <p:cNvPr id="21" name="TextBox 20"/>
+          <p:cNvPr id="23" name="TextBox 22"/>
           <p:cNvSpPr txBox="1"/>
           <p:nvPr/>
         </p:nvSpPr>
@@ -13178,7 +13573,7 @@
       </p:sp>
       <p:sp>
         <p:nvSpPr>
-          <p:cNvPr id="22" name="TextBox 21"/>
+          <p:cNvPr id="24" name="TextBox 23"/>
           <p:cNvSpPr txBox="1"/>
           <p:nvPr/>
         </p:nvSpPr>
@@ -13213,7 +13608,7 @@
       </p:sp>
       <p:sp>
         <p:nvSpPr>
-          <p:cNvPr id="23" name="TextBox 22"/>
+          <p:cNvPr id="25" name="TextBox 24"/>
           <p:cNvSpPr txBox="1"/>
           <p:nvPr/>
         </p:nvSpPr>
@@ -13241,20 +13636,20 @@
                 </a:solidFill>
                 <a:latin typeface="Arial"/>
               </a:rPr>
-              <a:t>QB — Missouri transfer; 2025: 67.4%, 1,946 yds, 11-9 TD-INT (+6 rush TD); named starter Jul 19</a:t>
-            </a:r>
-          </a:p>
-        </p:txBody>
-      </p:sp>
-      <p:sp>
-        <p:nvSpPr>
-          <p:cNvPr id="24" name="TextBox 23"/>
-          <p:cNvSpPr txBox="1"/>
-          <p:nvPr/>
-        </p:nvSpPr>
-        <p:spPr>
-          <a:xfrm>
-            <a:off x="6629400" y="3410712"/>
+              <a:t>QB — Missouri transfer; 2025: 67.4%, 1,946 yds, 11-9 TD-INT (+6 rush TD); named starter Jul 15 at ACC Kickoff</a:t>
+            </a:r>
+          </a:p>
+        </p:txBody>
+      </p:sp>
+      <p:sp>
+        <p:nvSpPr>
+          <p:cNvPr id="26" name="TextBox 25"/>
+          <p:cNvSpPr txBox="1"/>
+          <p:nvPr/>
+        </p:nvSpPr>
+        <p:spPr>
+          <a:xfrm>
+            <a:off x="6629400" y="3282696"/>
             <a:ext cx="4572000" cy="320040"/>
           </a:xfrm>
           <a:prstGeom prst="rect">
@@ -13283,13 +13678,13 @@
       </p:sp>
       <p:sp>
         <p:nvSpPr>
-          <p:cNvPr id="25" name="TextBox 24"/>
-          <p:cNvSpPr txBox="1"/>
-          <p:nvPr/>
-        </p:nvSpPr>
-        <p:spPr>
-          <a:xfrm>
-            <a:off x="6629400" y="3721608"/>
+          <p:cNvPr id="27" name="TextBox 26"/>
+          <p:cNvSpPr txBox="1"/>
+          <p:nvPr/>
+        </p:nvSpPr>
+        <p:spPr>
+          <a:xfrm>
+            <a:off x="6629400" y="3593591"/>
             <a:ext cx="4572000" cy="502920"/>
           </a:xfrm>
           <a:prstGeom prst="rect">
@@ -13318,13 +13713,13 @@
       </p:sp>
       <p:sp>
         <p:nvSpPr>
-          <p:cNvPr id="26" name="TextBox 25"/>
-          <p:cNvSpPr txBox="1"/>
-          <p:nvPr/>
-        </p:nvSpPr>
-        <p:spPr>
-          <a:xfrm>
-            <a:off x="6629400" y="4306824"/>
+          <p:cNvPr id="28" name="TextBox 27"/>
+          <p:cNvSpPr txBox="1"/>
+          <p:nvPr/>
+        </p:nvSpPr>
+        <p:spPr>
+          <a:xfrm>
+            <a:off x="6629400" y="4050791"/>
             <a:ext cx="4572000" cy="320040"/>
           </a:xfrm>
           <a:prstGeom prst="rect">
@@ -13353,13 +13748,13 @@
       </p:sp>
       <p:sp>
         <p:nvSpPr>
-          <p:cNvPr id="27" name="TextBox 26"/>
-          <p:cNvSpPr txBox="1"/>
-          <p:nvPr/>
-        </p:nvSpPr>
-        <p:spPr>
-          <a:xfrm>
-            <a:off x="6629400" y="4617720"/>
+          <p:cNvPr id="29" name="TextBox 28"/>
+          <p:cNvSpPr txBox="1"/>
+          <p:nvPr/>
+        </p:nvSpPr>
+        <p:spPr>
+          <a:xfrm>
+            <a:off x="6629400" y="4361688"/>
             <a:ext cx="4572000" cy="502920"/>
           </a:xfrm>
           <a:prstGeom prst="rect">
@@ -13388,13 +13783,13 @@
       </p:sp>
       <p:sp>
         <p:nvSpPr>
-          <p:cNvPr id="28" name="TextBox 27"/>
-          <p:cNvSpPr txBox="1"/>
-          <p:nvPr/>
-        </p:nvSpPr>
-        <p:spPr>
-          <a:xfrm>
-            <a:off x="6629400" y="5202936"/>
+          <p:cNvPr id="30" name="TextBox 29"/>
+          <p:cNvSpPr txBox="1"/>
+          <p:nvPr/>
+        </p:nvSpPr>
+        <p:spPr>
+          <a:xfrm>
+            <a:off x="6629400" y="4818888"/>
             <a:ext cx="4572000" cy="320040"/>
           </a:xfrm>
           <a:prstGeom prst="rect">
@@ -13423,13 +13818,13 @@
       </p:sp>
       <p:sp>
         <p:nvSpPr>
-          <p:cNvPr id="29" name="TextBox 28"/>
-          <p:cNvSpPr txBox="1"/>
-          <p:nvPr/>
-        </p:nvSpPr>
-        <p:spPr>
-          <a:xfrm>
-            <a:off x="6629400" y="5513831"/>
+          <p:cNvPr id="31" name="TextBox 30"/>
+          <p:cNvSpPr txBox="1"/>
+          <p:nvPr/>
+        </p:nvSpPr>
+        <p:spPr>
+          <a:xfrm>
+            <a:off x="6629400" y="5129783"/>
             <a:ext cx="4572000" cy="502920"/>
           </a:xfrm>
           <a:prstGeom prst="rect">
@@ -13458,29 +13853,108 @@
       </p:sp>
       <p:sp>
         <p:nvSpPr>
-          <p:cNvPr id="30" name="TextBox 29"/>
-          <p:cNvSpPr txBox="1"/>
-          <p:nvPr/>
-        </p:nvSpPr>
-        <p:spPr>
-          <a:xfrm>
-            <a:off x="822960" y="6355080"/>
-            <a:ext cx="10515600" cy="320040"/>
-          </a:xfrm>
-          <a:prstGeom prst="rect">
-            <a:avLst/>
-          </a:prstGeom>
-          <a:noFill/>
-        </p:spPr>
-        <p:txBody>
-          <a:bodyPr wrap="square" lIns="0" rIns="0" tIns="0" bIns="0">
-            <a:spAutoFit/>
-          </a:bodyPr>
-          <a:lstStyle/>
-          <a:p>
-            <a:pPr algn="l"/>
-            <a:r>
-              <a:rPr sz="950" b="0" i="0">
+          <p:cNvPr id="32" name="Rectangle 31"/>
+          <p:cNvSpPr/>
+          <p:nvPr/>
+        </p:nvSpPr>
+        <p:spPr>
+          <a:xfrm>
+            <a:off x="6629400" y="5605271"/>
+            <a:ext cx="4572000" cy="10972"/>
+          </a:xfrm>
+          <a:prstGeom prst="rect">
+            <a:avLst/>
+          </a:prstGeom>
+          <a:solidFill>
+            <a:srgbClr val="F47321"/>
+          </a:solidFill>
+          <a:ln>
+            <a:noFill/>
+          </a:ln>
+          <a:effectLst/>
+        </p:spPr>
+        <p:style>
+          <a:lnRef idx="1">
+            <a:schemeClr val="accent1"/>
+          </a:lnRef>
+          <a:fillRef idx="3">
+            <a:schemeClr val="accent1"/>
+          </a:fillRef>
+          <a:effectRef idx="2">
+            <a:schemeClr val="accent1"/>
+          </a:effectRef>
+          <a:fontRef idx="minor">
+            <a:schemeClr val="lt1"/>
+          </a:fontRef>
+        </p:style>
+        <p:txBody>
+          <a:bodyPr rtlCol="0" anchor="ctr"/>
+          <a:lstStyle/>
+          <a:p>
+            <a:pPr algn="ctr"/>
+          </a:p>
+        </p:txBody>
+      </p:sp>
+      <p:sp>
+        <p:nvSpPr>
+          <p:cNvPr id="33" name="TextBox 32"/>
+          <p:cNvSpPr txBox="1"/>
+          <p:nvPr/>
+        </p:nvSpPr>
+        <p:spPr>
+          <a:xfrm>
+            <a:off x="6629400" y="5650992"/>
+            <a:ext cx="4572000" cy="640080"/>
+          </a:xfrm>
+          <a:prstGeom prst="rect">
+            <a:avLst/>
+          </a:prstGeom>
+          <a:noFill/>
+        </p:spPr>
+        <p:txBody>
+          <a:bodyPr wrap="square" lIns="0" rIns="0" tIns="0" bIns="0">
+            <a:spAutoFit/>
+          </a:bodyPr>
+          <a:lstStyle/>
+          <a:p>
+            <a:pPr algn="l"/>
+            <a:r>
+              <a:rPr sz="950" b="1" i="0">
+                <a:solidFill>
+                  <a:srgbClr val="B64F0F"/>
+                </a:solidFill>
+                <a:latin typeface="Arial"/>
+              </a:rPr>
+              <a:t>FLAGS  Beau Pribula (Missouri) named starter Jul 15 at ACC Kickoff over Eli Holstein · RB/KR Solomon Beebe arrested Aug 17, 3 animal-cruelty misdemeanors; no team action yet · Beebe was primary KR and rotation back behind Lewis/Middlebrook (RB3, not RB2)</a:t>
+            </a:r>
+          </a:p>
+        </p:txBody>
+      </p:sp>
+      <p:sp>
+        <p:nvSpPr>
+          <p:cNvPr id="34" name="TextBox 33"/>
+          <p:cNvSpPr txBox="1"/>
+          <p:nvPr/>
+        </p:nvSpPr>
+        <p:spPr>
+          <a:xfrm>
+            <a:off x="822960" y="6519672"/>
+            <a:ext cx="10515600" cy="274320"/>
+          </a:xfrm>
+          <a:prstGeom prst="rect">
+            <a:avLst/>
+          </a:prstGeom>
+          <a:noFill/>
+        </p:spPr>
+        <p:txBody>
+          <a:bodyPr wrap="square" lIns="0" rIns="0" tIns="0" bIns="0">
+            <a:spAutoFit/>
+          </a:bodyPr>
+          <a:lstStyle/>
+          <a:p>
+            <a:pPr algn="l"/>
+            <a:r>
+              <a:rPr sz="900" b="0" i="0">
                 <a:solidFill>
                   <a:srgbClr val="5C6B7E"/>
                 </a:solidFill>
@@ -14945,7 +15419,7 @@
         <p:spPr>
           <a:xfrm>
             <a:off x="822960" y="1417320"/>
-            <a:ext cx="5166360" cy="4754880"/>
+            <a:ext cx="5166360" cy="5029200"/>
           </a:xfrm>
           <a:prstGeom prst="roundRect">
             <a:avLst/>
@@ -15152,7 +15626,7 @@
         </p:nvSpPr>
         <p:spPr>
           <a:xfrm>
-            <a:off x="1143000" y="3410712"/>
+            <a:off x="1143000" y="3282696"/>
             <a:ext cx="4572000" cy="320040"/>
           </a:xfrm>
           <a:prstGeom prst="rect">
@@ -15187,7 +15661,7 @@
         </p:nvSpPr>
         <p:spPr>
           <a:xfrm>
-            <a:off x="1143000" y="3721608"/>
+            <a:off x="1143000" y="3593591"/>
             <a:ext cx="4572000" cy="502920"/>
           </a:xfrm>
           <a:prstGeom prst="rect">
@@ -15222,7 +15696,7 @@
         </p:nvSpPr>
         <p:spPr>
           <a:xfrm>
-            <a:off x="1143000" y="4306824"/>
+            <a:off x="1143000" y="4050791"/>
             <a:ext cx="4572000" cy="320040"/>
           </a:xfrm>
           <a:prstGeom prst="rect">
@@ -15257,7 +15731,7 @@
         </p:nvSpPr>
         <p:spPr>
           <a:xfrm>
-            <a:off x="1143000" y="4617720"/>
+            <a:off x="1143000" y="4361688"/>
             <a:ext cx="4572000" cy="502920"/>
           </a:xfrm>
           <a:prstGeom prst="rect">
@@ -15292,7 +15766,7 @@
         </p:nvSpPr>
         <p:spPr>
           <a:xfrm>
-            <a:off x="1143000" y="5202936"/>
+            <a:off x="1143000" y="4818888"/>
             <a:ext cx="4572000" cy="320040"/>
           </a:xfrm>
           <a:prstGeom prst="rect">
@@ -15327,7 +15801,7 @@
         </p:nvSpPr>
         <p:spPr>
           <a:xfrm>
-            <a:off x="1143000" y="5513831"/>
+            <a:off x="1143000" y="5129783"/>
             <a:ext cx="4572000" cy="502920"/>
           </a:xfrm>
           <a:prstGeom prst="rect">
@@ -15356,14 +15830,93 @@
       </p:sp>
       <p:sp>
         <p:nvSpPr>
-          <p:cNvPr id="18" name="Rounded Rectangle 17"/>
+          <p:cNvPr id="18" name="Rectangle 17"/>
           <p:cNvSpPr/>
           <p:nvPr/>
         </p:nvSpPr>
         <p:spPr>
           <a:xfrm>
+            <a:off x="1143000" y="5605271"/>
+            <a:ext cx="4572000" cy="10972"/>
+          </a:xfrm>
+          <a:prstGeom prst="rect">
+            <a:avLst/>
+          </a:prstGeom>
+          <a:solidFill>
+            <a:srgbClr val="F47321"/>
+          </a:solidFill>
+          <a:ln>
+            <a:noFill/>
+          </a:ln>
+          <a:effectLst/>
+        </p:spPr>
+        <p:style>
+          <a:lnRef idx="1">
+            <a:schemeClr val="accent1"/>
+          </a:lnRef>
+          <a:fillRef idx="3">
+            <a:schemeClr val="accent1"/>
+          </a:fillRef>
+          <a:effectRef idx="2">
+            <a:schemeClr val="accent1"/>
+          </a:effectRef>
+          <a:fontRef idx="minor">
+            <a:schemeClr val="lt1"/>
+          </a:fontRef>
+        </p:style>
+        <p:txBody>
+          <a:bodyPr rtlCol="0" anchor="ctr"/>
+          <a:lstStyle/>
+          <a:p>
+            <a:pPr algn="ctr"/>
+          </a:p>
+        </p:txBody>
+      </p:sp>
+      <p:sp>
+        <p:nvSpPr>
+          <p:cNvPr id="19" name="TextBox 18"/>
+          <p:cNvSpPr txBox="1"/>
+          <p:nvPr/>
+        </p:nvSpPr>
+        <p:spPr>
+          <a:xfrm>
+            <a:off x="1143000" y="5650992"/>
+            <a:ext cx="4572000" cy="640080"/>
+          </a:xfrm>
+          <a:prstGeom prst="rect">
+            <a:avLst/>
+          </a:prstGeom>
+          <a:noFill/>
+        </p:spPr>
+        <p:txBody>
+          <a:bodyPr wrap="square" lIns="0" rIns="0" tIns="0" bIns="0">
+            <a:spAutoFit/>
+          </a:bodyPr>
+          <a:lstStyle/>
+          <a:p>
+            <a:pPr algn="l"/>
+            <a:r>
+              <a:rPr sz="950" b="1" i="0">
+                <a:solidFill>
+                  <a:srgbClr val="B64F0F"/>
+                </a:solidFill>
+                <a:latin typeface="Arial"/>
+              </a:rPr>
+              <a:t>FLAGS  Caden Creel returns as starter (1,076 rush yds / 1,514 pass yds in 2025); no injury news · RB1 Tre Cook transferred to WVU; Lando/Paul/Savage compete for carries · No JSU football injuries, suspensions, or arrests found as of Aug 23</a:t>
+            </a:r>
+          </a:p>
+        </p:txBody>
+      </p:sp>
+      <p:sp>
+        <p:nvSpPr>
+          <p:cNvPr id="20" name="Rounded Rectangle 19"/>
+          <p:cNvSpPr/>
+          <p:nvPr/>
+        </p:nvSpPr>
+        <p:spPr>
+          <a:xfrm>
             <a:off x="6309360" y="1417320"/>
-            <a:ext cx="5166360" cy="4754880"/>
+            <a:ext cx="5166360" cy="5029200"/>
           </a:xfrm>
           <a:prstGeom prst="roundRect">
             <a:avLst/>
@@ -15400,7 +15953,7 @@
       </p:sp>
       <p:pic>
         <p:nvPicPr>
-          <p:cNvPr id="19" name="Picture 18" descr="ndsu.png"/>
+          <p:cNvPr id="21" name="Picture 20" descr="ndsu.png"/>
           <p:cNvPicPr>
             <a:picLocks noChangeAspect="1"/>
           </p:cNvPicPr>
@@ -15424,7 +15977,7 @@
       </p:pic>
       <p:sp>
         <p:nvSpPr>
-          <p:cNvPr id="20" name="TextBox 19"/>
+          <p:cNvPr id="22" name="TextBox 21"/>
           <p:cNvSpPr txBox="1"/>
           <p:nvPr/>
         </p:nvSpPr>
@@ -15459,7 +16012,7 @@
       </p:sp>
       <p:sp>
         <p:nvSpPr>
-          <p:cNvPr id="21" name="TextBox 20"/>
+          <p:cNvPr id="23" name="TextBox 22"/>
           <p:cNvSpPr txBox="1"/>
           <p:nvPr/>
         </p:nvSpPr>
@@ -15494,7 +16047,7 @@
       </p:sp>
       <p:sp>
         <p:nvSpPr>
-          <p:cNvPr id="22" name="TextBox 21"/>
+          <p:cNvPr id="24" name="TextBox 23"/>
           <p:cNvSpPr txBox="1"/>
           <p:nvPr/>
         </p:nvSpPr>
@@ -15529,7 +16082,7 @@
       </p:sp>
       <p:sp>
         <p:nvSpPr>
-          <p:cNvPr id="23" name="TextBox 22"/>
+          <p:cNvPr id="25" name="TextBox 24"/>
           <p:cNvSpPr txBox="1"/>
           <p:nvPr/>
         </p:nvSpPr>
@@ -15564,13 +16117,13 @@
       </p:sp>
       <p:sp>
         <p:nvSpPr>
-          <p:cNvPr id="24" name="TextBox 23"/>
-          <p:cNvSpPr txBox="1"/>
-          <p:nvPr/>
-        </p:nvSpPr>
-        <p:spPr>
-          <a:xfrm>
-            <a:off x="6629400" y="3410712"/>
+          <p:cNvPr id="26" name="TextBox 25"/>
+          <p:cNvSpPr txBox="1"/>
+          <p:nvPr/>
+        </p:nvSpPr>
+        <p:spPr>
+          <a:xfrm>
+            <a:off x="6629400" y="3282696"/>
             <a:ext cx="4572000" cy="320040"/>
           </a:xfrm>
           <a:prstGeom prst="rect">
@@ -15599,13 +16152,13 @@
       </p:sp>
       <p:sp>
         <p:nvSpPr>
-          <p:cNvPr id="25" name="TextBox 24"/>
-          <p:cNvSpPr txBox="1"/>
-          <p:nvPr/>
-        </p:nvSpPr>
-        <p:spPr>
-          <a:xfrm>
-            <a:off x="6629400" y="3721608"/>
+          <p:cNvPr id="27" name="TextBox 26"/>
+          <p:cNvSpPr txBox="1"/>
+          <p:nvPr/>
+        </p:nvSpPr>
+        <p:spPr>
+          <a:xfrm>
+            <a:off x="6629400" y="3593591"/>
             <a:ext cx="4572000" cy="502920"/>
           </a:xfrm>
           <a:prstGeom prst="rect">
@@ -15634,13 +16187,13 @@
       </p:sp>
       <p:sp>
         <p:nvSpPr>
-          <p:cNvPr id="26" name="TextBox 25"/>
-          <p:cNvSpPr txBox="1"/>
-          <p:nvPr/>
-        </p:nvSpPr>
-        <p:spPr>
-          <a:xfrm>
-            <a:off x="6629400" y="4306824"/>
+          <p:cNvPr id="28" name="TextBox 27"/>
+          <p:cNvSpPr txBox="1"/>
+          <p:nvPr/>
+        </p:nvSpPr>
+        <p:spPr>
+          <a:xfrm>
+            <a:off x="6629400" y="4050791"/>
             <a:ext cx="4572000" cy="320040"/>
           </a:xfrm>
           <a:prstGeom prst="rect">
@@ -15669,13 +16222,13 @@
       </p:sp>
       <p:sp>
         <p:nvSpPr>
-          <p:cNvPr id="27" name="TextBox 26"/>
-          <p:cNvSpPr txBox="1"/>
-          <p:nvPr/>
-        </p:nvSpPr>
-        <p:spPr>
-          <a:xfrm>
-            <a:off x="6629400" y="4617720"/>
+          <p:cNvPr id="29" name="TextBox 28"/>
+          <p:cNvSpPr txBox="1"/>
+          <p:nvPr/>
+        </p:nvSpPr>
+        <p:spPr>
+          <a:xfrm>
+            <a:off x="6629400" y="4361688"/>
             <a:ext cx="4572000" cy="502920"/>
           </a:xfrm>
           <a:prstGeom prst="rect">
@@ -15704,13 +16257,13 @@
       </p:sp>
       <p:sp>
         <p:nvSpPr>
-          <p:cNvPr id="28" name="TextBox 27"/>
-          <p:cNvSpPr txBox="1"/>
-          <p:nvPr/>
-        </p:nvSpPr>
-        <p:spPr>
-          <a:xfrm>
-            <a:off x="6629400" y="5202936"/>
+          <p:cNvPr id="30" name="TextBox 29"/>
+          <p:cNvSpPr txBox="1"/>
+          <p:nvPr/>
+        </p:nvSpPr>
+        <p:spPr>
+          <a:xfrm>
+            <a:off x="6629400" y="4818888"/>
             <a:ext cx="4572000" cy="320040"/>
           </a:xfrm>
           <a:prstGeom prst="rect">
@@ -15739,13 +16292,13 @@
       </p:sp>
       <p:sp>
         <p:nvSpPr>
-          <p:cNvPr id="29" name="TextBox 28"/>
-          <p:cNvSpPr txBox="1"/>
-          <p:nvPr/>
-        </p:nvSpPr>
-        <p:spPr>
-          <a:xfrm>
-            <a:off x="6629400" y="5513831"/>
+          <p:cNvPr id="31" name="TextBox 30"/>
+          <p:cNvSpPr txBox="1"/>
+          <p:nvPr/>
+        </p:nvSpPr>
+        <p:spPr>
+          <a:xfrm>
+            <a:off x="6629400" y="5129783"/>
             <a:ext cx="4572000" cy="502920"/>
           </a:xfrm>
           <a:prstGeom prst="rect">
@@ -15774,29 +16327,108 @@
       </p:sp>
       <p:sp>
         <p:nvSpPr>
-          <p:cNvPr id="30" name="TextBox 29"/>
-          <p:cNvSpPr txBox="1"/>
-          <p:nvPr/>
-        </p:nvSpPr>
-        <p:spPr>
-          <a:xfrm>
-            <a:off x="822960" y="6355080"/>
-            <a:ext cx="10515600" cy="320040"/>
-          </a:xfrm>
-          <a:prstGeom prst="rect">
-            <a:avLst/>
-          </a:prstGeom>
-          <a:noFill/>
-        </p:spPr>
-        <p:txBody>
-          <a:bodyPr wrap="square" lIns="0" rIns="0" tIns="0" bIns="0">
-            <a:spAutoFit/>
-          </a:bodyPr>
-          <a:lstStyle/>
-          <a:p>
-            <a:pPr algn="l"/>
-            <a:r>
-              <a:rPr sz="950" b="0" i="0">
+          <p:cNvPr id="32" name="Rectangle 31"/>
+          <p:cNvSpPr/>
+          <p:nvPr/>
+        </p:nvSpPr>
+        <p:spPr>
+          <a:xfrm>
+            <a:off x="6629400" y="5605271"/>
+            <a:ext cx="4572000" cy="10972"/>
+          </a:xfrm>
+          <a:prstGeom prst="rect">
+            <a:avLst/>
+          </a:prstGeom>
+          <a:solidFill>
+            <a:srgbClr val="F47321"/>
+          </a:solidFill>
+          <a:ln>
+            <a:noFill/>
+          </a:ln>
+          <a:effectLst/>
+        </p:spPr>
+        <p:style>
+          <a:lnRef idx="1">
+            <a:schemeClr val="accent1"/>
+          </a:lnRef>
+          <a:fillRef idx="3">
+            <a:schemeClr val="accent1"/>
+          </a:fillRef>
+          <a:effectRef idx="2">
+            <a:schemeClr val="accent1"/>
+          </a:effectRef>
+          <a:fontRef idx="minor">
+            <a:schemeClr val="lt1"/>
+          </a:fontRef>
+        </p:style>
+        <p:txBody>
+          <a:bodyPr rtlCol="0" anchor="ctr"/>
+          <a:lstStyle/>
+          <a:p>
+            <a:pPr algn="ctr"/>
+          </a:p>
+        </p:txBody>
+      </p:sp>
+      <p:sp>
+        <p:nvSpPr>
+          <p:cNvPr id="33" name="TextBox 32"/>
+          <p:cNvSpPr txBox="1"/>
+          <p:nvPr/>
+        </p:nvSpPr>
+        <p:spPr>
+          <a:xfrm>
+            <a:off x="6629400" y="5650992"/>
+            <a:ext cx="4572000" cy="640080"/>
+          </a:xfrm>
+          <a:prstGeom prst="rect">
+            <a:avLst/>
+          </a:prstGeom>
+          <a:noFill/>
+        </p:spPr>
+        <p:txBody>
+          <a:bodyPr wrap="square" lIns="0" rIns="0" tIns="0" bIns="0">
+            <a:spAutoFit/>
+          </a:bodyPr>
+          <a:lstStyle/>
+          <a:p>
+            <a:pPr algn="l"/>
+            <a:r>
+              <a:rPr sz="950" b="1" i="0">
+                <a:solidFill>
+                  <a:srgbClr val="B64F0F"/>
+                </a:solidFill>
+                <a:latin typeface="Arial"/>
+              </a:rPr>
+              <a:t>FLAGS  Nathan Hayes (5th-yr Sr, captain) confirmed QB1; first career start vs JSU · NOT title-ineligible: NCAA repealed 2-yr ban Jun 24 - bowl, MWC title game, CFP all open · DT Zach Vanderpool back at practice Aug 19 after slight knee tweak</a:t>
+            </a:r>
+          </a:p>
+        </p:txBody>
+      </p:sp>
+      <p:sp>
+        <p:nvSpPr>
+          <p:cNvPr id="34" name="TextBox 33"/>
+          <p:cNvSpPr txBox="1"/>
+          <p:nvPr/>
+        </p:nvSpPr>
+        <p:spPr>
+          <a:xfrm>
+            <a:off x="822960" y="6519672"/>
+            <a:ext cx="10515600" cy="274320"/>
+          </a:xfrm>
+          <a:prstGeom prst="rect">
+            <a:avLst/>
+          </a:prstGeom>
+          <a:noFill/>
+        </p:spPr>
+        <p:txBody>
+          <a:bodyPr wrap="square" lIns="0" rIns="0" tIns="0" bIns="0">
+            <a:spAutoFit/>
+          </a:bodyPr>
+          <a:lstStyle/>
+          <a:p>
+            <a:pPr algn="l"/>
+            <a:r>
+              <a:rPr sz="900" b="0" i="0">
                 <a:solidFill>
                   <a:srgbClr val="5C6B7E"/>
                 </a:solidFill>
@@ -17261,7 +17893,7 @@
         <p:spPr>
           <a:xfrm>
             <a:off x="822960" y="1417320"/>
-            <a:ext cx="5166360" cy="4754880"/>
+            <a:ext cx="5166360" cy="5029200"/>
           </a:xfrm>
           <a:prstGeom prst="roundRect">
             <a:avLst/>
@@ -17468,7 +18100,7 @@
         </p:nvSpPr>
         <p:spPr>
           <a:xfrm>
-            <a:off x="1143000" y="3410712"/>
+            <a:off x="1143000" y="3282696"/>
             <a:ext cx="4572000" cy="320040"/>
           </a:xfrm>
           <a:prstGeom prst="rect">
@@ -17503,7 +18135,7 @@
         </p:nvSpPr>
         <p:spPr>
           <a:xfrm>
-            <a:off x="1143000" y="3721608"/>
+            <a:off x="1143000" y="3593591"/>
             <a:ext cx="4572000" cy="502920"/>
           </a:xfrm>
           <a:prstGeom prst="rect">
@@ -17538,7 +18170,7 @@
         </p:nvSpPr>
         <p:spPr>
           <a:xfrm>
-            <a:off x="1143000" y="4306824"/>
+            <a:off x="1143000" y="4050791"/>
             <a:ext cx="4572000" cy="320040"/>
           </a:xfrm>
           <a:prstGeom prst="rect">
@@ -17573,7 +18205,7 @@
         </p:nvSpPr>
         <p:spPr>
           <a:xfrm>
-            <a:off x="1143000" y="4617720"/>
+            <a:off x="1143000" y="4361688"/>
             <a:ext cx="4572000" cy="502920"/>
           </a:xfrm>
           <a:prstGeom prst="rect">
@@ -17608,7 +18240,7 @@
         </p:nvSpPr>
         <p:spPr>
           <a:xfrm>
-            <a:off x="1143000" y="5202936"/>
+            <a:off x="1143000" y="4818888"/>
             <a:ext cx="4572000" cy="320040"/>
           </a:xfrm>
           <a:prstGeom prst="rect">
@@ -17643,7 +18275,7 @@
         </p:nvSpPr>
         <p:spPr>
           <a:xfrm>
-            <a:off x="1143000" y="5513831"/>
+            <a:off x="1143000" y="5129783"/>
             <a:ext cx="4572000" cy="502920"/>
           </a:xfrm>
           <a:prstGeom prst="rect">
@@ -17672,14 +18304,93 @@
       </p:sp>
       <p:sp>
         <p:nvSpPr>
-          <p:cNvPr id="18" name="Rounded Rectangle 17"/>
+          <p:cNvPr id="18" name="Rectangle 17"/>
           <p:cNvSpPr/>
           <p:nvPr/>
         </p:nvSpPr>
         <p:spPr>
           <a:xfrm>
+            <a:off x="1143000" y="5605271"/>
+            <a:ext cx="4572000" cy="10972"/>
+          </a:xfrm>
+          <a:prstGeom prst="rect">
+            <a:avLst/>
+          </a:prstGeom>
+          <a:solidFill>
+            <a:srgbClr val="F47321"/>
+          </a:solidFill>
+          <a:ln>
+            <a:noFill/>
+          </a:ln>
+          <a:effectLst/>
+        </p:spPr>
+        <p:style>
+          <a:lnRef idx="1">
+            <a:schemeClr val="accent1"/>
+          </a:lnRef>
+          <a:fillRef idx="3">
+            <a:schemeClr val="accent1"/>
+          </a:fillRef>
+          <a:effectRef idx="2">
+            <a:schemeClr val="accent1"/>
+          </a:effectRef>
+          <a:fontRef idx="minor">
+            <a:schemeClr val="lt1"/>
+          </a:fontRef>
+        </p:style>
+        <p:txBody>
+          <a:bodyPr rtlCol="0" anchor="ctr"/>
+          <a:lstStyle/>
+          <a:p>
+            <a:pPr algn="ctr"/>
+          </a:p>
+        </p:txBody>
+      </p:sp>
+      <p:sp>
+        <p:nvSpPr>
+          <p:cNvPr id="19" name="TextBox 18"/>
+          <p:cNvSpPr txBox="1"/>
+          <p:nvPr/>
+        </p:nvSpPr>
+        <p:spPr>
+          <a:xfrm>
+            <a:off x="1143000" y="5650992"/>
+            <a:ext cx="4572000" cy="640080"/>
+          </a:xfrm>
+          <a:prstGeom prst="rect">
+            <a:avLst/>
+          </a:prstGeom>
+          <a:noFill/>
+        </p:spPr>
+        <p:txBody>
+          <a:bodyPr wrap="square" lIns="0" rIns="0" tIns="0" bIns="0">
+            <a:spAutoFit/>
+          </a:bodyPr>
+          <a:lstStyle/>
+          <a:p>
+            <a:pPr algn="l"/>
+            <a:r>
+              <a:rPr sz="950" b="1" i="0">
+                <a:solidFill>
+                  <a:srgbClr val="B64F0F"/>
+                </a:solidFill>
+                <a:latin typeface="Arial"/>
+              </a:rPr>
+              <a:t>FLAGS  Backup QB Maika Eugenio off roster Jul 23 ('personal and team' issues per Chang) · Micah Alejado starts (MWC pre OPOY); Bjorn Jurgensen (Virginia) cemented QB2 · WR1 Pofele Ashlock (knee) sidelined all camp; return timeline unclear as of Aug 11</a:t>
+            </a:r>
+          </a:p>
+        </p:txBody>
+      </p:sp>
+      <p:sp>
+        <p:nvSpPr>
+          <p:cNvPr id="20" name="Rounded Rectangle 19"/>
+          <p:cNvSpPr/>
+          <p:nvPr/>
+        </p:nvSpPr>
+        <p:spPr>
+          <a:xfrm>
             <a:off x="6309360" y="1417320"/>
-            <a:ext cx="5166360" cy="4754880"/>
+            <a:ext cx="5166360" cy="5029200"/>
           </a:xfrm>
           <a:prstGeom prst="roundRect">
             <a:avLst/>
@@ -17716,7 +18427,7 @@
       </p:sp>
       <p:pic>
         <p:nvPicPr>
-          <p:cNvPr id="19" name="Picture 18" descr="stanford.png"/>
+          <p:cNvPr id="21" name="Picture 20" descr="stanford.png"/>
           <p:cNvPicPr>
             <a:picLocks noChangeAspect="1"/>
           </p:cNvPicPr>
@@ -17740,7 +18451,7 @@
       </p:pic>
       <p:sp>
         <p:nvSpPr>
-          <p:cNvPr id="20" name="TextBox 19"/>
+          <p:cNvPr id="22" name="TextBox 21"/>
           <p:cNvSpPr txBox="1"/>
           <p:nvPr/>
         </p:nvSpPr>
@@ -17775,7 +18486,7 @@
       </p:sp>
       <p:sp>
         <p:nvSpPr>
-          <p:cNvPr id="21" name="TextBox 20"/>
+          <p:cNvPr id="23" name="TextBox 22"/>
           <p:cNvSpPr txBox="1"/>
           <p:nvPr/>
         </p:nvSpPr>
@@ -17810,7 +18521,7 @@
       </p:sp>
       <p:sp>
         <p:nvSpPr>
-          <p:cNvPr id="22" name="TextBox 21"/>
+          <p:cNvPr id="24" name="TextBox 23"/>
           <p:cNvSpPr txBox="1"/>
           <p:nvPr/>
         </p:nvSpPr>
@@ -17845,7 +18556,7 @@
       </p:sp>
       <p:sp>
         <p:nvSpPr>
-          <p:cNvPr id="23" name="TextBox 22"/>
+          <p:cNvPr id="25" name="TextBox 24"/>
           <p:cNvSpPr txBox="1"/>
           <p:nvPr/>
         </p:nvSpPr>
@@ -17880,13 +18591,13 @@
       </p:sp>
       <p:sp>
         <p:nvSpPr>
-          <p:cNvPr id="24" name="TextBox 23"/>
-          <p:cNvSpPr txBox="1"/>
-          <p:nvPr/>
-        </p:nvSpPr>
-        <p:spPr>
-          <a:xfrm>
-            <a:off x="6629400" y="3410712"/>
+          <p:cNvPr id="26" name="TextBox 25"/>
+          <p:cNvSpPr txBox="1"/>
+          <p:nvPr/>
+        </p:nvSpPr>
+        <p:spPr>
+          <a:xfrm>
+            <a:off x="6629400" y="3282696"/>
             <a:ext cx="4572000" cy="320040"/>
           </a:xfrm>
           <a:prstGeom prst="rect">
@@ -17915,13 +18626,13 @@
       </p:sp>
       <p:sp>
         <p:nvSpPr>
-          <p:cNvPr id="25" name="TextBox 24"/>
-          <p:cNvSpPr txBox="1"/>
-          <p:nvPr/>
-        </p:nvSpPr>
-        <p:spPr>
-          <a:xfrm>
-            <a:off x="6629400" y="3721608"/>
+          <p:cNvPr id="27" name="TextBox 26"/>
+          <p:cNvSpPr txBox="1"/>
+          <p:nvPr/>
+        </p:nvSpPr>
+        <p:spPr>
+          <a:xfrm>
+            <a:off x="6629400" y="3593591"/>
             <a:ext cx="4572000" cy="502920"/>
           </a:xfrm>
           <a:prstGeom prst="rect">
@@ -17950,13 +18661,13 @@
       </p:sp>
       <p:sp>
         <p:nvSpPr>
-          <p:cNvPr id="26" name="TextBox 25"/>
-          <p:cNvSpPr txBox="1"/>
-          <p:nvPr/>
-        </p:nvSpPr>
-        <p:spPr>
-          <a:xfrm>
-            <a:off x="6629400" y="4306824"/>
+          <p:cNvPr id="28" name="TextBox 27"/>
+          <p:cNvSpPr txBox="1"/>
+          <p:nvPr/>
+        </p:nvSpPr>
+        <p:spPr>
+          <a:xfrm>
+            <a:off x="6629400" y="4050791"/>
             <a:ext cx="4572000" cy="320040"/>
           </a:xfrm>
           <a:prstGeom prst="rect">
@@ -17985,13 +18696,13 @@
       </p:sp>
       <p:sp>
         <p:nvSpPr>
-          <p:cNvPr id="27" name="TextBox 26"/>
-          <p:cNvSpPr txBox="1"/>
-          <p:nvPr/>
-        </p:nvSpPr>
-        <p:spPr>
-          <a:xfrm>
-            <a:off x="6629400" y="4617720"/>
+          <p:cNvPr id="29" name="TextBox 28"/>
+          <p:cNvSpPr txBox="1"/>
+          <p:nvPr/>
+        </p:nvSpPr>
+        <p:spPr>
+          <a:xfrm>
+            <a:off x="6629400" y="4361688"/>
             <a:ext cx="4572000" cy="502920"/>
           </a:xfrm>
           <a:prstGeom prst="rect">
@@ -18020,13 +18731,13 @@
       </p:sp>
       <p:sp>
         <p:nvSpPr>
-          <p:cNvPr id="28" name="TextBox 27"/>
-          <p:cNvSpPr txBox="1"/>
-          <p:nvPr/>
-        </p:nvSpPr>
-        <p:spPr>
-          <a:xfrm>
-            <a:off x="6629400" y="5202936"/>
+          <p:cNvPr id="30" name="TextBox 29"/>
+          <p:cNvSpPr txBox="1"/>
+          <p:nvPr/>
+        </p:nvSpPr>
+        <p:spPr>
+          <a:xfrm>
+            <a:off x="6629400" y="4818888"/>
             <a:ext cx="4572000" cy="320040"/>
           </a:xfrm>
           <a:prstGeom prst="rect">
@@ -18055,13 +18766,13 @@
       </p:sp>
       <p:sp>
         <p:nvSpPr>
-          <p:cNvPr id="29" name="TextBox 28"/>
-          <p:cNvSpPr txBox="1"/>
-          <p:nvPr/>
-        </p:nvSpPr>
-        <p:spPr>
-          <a:xfrm>
-            <a:off x="6629400" y="5513831"/>
+          <p:cNvPr id="31" name="TextBox 30"/>
+          <p:cNvSpPr txBox="1"/>
+          <p:nvPr/>
+        </p:nvSpPr>
+        <p:spPr>
+          <a:xfrm>
+            <a:off x="6629400" y="5129783"/>
             <a:ext cx="4572000" cy="502920"/>
           </a:xfrm>
           <a:prstGeom prst="rect">
@@ -18090,29 +18801,108 @@
       </p:sp>
       <p:sp>
         <p:nvSpPr>
-          <p:cNvPr id="30" name="TextBox 29"/>
-          <p:cNvSpPr txBox="1"/>
-          <p:nvPr/>
-        </p:nvSpPr>
-        <p:spPr>
-          <a:xfrm>
-            <a:off x="822960" y="6355080"/>
-            <a:ext cx="10515600" cy="320040"/>
-          </a:xfrm>
-          <a:prstGeom prst="rect">
-            <a:avLst/>
-          </a:prstGeom>
-          <a:noFill/>
-        </p:spPr>
-        <p:txBody>
-          <a:bodyPr wrap="square" lIns="0" rIns="0" tIns="0" bIns="0">
-            <a:spAutoFit/>
-          </a:bodyPr>
-          <a:lstStyle/>
-          <a:p>
-            <a:pPr algn="l"/>
-            <a:r>
-              <a:rPr sz="950" b="0" i="0">
+          <p:cNvPr id="32" name="Rectangle 31"/>
+          <p:cNvSpPr/>
+          <p:nvPr/>
+        </p:nvSpPr>
+        <p:spPr>
+          <a:xfrm>
+            <a:off x="6629400" y="5605271"/>
+            <a:ext cx="4572000" cy="10972"/>
+          </a:xfrm>
+          <a:prstGeom prst="rect">
+            <a:avLst/>
+          </a:prstGeom>
+          <a:solidFill>
+            <a:srgbClr val="F47321"/>
+          </a:solidFill>
+          <a:ln>
+            <a:noFill/>
+          </a:ln>
+          <a:effectLst/>
+        </p:spPr>
+        <p:style>
+          <a:lnRef idx="1">
+            <a:schemeClr val="accent1"/>
+          </a:lnRef>
+          <a:fillRef idx="3">
+            <a:schemeClr val="accent1"/>
+          </a:fillRef>
+          <a:effectRef idx="2">
+            <a:schemeClr val="accent1"/>
+          </a:effectRef>
+          <a:fontRef idx="minor">
+            <a:schemeClr val="lt1"/>
+          </a:fontRef>
+        </p:style>
+        <p:txBody>
+          <a:bodyPr rtlCol="0" anchor="ctr"/>
+          <a:lstStyle/>
+          <a:p>
+            <a:pPr algn="ctr"/>
+          </a:p>
+        </p:txBody>
+      </p:sp>
+      <p:sp>
+        <p:nvSpPr>
+          <p:cNvPr id="33" name="TextBox 32"/>
+          <p:cNvSpPr txBox="1"/>
+          <p:nvPr/>
+        </p:nvSpPr>
+        <p:spPr>
+          <a:xfrm>
+            <a:off x="6629400" y="5650992"/>
+            <a:ext cx="4572000" cy="640080"/>
+          </a:xfrm>
+          <a:prstGeom prst="rect">
+            <a:avLst/>
+          </a:prstGeom>
+          <a:noFill/>
+        </p:spPr>
+        <p:txBody>
+          <a:bodyPr wrap="square" lIns="0" rIns="0" tIns="0" bIns="0">
+            <a:spAutoFit/>
+          </a:bodyPr>
+          <a:lstStyle/>
+          <a:p>
+            <a:pPr algn="l"/>
+            <a:r>
+              <a:rPr sz="950" b="1" i="0">
+                <a:solidFill>
+                  <a:srgbClr val="B64F0F"/>
+                </a:solidFill>
+                <a:latin typeface="Arial"/>
+              </a:rPr>
+              <a:t>FLAGS  Davis Warren (Michigan) named starter Aug 18 over Dylan Rizk, Michael Mitchell Jr. · Warren tore right ACL in Dec 2024 bowl, missed all of 2025; first game back · Tavita Pritchard's first game as HC (hired Nov 28, 2025); Andrew Luck GM, year 2</a:t>
+            </a:r>
+          </a:p>
+        </p:txBody>
+      </p:sp>
+      <p:sp>
+        <p:nvSpPr>
+          <p:cNvPr id="34" name="TextBox 33"/>
+          <p:cNvSpPr txBox="1"/>
+          <p:nvPr/>
+        </p:nvSpPr>
+        <p:spPr>
+          <a:xfrm>
+            <a:off x="822960" y="6519672"/>
+            <a:ext cx="10515600" cy="274320"/>
+          </a:xfrm>
+          <a:prstGeom prst="rect">
+            <a:avLst/>
+          </a:prstGeom>
+          <a:noFill/>
+        </p:spPr>
+        <p:txBody>
+          <a:bodyPr wrap="square" lIns="0" rIns="0" tIns="0" bIns="0">
+            <a:spAutoFit/>
+          </a:bodyPr>
+          <a:lstStyle/>
+          <a:p>
+            <a:pPr algn="l"/>
+            <a:r>
+              <a:rPr sz="900" b="0" i="0">
                 <a:solidFill>
                   <a:srgbClr val="5C6B7E"/>
                 </a:solidFill>

</xml_diff>

<commit_message>
Deck v12: flags and lean lines off the layout; line movement promoted
FLAGS ribbon (score bug), qualitative FLAGS strips (keys slides, loader
removed), and lean lines (numbers slide + closer subtitles) no longer
render; lean/players stay in GAMES as data. Odds movement takes their
place: LINE MOVE row in the score bug, full first-seen/opened/CLV strip
at the slide bottom, movement strip as the closer-card subtitle.

Co-Authored-By: Claude Fable 5 <noreply@anthropic.com>
</commit_message>
<xml_diff>
--- a/decks/2026_Week0_Episode1.pptx
+++ b/decks/2026_Week0_Episode1.pptx
@@ -5968,7 +5968,7 @@
                 </a:solidFill>
                 <a:latin typeface="Arial"/>
               </a:rPr>
-              <a:t>FLAGS  EDGE_GONE · CLV+2.5</a:t>
+              <a:t>LINE MOVE  –3 → –5.5 · CLV +2.5</a:t>
             </a:r>
           </a:p>
         </p:txBody>
@@ -5981,64 +5981,29 @@
         </p:nvSpPr>
         <p:spPr>
           <a:xfrm>
-            <a:off x="822960" y="6053328"/>
-            <a:ext cx="10515600" cy="228600"/>
-          </a:xfrm>
-          <a:prstGeom prst="rect">
-            <a:avLst/>
-          </a:prstGeom>
-          <a:noFill/>
-        </p:spPr>
-        <p:txBody>
-          <a:bodyPr wrap="square" lIns="0" rIns="0" tIns="0" bIns="0">
-            <a:spAutoFit/>
-          </a:bodyPr>
-          <a:lstStyle/>
-          <a:p>
-            <a:pPr algn="l"/>
-            <a:r>
-              <a:rPr sz="900" b="0" i="0">
+            <a:off x="822960" y="6236208"/>
+            <a:ext cx="10515600" cy="274320"/>
+          </a:xfrm>
+          <a:prstGeom prst="rect">
+            <a:avLst/>
+          </a:prstGeom>
+          <a:noFill/>
+        </p:spPr>
+        <p:txBody>
+          <a:bodyPr wrap="square" lIns="0" rIns="0" tIns="0" bIns="0">
+            <a:spAutoFit/>
+          </a:bodyPr>
+          <a:lstStyle/>
+          <a:p>
+            <a:pPr algn="l"/>
+            <a:r>
+              <a:rPr sz="1050" b="0" i="0">
                 <a:solidFill>
                   <a:srgbClr val="5C6B7E"/>
                 </a:solidFill>
                 <a:latin typeface="Arial"/>
               </a:rPr>
-              <a:t>Line ledger: first-seen –3 (Aug 18) → now –5.5 · opened –3 · CLV +2.5 · market ML 66% UNLV</a:t>
-            </a:r>
-          </a:p>
-        </p:txBody>
-      </p:sp>
-      <p:sp>
-        <p:nvSpPr>
-          <p:cNvPr id="34" name="TextBox 33"/>
-          <p:cNvSpPr txBox="1"/>
-          <p:nvPr/>
-        </p:nvSpPr>
-        <p:spPr>
-          <a:xfrm>
-            <a:off x="822960" y="6263640"/>
-            <a:ext cx="10515600" cy="365760"/>
-          </a:xfrm>
-          <a:prstGeom prst="rect">
-            <a:avLst/>
-          </a:prstGeom>
-          <a:noFill/>
-        </p:spPr>
-        <p:txBody>
-          <a:bodyPr wrap="square" lIns="0" rIns="0" tIns="0" bIns="0">
-            <a:spAutoFit/>
-          </a:bodyPr>
-          <a:lstStyle/>
-          <a:p>
-            <a:pPr algn="l"/>
-            <a:r>
-              <a:rPr sz="1300" b="1" i="0">
-                <a:solidFill>
-                  <a:srgbClr val="0A2851"/>
-                </a:solidFill>
-                <a:latin typeface="Arial"/>
-              </a:rPr>
-              <a:t>Model side UNLV — the edge was at −3 and it's gone; at −5.5 this is a watch and the first film_study run, not a play</a:t>
+              <a:t>Line movement: first-seen –3 (Aug 18) → now –5.5 · opened –3 · CLV +2.5</a:t>
             </a:r>
           </a:p>
         </p:txBody>
@@ -6196,7 +6161,7 @@
         <p:spPr>
           <a:xfrm>
             <a:off x="822960" y="1417320"/>
-            <a:ext cx="5166360" cy="4160520"/>
+            <a:ext cx="5166360" cy="3977639"/>
           </a:xfrm>
           <a:prstGeom prst="roundRect">
             <a:avLst/>
@@ -6608,49 +6573,14 @@
       </p:sp>
       <p:sp>
         <p:nvSpPr>
-          <p:cNvPr id="17" name="TextBox 16"/>
-          <p:cNvSpPr txBox="1"/>
-          <p:nvPr/>
-        </p:nvSpPr>
-        <p:spPr>
-          <a:xfrm>
-            <a:off x="1143000" y="5074920"/>
-            <a:ext cx="4572000" cy="457200"/>
-          </a:xfrm>
-          <a:prstGeom prst="rect">
-            <a:avLst/>
-          </a:prstGeom>
-          <a:noFill/>
-        </p:spPr>
-        <p:txBody>
-          <a:bodyPr wrap="square" lIns="0" rIns="0" tIns="0" bIns="0">
-            <a:spAutoFit/>
-          </a:bodyPr>
-          <a:lstStyle/>
-          <a:p>
-            <a:pPr algn="l"/>
-            <a:r>
-              <a:rPr sz="900" b="1" i="0">
-                <a:solidFill>
-                  <a:srgbClr val="B64F0F"/>
-                </a:solidFill>
-                <a:latin typeface="Arial"/>
-              </a:rPr>
-              <a:t>FLAGS  Huff picks Stokes vs Noland internally Aug 23 but won't announce until kickoff · Charles Huff's first game as Memphis HC (hired Dec 8, 2025); 75 new players</a:t>
-            </a:r>
-          </a:p>
-        </p:txBody>
-      </p:sp>
-      <p:sp>
-        <p:nvSpPr>
-          <p:cNvPr id="18" name="Rounded Rectangle 17"/>
+          <p:cNvPr id="17" name="Rounded Rectangle 16"/>
           <p:cNvSpPr/>
           <p:nvPr/>
         </p:nvSpPr>
         <p:spPr>
           <a:xfrm>
             <a:off x="6309360" y="1417320"/>
-            <a:ext cx="5166360" cy="4160520"/>
+            <a:ext cx="5166360" cy="3977639"/>
           </a:xfrm>
           <a:prstGeom prst="roundRect">
             <a:avLst/>
@@ -6687,7 +6617,7 @@
       </p:sp>
       <p:pic>
         <p:nvPicPr>
-          <p:cNvPr id="19" name="Picture 18" descr="unlv.png"/>
+          <p:cNvPr id="18" name="Picture 17" descr="unlv.png"/>
           <p:cNvPicPr>
             <a:picLocks noChangeAspect="1"/>
           </p:cNvPicPr>
@@ -6711,7 +6641,7 @@
       </p:pic>
       <p:sp>
         <p:nvSpPr>
-          <p:cNvPr id="20" name="TextBox 19"/>
+          <p:cNvPr id="19" name="TextBox 18"/>
           <p:cNvSpPr txBox="1"/>
           <p:nvPr/>
         </p:nvSpPr>
@@ -6746,7 +6676,7 @@
       </p:sp>
       <p:sp>
         <p:nvSpPr>
-          <p:cNvPr id="21" name="Oval 20"/>
+          <p:cNvPr id="20" name="Oval 19"/>
           <p:cNvSpPr/>
           <p:nvPr/>
         </p:nvSpPr>
@@ -6790,7 +6720,7 @@
       </p:sp>
       <p:sp>
         <p:nvSpPr>
-          <p:cNvPr id="22" name="TextBox 21"/>
+          <p:cNvPr id="21" name="TextBox 20"/>
           <p:cNvSpPr txBox="1"/>
           <p:nvPr/>
         </p:nvSpPr>
@@ -6825,7 +6755,7 @@
       </p:sp>
       <p:sp>
         <p:nvSpPr>
-          <p:cNvPr id="23" name="Oval 22"/>
+          <p:cNvPr id="22" name="Oval 21"/>
           <p:cNvSpPr/>
           <p:nvPr/>
         </p:nvSpPr>
@@ -6869,7 +6799,7 @@
       </p:sp>
       <p:sp>
         <p:nvSpPr>
-          <p:cNvPr id="24" name="TextBox 23"/>
+          <p:cNvPr id="23" name="TextBox 22"/>
           <p:cNvSpPr txBox="1"/>
           <p:nvPr/>
         </p:nvSpPr>
@@ -6904,7 +6834,7 @@
       </p:sp>
       <p:sp>
         <p:nvSpPr>
-          <p:cNvPr id="25" name="Oval 24"/>
+          <p:cNvPr id="24" name="Oval 23"/>
           <p:cNvSpPr/>
           <p:nvPr/>
         </p:nvSpPr>
@@ -6948,7 +6878,7 @@
       </p:sp>
       <p:sp>
         <p:nvSpPr>
-          <p:cNvPr id="26" name="TextBox 25"/>
+          <p:cNvPr id="25" name="TextBox 24"/>
           <p:cNvSpPr txBox="1"/>
           <p:nvPr/>
         </p:nvSpPr>
@@ -6983,7 +6913,7 @@
       </p:sp>
       <p:sp>
         <p:nvSpPr>
-          <p:cNvPr id="27" name="Oval 26"/>
+          <p:cNvPr id="26" name="Oval 25"/>
           <p:cNvSpPr/>
           <p:nvPr/>
         </p:nvSpPr>
@@ -7027,7 +6957,7 @@
       </p:sp>
       <p:sp>
         <p:nvSpPr>
-          <p:cNvPr id="28" name="TextBox 27"/>
+          <p:cNvPr id="27" name="TextBox 26"/>
           <p:cNvSpPr txBox="1"/>
           <p:nvPr/>
         </p:nvSpPr>
@@ -7062,42 +6992,7 @@
       </p:sp>
       <p:sp>
         <p:nvSpPr>
-          <p:cNvPr id="29" name="TextBox 28"/>
-          <p:cNvSpPr txBox="1"/>
-          <p:nvPr/>
-        </p:nvSpPr>
-        <p:spPr>
-          <a:xfrm>
-            <a:off x="6629400" y="5074920"/>
-            <a:ext cx="4572000" cy="457200"/>
-          </a:xfrm>
-          <a:prstGeom prst="rect">
-            <a:avLst/>
-          </a:prstGeom>
-          <a:noFill/>
-        </p:spPr>
-        <p:txBody>
-          <a:bodyPr wrap="square" lIns="0" rIns="0" tIns="0" bIns="0">
-            <a:spAutoFit/>
-          </a:bodyPr>
-          <a:lstStyle/>
-          <a:p>
-            <a:pPr algn="l"/>
-            <a:r>
-              <a:rPr sz="900" b="1" i="0">
-                <a:solidFill>
-                  <a:srgbClr val="B64F0F"/>
-                </a:solidFill>
-                <a:latin typeface="Arial"/>
-              </a:rPr>
-              <a:t>FLAGS  Mullen: no starter named, Arnold and Orji may both play vs Memphis · DT Fuller, DB Welch, LB Spellman regained eligibility via Colorado ruling (NCAA appealing)</a:t>
-            </a:r>
-          </a:p>
-        </p:txBody>
-      </p:sp>
-      <p:sp>
-        <p:nvSpPr>
-          <p:cNvPr id="30" name="Rounded Rectangle 29"/>
+          <p:cNvPr id="28" name="Rounded Rectangle 27"/>
           <p:cNvSpPr/>
           <p:nvPr/>
         </p:nvSpPr>
@@ -7141,7 +7036,7 @@
       </p:sp>
       <p:sp>
         <p:nvSpPr>
-          <p:cNvPr id="31" name="TextBox 30"/>
+          <p:cNvPr id="29" name="TextBox 28"/>
           <p:cNvSpPr txBox="1"/>
           <p:nvPr/>
         </p:nvSpPr>
@@ -7176,7 +7071,7 @@
       </p:sp>
       <p:sp>
         <p:nvSpPr>
-          <p:cNvPr id="32" name="TextBox 31"/>
+          <p:cNvPr id="30" name="TextBox 29"/>
           <p:cNvSpPr txBox="1"/>
           <p:nvPr/>
         </p:nvSpPr>
@@ -7211,7 +7106,7 @@
       </p:sp>
       <p:sp>
         <p:nvSpPr>
-          <p:cNvPr id="33" name="TextBox 32"/>
+          <p:cNvPr id="31" name="TextBox 30"/>
           <p:cNvSpPr txBox="1"/>
           <p:nvPr/>
         </p:nvSpPr>
@@ -7246,7 +7141,7 @@
       </p:sp>
       <p:sp>
         <p:nvSpPr>
-          <p:cNvPr id="34" name="TextBox 33"/>
+          <p:cNvPr id="32" name="TextBox 31"/>
           <p:cNvSpPr txBox="1"/>
           <p:nvPr/>
         </p:nvSpPr>
@@ -7620,7 +7515,7 @@
                 </a:solidFill>
                 <a:latin typeface="Arial"/>
               </a:rPr>
-              <a:t>UNC ATS at −7.5 — research, not a play, while the win-prob gap is this wide · O/U no lean</a:t>
+              <a:t>first-seen –6.5 (Aug 18) → now –7.5 · opened –7.5 · CLV -1</a:t>
             </a:r>
           </a:p>
         </p:txBody>
@@ -7940,7 +7835,7 @@
                 </a:solidFill>
                 <a:latin typeface="Arial"/>
               </a:rPr>
-              <a:t>No play: value was at −3, fair is −6, the market sits at −5.5 · machine still leans UVA</a:t>
+              <a:t>first-seen –3 (Aug 18) → now –5.5 · opened –3.5 · CLV +2.5</a:t>
             </a:r>
           </a:p>
         </p:txBody>
@@ -8260,7 +8155,7 @@
                 </a:solidFill>
                 <a:latin typeface="Arial"/>
               </a:rPr>
-              <a:t>JSU at −7 or worse — already paid in line movement</a:t>
+              <a:t>first-seen –10 (Jul 14) → now –7 · opened –10 · CLV +3</a:t>
             </a:r>
           </a:p>
         </p:txBody>
@@ -8580,7 +8475,7 @@
                 </a:solidFill>
                 <a:latin typeface="Arial"/>
               </a:rPr>
-              <a:t>Hawai'i +5.5 — a 4-pt gap, not a conviction; the opener at +3 was the worse number</a:t>
+              <a:t>first-seen –3 (Aug 18) → now –5.5 · opened –3 · CLV -2.5</a:t>
             </a:r>
           </a:p>
         </p:txBody>
@@ -8900,7 +8795,7 @@
                 </a:solidFill>
                 <a:latin typeface="Arial"/>
               </a:rPr>
-              <a:t>UNLV — the edge was at −3 and it's gone; at −5.5 this is a watch and the first film_study run, not a play</a:t>
+              <a:t>first-seen –3 (Aug 18) → now –5.5 · opened –3 · CLV +2.5</a:t>
             </a:r>
           </a:p>
         </p:txBody>
@@ -10166,7 +10061,7 @@
                 </a:solidFill>
                 <a:latin typeface="Arial"/>
               </a:rPr>
-              <a:t>FLAGS  YEL · STRUCT</a:t>
+              <a:t>LINE MOVE  –6.5 → –7.5 · CLV -1</a:t>
             </a:r>
           </a:p>
         </p:txBody>
@@ -10179,64 +10074,29 @@
         </p:nvSpPr>
         <p:spPr>
           <a:xfrm>
-            <a:off x="822960" y="6053328"/>
-            <a:ext cx="10515600" cy="228600"/>
-          </a:xfrm>
-          <a:prstGeom prst="rect">
-            <a:avLst/>
-          </a:prstGeom>
-          <a:noFill/>
-        </p:spPr>
-        <p:txBody>
-          <a:bodyPr wrap="square" lIns="0" rIns="0" tIns="0" bIns="0">
-            <a:spAutoFit/>
-          </a:bodyPr>
-          <a:lstStyle/>
-          <a:p>
-            <a:pPr algn="l"/>
-            <a:r>
-              <a:rPr sz="900" b="0" i="0">
+            <a:off x="822960" y="6236208"/>
+            <a:ext cx="10515600" cy="274320"/>
+          </a:xfrm>
+          <a:prstGeom prst="rect">
+            <a:avLst/>
+          </a:prstGeom>
+          <a:noFill/>
+        </p:spPr>
+        <p:txBody>
+          <a:bodyPr wrap="square" lIns="0" rIns="0" tIns="0" bIns="0">
+            <a:spAutoFit/>
+          </a:bodyPr>
+          <a:lstStyle/>
+          <a:p>
+            <a:pPr algn="l"/>
+            <a:r>
+              <a:rPr sz="1050" b="0" i="0">
                 <a:solidFill>
                   <a:srgbClr val="5C6B7E"/>
                 </a:solidFill>
                 <a:latin typeface="Arial"/>
               </a:rPr>
-              <a:t>Line ledger: first-seen –6.5 (Aug 18) → now –7.5 · opened –7.5 · CLV -1 · market ML 73% TCU</a:t>
-            </a:r>
-          </a:p>
-        </p:txBody>
-      </p:sp>
-      <p:sp>
-        <p:nvSpPr>
-          <p:cNvPr id="34" name="TextBox 33"/>
-          <p:cNvSpPr txBox="1"/>
-          <p:nvPr/>
-        </p:nvSpPr>
-        <p:spPr>
-          <a:xfrm>
-            <a:off x="822960" y="6263640"/>
-            <a:ext cx="10515600" cy="365760"/>
-          </a:xfrm>
-          <a:prstGeom prst="rect">
-            <a:avLst/>
-          </a:prstGeom>
-          <a:noFill/>
-        </p:spPr>
-        <p:txBody>
-          <a:bodyPr wrap="square" lIns="0" rIns="0" tIns="0" bIns="0">
-            <a:spAutoFit/>
-          </a:bodyPr>
-          <a:lstStyle/>
-          <a:p>
-            <a:pPr algn="l"/>
-            <a:r>
-              <a:rPr sz="1300" b="1" i="0">
-                <a:solidFill>
-                  <a:srgbClr val="0A2851"/>
-                </a:solidFill>
-                <a:latin typeface="Arial"/>
-              </a:rPr>
-              <a:t>Lean: UNC ATS at −7.5 — research, not a play, while the win-prob gap is this wide · O/U no lean</a:t>
+              <a:t>Line movement: first-seen –6.5 (Aug 18) → now –7.5 · opened –7.5 · CLV -1</a:t>
             </a:r>
           </a:p>
         </p:txBody>
@@ -10394,7 +10254,7 @@
         <p:spPr>
           <a:xfrm>
             <a:off x="822960" y="1417320"/>
-            <a:ext cx="5166360" cy="4160520"/>
+            <a:ext cx="5166360" cy="3977639"/>
           </a:xfrm>
           <a:prstGeom prst="roundRect">
             <a:avLst/>
@@ -10806,49 +10666,14 @@
       </p:sp>
       <p:sp>
         <p:nvSpPr>
-          <p:cNvPr id="17" name="TextBox 16"/>
-          <p:cNvSpPr txBox="1"/>
-          <p:nvPr/>
-        </p:nvSpPr>
-        <p:spPr>
-          <a:xfrm>
-            <a:off x="1143000" y="5074920"/>
-            <a:ext cx="4572000" cy="457200"/>
-          </a:xfrm>
-          <a:prstGeom prst="rect">
-            <a:avLst/>
-          </a:prstGeom>
-          <a:noFill/>
-        </p:spPr>
-        <p:txBody>
-          <a:bodyPr wrap="square" lIns="0" rIns="0" tIns="0" bIns="0">
-            <a:spAutoFit/>
-          </a:bodyPr>
-          <a:lstStyle/>
-          <a:p>
-            <a:pPr algn="l"/>
-            <a:r>
-              <a:rPr sz="900" b="1" i="0">
-                <a:solidFill>
-                  <a:srgbClr val="B64F0F"/>
-                </a:solidFill>
-                <a:latin typeface="Arial"/>
-              </a:rPr>
-              <a:t>FLAGS  DC Steve Belichick on indefinite medical leave since Aug 6; no return timeline · No interim DC named; Belichick says defense coached 'collectively' - play-caller unknown</a:t>
-            </a:r>
-          </a:p>
-        </p:txBody>
-      </p:sp>
-      <p:sp>
-        <p:nvSpPr>
-          <p:cNvPr id="18" name="Rounded Rectangle 17"/>
+          <p:cNvPr id="17" name="Rounded Rectangle 16"/>
           <p:cNvSpPr/>
           <p:nvPr/>
         </p:nvSpPr>
         <p:spPr>
           <a:xfrm>
             <a:off x="6309360" y="1417320"/>
-            <a:ext cx="5166360" cy="4160520"/>
+            <a:ext cx="5166360" cy="3977639"/>
           </a:xfrm>
           <a:prstGeom prst="roundRect">
             <a:avLst/>
@@ -10885,7 +10710,7 @@
       </p:sp>
       <p:pic>
         <p:nvPicPr>
-          <p:cNvPr id="19" name="Picture 18" descr="tcu.png"/>
+          <p:cNvPr id="18" name="Picture 17" descr="tcu.png"/>
           <p:cNvPicPr>
             <a:picLocks noChangeAspect="1"/>
           </p:cNvPicPr>
@@ -10909,7 +10734,7 @@
       </p:pic>
       <p:sp>
         <p:nvSpPr>
-          <p:cNvPr id="20" name="TextBox 19"/>
+          <p:cNvPr id="19" name="TextBox 18"/>
           <p:cNvSpPr txBox="1"/>
           <p:nvPr/>
         </p:nvSpPr>
@@ -10944,7 +10769,7 @@
       </p:sp>
       <p:sp>
         <p:nvSpPr>
-          <p:cNvPr id="21" name="Oval 20"/>
+          <p:cNvPr id="20" name="Oval 19"/>
           <p:cNvSpPr/>
           <p:nvPr/>
         </p:nvSpPr>
@@ -10988,7 +10813,7 @@
       </p:sp>
       <p:sp>
         <p:nvSpPr>
-          <p:cNvPr id="22" name="TextBox 21"/>
+          <p:cNvPr id="21" name="TextBox 20"/>
           <p:cNvSpPr txBox="1"/>
           <p:nvPr/>
         </p:nvSpPr>
@@ -11023,7 +10848,7 @@
       </p:sp>
       <p:sp>
         <p:nvSpPr>
-          <p:cNvPr id="23" name="Oval 22"/>
+          <p:cNvPr id="22" name="Oval 21"/>
           <p:cNvSpPr/>
           <p:nvPr/>
         </p:nvSpPr>
@@ -11067,7 +10892,7 @@
       </p:sp>
       <p:sp>
         <p:nvSpPr>
-          <p:cNvPr id="24" name="TextBox 23"/>
+          <p:cNvPr id="23" name="TextBox 22"/>
           <p:cNvSpPr txBox="1"/>
           <p:nvPr/>
         </p:nvSpPr>
@@ -11102,7 +10927,7 @@
       </p:sp>
       <p:sp>
         <p:nvSpPr>
-          <p:cNvPr id="25" name="Oval 24"/>
+          <p:cNvPr id="24" name="Oval 23"/>
           <p:cNvSpPr/>
           <p:nvPr/>
         </p:nvSpPr>
@@ -11146,7 +10971,7 @@
       </p:sp>
       <p:sp>
         <p:nvSpPr>
-          <p:cNvPr id="26" name="TextBox 25"/>
+          <p:cNvPr id="25" name="TextBox 24"/>
           <p:cNvSpPr txBox="1"/>
           <p:nvPr/>
         </p:nvSpPr>
@@ -11181,7 +11006,7 @@
       </p:sp>
       <p:sp>
         <p:nvSpPr>
-          <p:cNvPr id="27" name="Oval 26"/>
+          <p:cNvPr id="26" name="Oval 25"/>
           <p:cNvSpPr/>
           <p:nvPr/>
         </p:nvSpPr>
@@ -11225,7 +11050,7 @@
       </p:sp>
       <p:sp>
         <p:nvSpPr>
-          <p:cNvPr id="28" name="TextBox 27"/>
+          <p:cNvPr id="27" name="TextBox 26"/>
           <p:cNvSpPr txBox="1"/>
           <p:nvPr/>
         </p:nvSpPr>
@@ -11260,42 +11085,7 @@
       </p:sp>
       <p:sp>
         <p:nvSpPr>
-          <p:cNvPr id="29" name="TextBox 28"/>
-          <p:cNvSpPr txBox="1"/>
-          <p:nvPr/>
-        </p:nvSpPr>
-        <p:spPr>
-          <a:xfrm>
-            <a:off x="6629400" y="5074920"/>
-            <a:ext cx="4572000" cy="457200"/>
-          </a:xfrm>
-          <a:prstGeom prst="rect">
-            <a:avLst/>
-          </a:prstGeom>
-          <a:noFill/>
-        </p:spPr>
-        <p:txBody>
-          <a:bodyPr wrap="square" lIns="0" rIns="0" tIns="0" bIns="0">
-            <a:spAutoFit/>
-          </a:bodyPr>
-          <a:lstStyle/>
-          <a:p>
-            <a:pPr algn="l"/>
-            <a:r>
-              <a:rPr sz="900" b="1" i="0">
-                <a:solidFill>
-                  <a:srgbClr val="B64F0F"/>
-                </a:solidFill>
-                <a:latin typeface="Arial"/>
-              </a:rPr>
-              <a:t>FLAGS  Jaden Craig (Harvard, 0 FBS snaps) is working QB1; no formal Dykes announcement found · Projected starting S Jacob Fields dismissed Aug 18 (locker-room altercation Aug 13)</a:t>
-            </a:r>
-          </a:p>
-        </p:txBody>
-      </p:sp>
-      <p:sp>
-        <p:nvSpPr>
-          <p:cNvPr id="30" name="Rounded Rectangle 29"/>
+          <p:cNvPr id="28" name="Rounded Rectangle 27"/>
           <p:cNvSpPr/>
           <p:nvPr/>
         </p:nvSpPr>
@@ -11339,7 +11129,7 @@
       </p:sp>
       <p:sp>
         <p:nvSpPr>
-          <p:cNvPr id="31" name="TextBox 30"/>
+          <p:cNvPr id="29" name="TextBox 28"/>
           <p:cNvSpPr txBox="1"/>
           <p:nvPr/>
         </p:nvSpPr>
@@ -11374,7 +11164,7 @@
       </p:sp>
       <p:sp>
         <p:nvSpPr>
-          <p:cNvPr id="32" name="TextBox 31"/>
+          <p:cNvPr id="30" name="TextBox 29"/>
           <p:cNvSpPr txBox="1"/>
           <p:nvPr/>
         </p:nvSpPr>
@@ -11409,7 +11199,7 @@
       </p:sp>
       <p:sp>
         <p:nvSpPr>
-          <p:cNvPr id="33" name="TextBox 32"/>
+          <p:cNvPr id="31" name="TextBox 30"/>
           <p:cNvSpPr txBox="1"/>
           <p:nvPr/>
         </p:nvSpPr>
@@ -11444,7 +11234,7 @@
       </p:sp>
       <p:sp>
         <p:nvSpPr>
-          <p:cNvPr id="34" name="TextBox 33"/>
+          <p:cNvPr id="32" name="TextBox 31"/>
           <p:cNvSpPr txBox="1"/>
           <p:nvPr/>
         </p:nvSpPr>
@@ -12633,7 +12423,7 @@
                 </a:solidFill>
                 <a:latin typeface="Arial"/>
               </a:rPr>
-              <a:t>FLAGS  EDGE_GONE · CLV+2.5</a:t>
+              <a:t>LINE MOVE  –3 → –5.5 · CLV +2.5</a:t>
             </a:r>
           </a:p>
         </p:txBody>
@@ -12646,64 +12436,29 @@
         </p:nvSpPr>
         <p:spPr>
           <a:xfrm>
-            <a:off x="822960" y="6053328"/>
-            <a:ext cx="10515600" cy="228600"/>
-          </a:xfrm>
-          <a:prstGeom prst="rect">
-            <a:avLst/>
-          </a:prstGeom>
-          <a:noFill/>
-        </p:spPr>
-        <p:txBody>
-          <a:bodyPr wrap="square" lIns="0" rIns="0" tIns="0" bIns="0">
-            <a:spAutoFit/>
-          </a:bodyPr>
-          <a:lstStyle/>
-          <a:p>
-            <a:pPr algn="l"/>
-            <a:r>
-              <a:rPr sz="900" b="0" i="0">
+            <a:off x="822960" y="6236208"/>
+            <a:ext cx="10515600" cy="274320"/>
+          </a:xfrm>
+          <a:prstGeom prst="rect">
+            <a:avLst/>
+          </a:prstGeom>
+          <a:noFill/>
+        </p:spPr>
+        <p:txBody>
+          <a:bodyPr wrap="square" lIns="0" rIns="0" tIns="0" bIns="0">
+            <a:spAutoFit/>
+          </a:bodyPr>
+          <a:lstStyle/>
+          <a:p>
+            <a:pPr algn="l"/>
+            <a:r>
+              <a:rPr sz="1050" b="0" i="0">
                 <a:solidFill>
                   <a:srgbClr val="5C6B7E"/>
                 </a:solidFill>
                 <a:latin typeface="Arial"/>
               </a:rPr>
-              <a:t>Line ledger: first-seen –3 (Aug 18) → now –5.5 · opened –3.5 · CLV +2.5 · market ML 66% UVA</a:t>
-            </a:r>
-          </a:p>
-        </p:txBody>
-      </p:sp>
-      <p:sp>
-        <p:nvSpPr>
-          <p:cNvPr id="34" name="TextBox 33"/>
-          <p:cNvSpPr txBox="1"/>
-          <p:nvPr/>
-        </p:nvSpPr>
-        <p:spPr>
-          <a:xfrm>
-            <a:off x="822960" y="6263640"/>
-            <a:ext cx="10515600" cy="365760"/>
-          </a:xfrm>
-          <a:prstGeom prst="rect">
-            <a:avLst/>
-          </a:prstGeom>
-          <a:noFill/>
-        </p:spPr>
-        <p:txBody>
-          <a:bodyPr wrap="square" lIns="0" rIns="0" tIns="0" bIns="0">
-            <a:spAutoFit/>
-          </a:bodyPr>
-          <a:lstStyle/>
-          <a:p>
-            <a:pPr algn="l"/>
-            <a:r>
-              <a:rPr sz="1300" b="1" i="0">
-                <a:solidFill>
-                  <a:srgbClr val="0A2851"/>
-                </a:solidFill>
-                <a:latin typeface="Arial"/>
-              </a:rPr>
-              <a:t>No play: value was at −3, fair is −6, the market sits at −5.5 · machine still leans UVA</a:t>
+              <a:t>Line movement: first-seen –3 (Aug 18) → now –5.5 · opened –3.5 · CLV +2.5</a:t>
             </a:r>
           </a:p>
         </p:txBody>
@@ -12861,7 +12616,7 @@
         <p:spPr>
           <a:xfrm>
             <a:off x="822960" y="1417320"/>
-            <a:ext cx="5166360" cy="4160520"/>
+            <a:ext cx="5166360" cy="3977639"/>
           </a:xfrm>
           <a:prstGeom prst="roundRect">
             <a:avLst/>
@@ -13273,49 +13028,14 @@
       </p:sp>
       <p:sp>
         <p:nvSpPr>
-          <p:cNvPr id="17" name="TextBox 16"/>
-          <p:cNvSpPr txBox="1"/>
-          <p:nvPr/>
-        </p:nvSpPr>
-        <p:spPr>
-          <a:xfrm>
-            <a:off x="1143000" y="5074920"/>
-            <a:ext cx="4572000" cy="457200"/>
-          </a:xfrm>
-          <a:prstGeom prst="rect">
-            <a:avLst/>
-          </a:prstGeom>
-          <a:noFill/>
-        </p:spPr>
-        <p:txBody>
-          <a:bodyPr wrap="square" lIns="0" rIns="0" tIns="0" bIns="0">
-            <a:spAutoFit/>
-          </a:bodyPr>
-          <a:lstStyle/>
-          <a:p>
-            <a:pPr algn="l"/>
-            <a:r>
-              <a:rPr sz="900" b="1" i="0">
-                <a:solidFill>
-                  <a:srgbClr val="B64F0F"/>
-                </a:solidFill>
-                <a:latin typeface="Arial"/>
-              </a:rPr>
-              <a:t>FLAGS  CJ Bailey (3rd-yr starter) healthy; no injury reports through camp · WR Teddy Hoffmann (top returning WR) suspended all of 2026 - PED positive</a:t>
-            </a:r>
-          </a:p>
-        </p:txBody>
-      </p:sp>
-      <p:sp>
-        <p:nvSpPr>
-          <p:cNvPr id="18" name="Rounded Rectangle 17"/>
+          <p:cNvPr id="17" name="Rounded Rectangle 16"/>
           <p:cNvSpPr/>
           <p:nvPr/>
         </p:nvSpPr>
         <p:spPr>
           <a:xfrm>
             <a:off x="6309360" y="1417320"/>
-            <a:ext cx="5166360" cy="4160520"/>
+            <a:ext cx="5166360" cy="3977639"/>
           </a:xfrm>
           <a:prstGeom prst="roundRect">
             <a:avLst/>
@@ -13352,7 +13072,7 @@
       </p:sp>
       <p:pic>
         <p:nvPicPr>
-          <p:cNvPr id="19" name="Picture 18" descr="uva.png"/>
+          <p:cNvPr id="18" name="Picture 17" descr="uva.png"/>
           <p:cNvPicPr>
             <a:picLocks noChangeAspect="1"/>
           </p:cNvPicPr>
@@ -13376,7 +13096,7 @@
       </p:pic>
       <p:sp>
         <p:nvSpPr>
-          <p:cNvPr id="20" name="TextBox 19"/>
+          <p:cNvPr id="19" name="TextBox 18"/>
           <p:cNvSpPr txBox="1"/>
           <p:nvPr/>
         </p:nvSpPr>
@@ -13411,7 +13131,7 @@
       </p:sp>
       <p:sp>
         <p:nvSpPr>
-          <p:cNvPr id="21" name="Oval 20"/>
+          <p:cNvPr id="20" name="Oval 19"/>
           <p:cNvSpPr/>
           <p:nvPr/>
         </p:nvSpPr>
@@ -13455,7 +13175,7 @@
       </p:sp>
       <p:sp>
         <p:nvSpPr>
-          <p:cNvPr id="22" name="TextBox 21"/>
+          <p:cNvPr id="21" name="TextBox 20"/>
           <p:cNvSpPr txBox="1"/>
           <p:nvPr/>
         </p:nvSpPr>
@@ -13490,7 +13210,7 @@
       </p:sp>
       <p:sp>
         <p:nvSpPr>
-          <p:cNvPr id="23" name="Oval 22"/>
+          <p:cNvPr id="22" name="Oval 21"/>
           <p:cNvSpPr/>
           <p:nvPr/>
         </p:nvSpPr>
@@ -13534,7 +13254,7 @@
       </p:sp>
       <p:sp>
         <p:nvSpPr>
-          <p:cNvPr id="24" name="TextBox 23"/>
+          <p:cNvPr id="23" name="TextBox 22"/>
           <p:cNvSpPr txBox="1"/>
           <p:nvPr/>
         </p:nvSpPr>
@@ -13569,7 +13289,7 @@
       </p:sp>
       <p:sp>
         <p:nvSpPr>
-          <p:cNvPr id="25" name="Oval 24"/>
+          <p:cNvPr id="24" name="Oval 23"/>
           <p:cNvSpPr/>
           <p:nvPr/>
         </p:nvSpPr>
@@ -13613,7 +13333,7 @@
       </p:sp>
       <p:sp>
         <p:nvSpPr>
-          <p:cNvPr id="26" name="TextBox 25"/>
+          <p:cNvPr id="25" name="TextBox 24"/>
           <p:cNvSpPr txBox="1"/>
           <p:nvPr/>
         </p:nvSpPr>
@@ -13648,7 +13368,7 @@
       </p:sp>
       <p:sp>
         <p:nvSpPr>
-          <p:cNvPr id="27" name="Oval 26"/>
+          <p:cNvPr id="26" name="Oval 25"/>
           <p:cNvSpPr/>
           <p:nvPr/>
         </p:nvSpPr>
@@ -13692,7 +13412,7 @@
       </p:sp>
       <p:sp>
         <p:nvSpPr>
-          <p:cNvPr id="28" name="TextBox 27"/>
+          <p:cNvPr id="27" name="TextBox 26"/>
           <p:cNvSpPr txBox="1"/>
           <p:nvPr/>
         </p:nvSpPr>
@@ -13727,42 +13447,7 @@
       </p:sp>
       <p:sp>
         <p:nvSpPr>
-          <p:cNvPr id="29" name="TextBox 28"/>
-          <p:cNvSpPr txBox="1"/>
-          <p:nvPr/>
-        </p:nvSpPr>
-        <p:spPr>
-          <a:xfrm>
-            <a:off x="6629400" y="5074920"/>
-            <a:ext cx="4572000" cy="457200"/>
-          </a:xfrm>
-          <a:prstGeom prst="rect">
-            <a:avLst/>
-          </a:prstGeom>
-          <a:noFill/>
-        </p:spPr>
-        <p:txBody>
-          <a:bodyPr wrap="square" lIns="0" rIns="0" tIns="0" bIns="0">
-            <a:spAutoFit/>
-          </a:bodyPr>
-          <a:lstStyle/>
-          <a:p>
-            <a:pPr algn="l"/>
-            <a:r>
-              <a:rPr sz="900" b="1" i="0">
-                <a:solidFill>
-                  <a:srgbClr val="B64F0F"/>
-                </a:solidFill>
-                <a:latin typeface="Arial"/>
-              </a:rPr>
-              <a:t>FLAGS  Beau Pribula (Missouri) named starter Jul 15 at ACC Kickoff over Eli Holstein · RB/KR Solomon Beebe arrested Aug 17, 3 animal-cruelty misdemeanors; no team action yet</a:t>
-            </a:r>
-          </a:p>
-        </p:txBody>
-      </p:sp>
-      <p:sp>
-        <p:nvSpPr>
-          <p:cNvPr id="30" name="Rounded Rectangle 29"/>
+          <p:cNvPr id="28" name="Rounded Rectangle 27"/>
           <p:cNvSpPr/>
           <p:nvPr/>
         </p:nvSpPr>
@@ -13806,7 +13491,7 @@
       </p:sp>
       <p:sp>
         <p:nvSpPr>
-          <p:cNvPr id="31" name="TextBox 30"/>
+          <p:cNvPr id="29" name="TextBox 28"/>
           <p:cNvSpPr txBox="1"/>
           <p:nvPr/>
         </p:nvSpPr>
@@ -13841,7 +13526,7 @@
       </p:sp>
       <p:sp>
         <p:nvSpPr>
-          <p:cNvPr id="32" name="TextBox 31"/>
+          <p:cNvPr id="30" name="TextBox 29"/>
           <p:cNvSpPr txBox="1"/>
           <p:nvPr/>
         </p:nvSpPr>
@@ -13876,7 +13561,7 @@
       </p:sp>
       <p:sp>
         <p:nvSpPr>
-          <p:cNvPr id="33" name="TextBox 32"/>
+          <p:cNvPr id="31" name="TextBox 30"/>
           <p:cNvSpPr txBox="1"/>
           <p:nvPr/>
         </p:nvSpPr>
@@ -13911,7 +13596,7 @@
       </p:sp>
       <p:sp>
         <p:nvSpPr>
-          <p:cNvPr id="34" name="TextBox 33"/>
+          <p:cNvPr id="32" name="TextBox 31"/>
           <p:cNvSpPr txBox="1"/>
           <p:nvPr/>
         </p:nvSpPr>
@@ -15100,7 +14785,7 @@
                 </a:solidFill>
                 <a:latin typeface="Arial"/>
               </a:rPr>
-              <a:t>FLAGS  CLV+3</a:t>
+              <a:t>LINE MOVE  –10 → –7 · CLV +3</a:t>
             </a:r>
           </a:p>
         </p:txBody>
@@ -15113,64 +14798,29 @@
         </p:nvSpPr>
         <p:spPr>
           <a:xfrm>
-            <a:off x="822960" y="6053328"/>
-            <a:ext cx="10515600" cy="228600"/>
-          </a:xfrm>
-          <a:prstGeom prst="rect">
-            <a:avLst/>
-          </a:prstGeom>
-          <a:noFill/>
-        </p:spPr>
-        <p:txBody>
-          <a:bodyPr wrap="square" lIns="0" rIns="0" tIns="0" bIns="0">
-            <a:spAutoFit/>
-          </a:bodyPr>
-          <a:lstStyle/>
-          <a:p>
-            <a:pPr algn="l"/>
-            <a:r>
-              <a:rPr sz="900" b="0" i="0">
+            <a:off x="822960" y="6236208"/>
+            <a:ext cx="10515600" cy="274320"/>
+          </a:xfrm>
+          <a:prstGeom prst="rect">
+            <a:avLst/>
+          </a:prstGeom>
+          <a:noFill/>
+        </p:spPr>
+        <p:txBody>
+          <a:bodyPr wrap="square" lIns="0" rIns="0" tIns="0" bIns="0">
+            <a:spAutoFit/>
+          </a:bodyPr>
+          <a:lstStyle/>
+          <a:p>
+            <a:pPr algn="l"/>
+            <a:r>
+              <a:rPr sz="1050" b="0" i="0">
                 <a:solidFill>
                   <a:srgbClr val="5C6B7E"/>
                 </a:solidFill>
                 <a:latin typeface="Arial"/>
               </a:rPr>
-              <a:t>Line ledger: first-seen –10 (Jul 14) → now –7 · opened –10 · CLV +3 · market ML 70% NDSU</a:t>
-            </a:r>
-          </a:p>
-        </p:txBody>
-      </p:sp>
-      <p:sp>
-        <p:nvSpPr>
-          <p:cNvPr id="34" name="TextBox 33"/>
-          <p:cNvSpPr txBox="1"/>
-          <p:nvPr/>
-        </p:nvSpPr>
-        <p:spPr>
-          <a:xfrm>
-            <a:off x="822960" y="6263640"/>
-            <a:ext cx="10515600" cy="365760"/>
-          </a:xfrm>
-          <a:prstGeom prst="rect">
-            <a:avLst/>
-          </a:prstGeom>
-          <a:noFill/>
-        </p:spPr>
-        <p:txBody>
-          <a:bodyPr wrap="square" lIns="0" rIns="0" tIns="0" bIns="0">
-            <a:spAutoFit/>
-          </a:bodyPr>
-          <a:lstStyle/>
-          <a:p>
-            <a:pPr algn="l"/>
-            <a:r>
-              <a:rPr sz="1300" b="1" i="0">
-                <a:solidFill>
-                  <a:srgbClr val="0A2851"/>
-                </a:solidFill>
-                <a:latin typeface="Arial"/>
-              </a:rPr>
-              <a:t>Model side: JSU at −7 or worse — already paid in line movement</a:t>
+              <a:t>Line movement: first-seen –10 (Jul 14) → now –7 · opened –10 · CLV +3</a:t>
             </a:r>
           </a:p>
         </p:txBody>
@@ -15328,7 +14978,7 @@
         <p:spPr>
           <a:xfrm>
             <a:off x="822960" y="1417320"/>
-            <a:ext cx="5166360" cy="4160520"/>
+            <a:ext cx="5166360" cy="3977639"/>
           </a:xfrm>
           <a:prstGeom prst="roundRect">
             <a:avLst/>
@@ -15740,49 +15390,14 @@
       </p:sp>
       <p:sp>
         <p:nvSpPr>
-          <p:cNvPr id="17" name="TextBox 16"/>
-          <p:cNvSpPr txBox="1"/>
-          <p:nvPr/>
-        </p:nvSpPr>
-        <p:spPr>
-          <a:xfrm>
-            <a:off x="1143000" y="5074920"/>
-            <a:ext cx="4572000" cy="457200"/>
-          </a:xfrm>
-          <a:prstGeom prst="rect">
-            <a:avLst/>
-          </a:prstGeom>
-          <a:noFill/>
-        </p:spPr>
-        <p:txBody>
-          <a:bodyPr wrap="square" lIns="0" rIns="0" tIns="0" bIns="0">
-            <a:spAutoFit/>
-          </a:bodyPr>
-          <a:lstStyle/>
-          <a:p>
-            <a:pPr algn="l"/>
-            <a:r>
-              <a:rPr sz="900" b="1" i="0">
-                <a:solidFill>
-                  <a:srgbClr val="B64F0F"/>
-                </a:solidFill>
-                <a:latin typeface="Arial"/>
-              </a:rPr>
-              <a:t>FLAGS  Caden Creel returns as starter (1,076 rush yds / 1,514 pass yds in 2025); no injury news · RB1 Tre Cook transferred to WVU; Lando/Paul/Savage compete for carries</a:t>
-            </a:r>
-          </a:p>
-        </p:txBody>
-      </p:sp>
-      <p:sp>
-        <p:nvSpPr>
-          <p:cNvPr id="18" name="Rounded Rectangle 17"/>
+          <p:cNvPr id="17" name="Rounded Rectangle 16"/>
           <p:cNvSpPr/>
           <p:nvPr/>
         </p:nvSpPr>
         <p:spPr>
           <a:xfrm>
             <a:off x="6309360" y="1417320"/>
-            <a:ext cx="5166360" cy="4160520"/>
+            <a:ext cx="5166360" cy="3977639"/>
           </a:xfrm>
           <a:prstGeom prst="roundRect">
             <a:avLst/>
@@ -15819,7 +15434,7 @@
       </p:sp>
       <p:pic>
         <p:nvPicPr>
-          <p:cNvPr id="19" name="Picture 18" descr="ndsu.png"/>
+          <p:cNvPr id="18" name="Picture 17" descr="ndsu.png"/>
           <p:cNvPicPr>
             <a:picLocks noChangeAspect="1"/>
           </p:cNvPicPr>
@@ -15843,7 +15458,7 @@
       </p:pic>
       <p:sp>
         <p:nvSpPr>
-          <p:cNvPr id="20" name="TextBox 19"/>
+          <p:cNvPr id="19" name="TextBox 18"/>
           <p:cNvSpPr txBox="1"/>
           <p:nvPr/>
         </p:nvSpPr>
@@ -15878,7 +15493,7 @@
       </p:sp>
       <p:sp>
         <p:nvSpPr>
-          <p:cNvPr id="21" name="Oval 20"/>
+          <p:cNvPr id="20" name="Oval 19"/>
           <p:cNvSpPr/>
           <p:nvPr/>
         </p:nvSpPr>
@@ -15922,7 +15537,7 @@
       </p:sp>
       <p:sp>
         <p:nvSpPr>
-          <p:cNvPr id="22" name="TextBox 21"/>
+          <p:cNvPr id="21" name="TextBox 20"/>
           <p:cNvSpPr txBox="1"/>
           <p:nvPr/>
         </p:nvSpPr>
@@ -15957,7 +15572,7 @@
       </p:sp>
       <p:sp>
         <p:nvSpPr>
-          <p:cNvPr id="23" name="Oval 22"/>
+          <p:cNvPr id="22" name="Oval 21"/>
           <p:cNvSpPr/>
           <p:nvPr/>
         </p:nvSpPr>
@@ -16001,7 +15616,7 @@
       </p:sp>
       <p:sp>
         <p:nvSpPr>
-          <p:cNvPr id="24" name="TextBox 23"/>
+          <p:cNvPr id="23" name="TextBox 22"/>
           <p:cNvSpPr txBox="1"/>
           <p:nvPr/>
         </p:nvSpPr>
@@ -16036,7 +15651,7 @@
       </p:sp>
       <p:sp>
         <p:nvSpPr>
-          <p:cNvPr id="25" name="Oval 24"/>
+          <p:cNvPr id="24" name="Oval 23"/>
           <p:cNvSpPr/>
           <p:nvPr/>
         </p:nvSpPr>
@@ -16080,7 +15695,7 @@
       </p:sp>
       <p:sp>
         <p:nvSpPr>
-          <p:cNvPr id="26" name="TextBox 25"/>
+          <p:cNvPr id="25" name="TextBox 24"/>
           <p:cNvSpPr txBox="1"/>
           <p:nvPr/>
         </p:nvSpPr>
@@ -16115,7 +15730,7 @@
       </p:sp>
       <p:sp>
         <p:nvSpPr>
-          <p:cNvPr id="27" name="Oval 26"/>
+          <p:cNvPr id="26" name="Oval 25"/>
           <p:cNvSpPr/>
           <p:nvPr/>
         </p:nvSpPr>
@@ -16159,7 +15774,7 @@
       </p:sp>
       <p:sp>
         <p:nvSpPr>
-          <p:cNvPr id="28" name="TextBox 27"/>
+          <p:cNvPr id="27" name="TextBox 26"/>
           <p:cNvSpPr txBox="1"/>
           <p:nvPr/>
         </p:nvSpPr>
@@ -16194,42 +15809,7 @@
       </p:sp>
       <p:sp>
         <p:nvSpPr>
-          <p:cNvPr id="29" name="TextBox 28"/>
-          <p:cNvSpPr txBox="1"/>
-          <p:nvPr/>
-        </p:nvSpPr>
-        <p:spPr>
-          <a:xfrm>
-            <a:off x="6629400" y="5074920"/>
-            <a:ext cx="4572000" cy="457200"/>
-          </a:xfrm>
-          <a:prstGeom prst="rect">
-            <a:avLst/>
-          </a:prstGeom>
-          <a:noFill/>
-        </p:spPr>
-        <p:txBody>
-          <a:bodyPr wrap="square" lIns="0" rIns="0" tIns="0" bIns="0">
-            <a:spAutoFit/>
-          </a:bodyPr>
-          <a:lstStyle/>
-          <a:p>
-            <a:pPr algn="l"/>
-            <a:r>
-              <a:rPr sz="900" b="1" i="0">
-                <a:solidFill>
-                  <a:srgbClr val="B64F0F"/>
-                </a:solidFill>
-                <a:latin typeface="Arial"/>
-              </a:rPr>
-              <a:t>FLAGS  Nathan Hayes (5th-yr Sr, captain) confirmed QB1; first career start vs JSU · NOT title-ineligible: NCAA repealed 2-yr ban Jun 24 - bowl, MWC title game, CFP all open</a:t>
-            </a:r>
-          </a:p>
-        </p:txBody>
-      </p:sp>
-      <p:sp>
-        <p:nvSpPr>
-          <p:cNvPr id="30" name="Rounded Rectangle 29"/>
+          <p:cNvPr id="28" name="Rounded Rectangle 27"/>
           <p:cNvSpPr/>
           <p:nvPr/>
         </p:nvSpPr>
@@ -16273,7 +15853,7 @@
       </p:sp>
       <p:sp>
         <p:nvSpPr>
-          <p:cNvPr id="31" name="TextBox 30"/>
+          <p:cNvPr id="29" name="TextBox 28"/>
           <p:cNvSpPr txBox="1"/>
           <p:nvPr/>
         </p:nvSpPr>
@@ -16308,7 +15888,7 @@
       </p:sp>
       <p:sp>
         <p:nvSpPr>
-          <p:cNvPr id="32" name="TextBox 31"/>
+          <p:cNvPr id="30" name="TextBox 29"/>
           <p:cNvSpPr txBox="1"/>
           <p:nvPr/>
         </p:nvSpPr>
@@ -16343,7 +15923,7 @@
       </p:sp>
       <p:sp>
         <p:nvSpPr>
-          <p:cNvPr id="33" name="TextBox 32"/>
+          <p:cNvPr id="31" name="TextBox 30"/>
           <p:cNvSpPr txBox="1"/>
           <p:nvPr/>
         </p:nvSpPr>
@@ -16378,7 +15958,7 @@
       </p:sp>
       <p:sp>
         <p:nvSpPr>
-          <p:cNvPr id="34" name="TextBox 33"/>
+          <p:cNvPr id="32" name="TextBox 31"/>
           <p:cNvSpPr txBox="1"/>
           <p:nvPr/>
         </p:nvSpPr>
@@ -17567,7 +17147,7 @@
                 </a:solidFill>
                 <a:latin typeface="Arial"/>
               </a:rPr>
-              <a:t>FLAGS  CLV-2.5</a:t>
+              <a:t>LINE MOVE  –3 → –5.5 · CLV -2.5</a:t>
             </a:r>
           </a:p>
         </p:txBody>
@@ -17580,64 +17160,29 @@
         </p:nvSpPr>
         <p:spPr>
           <a:xfrm>
-            <a:off x="822960" y="6053328"/>
-            <a:ext cx="10515600" cy="228600"/>
-          </a:xfrm>
-          <a:prstGeom prst="rect">
-            <a:avLst/>
-          </a:prstGeom>
-          <a:noFill/>
-        </p:spPr>
-        <p:txBody>
-          <a:bodyPr wrap="square" lIns="0" rIns="0" tIns="0" bIns="0">
-            <a:spAutoFit/>
-          </a:bodyPr>
-          <a:lstStyle/>
-          <a:p>
-            <a:pPr algn="l"/>
-            <a:r>
-              <a:rPr sz="900" b="0" i="0">
+            <a:off x="822960" y="6236208"/>
+            <a:ext cx="10515600" cy="274320"/>
+          </a:xfrm>
+          <a:prstGeom prst="rect">
+            <a:avLst/>
+          </a:prstGeom>
+          <a:noFill/>
+        </p:spPr>
+        <p:txBody>
+          <a:bodyPr wrap="square" lIns="0" rIns="0" tIns="0" bIns="0">
+            <a:spAutoFit/>
+          </a:bodyPr>
+          <a:lstStyle/>
+          <a:p>
+            <a:pPr algn="l"/>
+            <a:r>
+              <a:rPr sz="1050" b="0" i="0">
                 <a:solidFill>
                   <a:srgbClr val="5C6B7E"/>
                 </a:solidFill>
                 <a:latin typeface="Arial"/>
               </a:rPr>
-              <a:t>Line ledger: first-seen –3 (Aug 18) → now –5.5 · opened –3 · CLV -2.5 · market ML 66% STAN</a:t>
-            </a:r>
-          </a:p>
-        </p:txBody>
-      </p:sp>
-      <p:sp>
-        <p:nvSpPr>
-          <p:cNvPr id="34" name="TextBox 33"/>
-          <p:cNvSpPr txBox="1"/>
-          <p:nvPr/>
-        </p:nvSpPr>
-        <p:spPr>
-          <a:xfrm>
-            <a:off x="822960" y="6263640"/>
-            <a:ext cx="10515600" cy="365760"/>
-          </a:xfrm>
-          <a:prstGeom prst="rect">
-            <a:avLst/>
-          </a:prstGeom>
-          <a:noFill/>
-        </p:spPr>
-        <p:txBody>
-          <a:bodyPr wrap="square" lIns="0" rIns="0" tIns="0" bIns="0">
-            <a:spAutoFit/>
-          </a:bodyPr>
-          <a:lstStyle/>
-          <a:p>
-            <a:pPr algn="l"/>
-            <a:r>
-              <a:rPr sz="1300" b="1" i="0">
-                <a:solidFill>
-                  <a:srgbClr val="0A2851"/>
-                </a:solidFill>
-                <a:latin typeface="Arial"/>
-              </a:rPr>
-              <a:t>Lean: Hawai'i +5.5 — a 4-pt gap, not a conviction; the opener at +3 was the worse number</a:t>
+              <a:t>Line movement: first-seen –3 (Aug 18) → now –5.5 · opened –3 · CLV -2.5</a:t>
             </a:r>
           </a:p>
         </p:txBody>
@@ -17795,7 +17340,7 @@
         <p:spPr>
           <a:xfrm>
             <a:off x="822960" y="1417320"/>
-            <a:ext cx="5166360" cy="4160520"/>
+            <a:ext cx="5166360" cy="3977639"/>
           </a:xfrm>
           <a:prstGeom prst="roundRect">
             <a:avLst/>
@@ -18207,49 +17752,14 @@
       </p:sp>
       <p:sp>
         <p:nvSpPr>
-          <p:cNvPr id="17" name="TextBox 16"/>
-          <p:cNvSpPr txBox="1"/>
-          <p:nvPr/>
-        </p:nvSpPr>
-        <p:spPr>
-          <a:xfrm>
-            <a:off x="1143000" y="5074920"/>
-            <a:ext cx="4572000" cy="457200"/>
-          </a:xfrm>
-          <a:prstGeom prst="rect">
-            <a:avLst/>
-          </a:prstGeom>
-          <a:noFill/>
-        </p:spPr>
-        <p:txBody>
-          <a:bodyPr wrap="square" lIns="0" rIns="0" tIns="0" bIns="0">
-            <a:spAutoFit/>
-          </a:bodyPr>
-          <a:lstStyle/>
-          <a:p>
-            <a:pPr algn="l"/>
-            <a:r>
-              <a:rPr sz="900" b="1" i="0">
-                <a:solidFill>
-                  <a:srgbClr val="B64F0F"/>
-                </a:solidFill>
-                <a:latin typeface="Arial"/>
-              </a:rPr>
-              <a:t>FLAGS  Backup QB Maika Eugenio off roster Jul 23 ('personal and team' issues per Chang) · Micah Alejado starts (MWC pre OPOY); Bjorn Jurgensen (Virginia) cemented QB2</a:t>
-            </a:r>
-          </a:p>
-        </p:txBody>
-      </p:sp>
-      <p:sp>
-        <p:nvSpPr>
-          <p:cNvPr id="18" name="Rounded Rectangle 17"/>
+          <p:cNvPr id="17" name="Rounded Rectangle 16"/>
           <p:cNvSpPr/>
           <p:nvPr/>
         </p:nvSpPr>
         <p:spPr>
           <a:xfrm>
             <a:off x="6309360" y="1417320"/>
-            <a:ext cx="5166360" cy="4160520"/>
+            <a:ext cx="5166360" cy="3977639"/>
           </a:xfrm>
           <a:prstGeom prst="roundRect">
             <a:avLst/>
@@ -18286,7 +17796,7 @@
       </p:sp>
       <p:pic>
         <p:nvPicPr>
-          <p:cNvPr id="19" name="Picture 18" descr="stanford.png"/>
+          <p:cNvPr id="18" name="Picture 17" descr="stanford.png"/>
           <p:cNvPicPr>
             <a:picLocks noChangeAspect="1"/>
           </p:cNvPicPr>
@@ -18310,7 +17820,7 @@
       </p:pic>
       <p:sp>
         <p:nvSpPr>
-          <p:cNvPr id="20" name="TextBox 19"/>
+          <p:cNvPr id="19" name="TextBox 18"/>
           <p:cNvSpPr txBox="1"/>
           <p:nvPr/>
         </p:nvSpPr>
@@ -18345,7 +17855,7 @@
       </p:sp>
       <p:sp>
         <p:nvSpPr>
-          <p:cNvPr id="21" name="Oval 20"/>
+          <p:cNvPr id="20" name="Oval 19"/>
           <p:cNvSpPr/>
           <p:nvPr/>
         </p:nvSpPr>
@@ -18389,7 +17899,7 @@
       </p:sp>
       <p:sp>
         <p:nvSpPr>
-          <p:cNvPr id="22" name="TextBox 21"/>
+          <p:cNvPr id="21" name="TextBox 20"/>
           <p:cNvSpPr txBox="1"/>
           <p:nvPr/>
         </p:nvSpPr>
@@ -18424,7 +17934,7 @@
       </p:sp>
       <p:sp>
         <p:nvSpPr>
-          <p:cNvPr id="23" name="Oval 22"/>
+          <p:cNvPr id="22" name="Oval 21"/>
           <p:cNvSpPr/>
           <p:nvPr/>
         </p:nvSpPr>
@@ -18468,7 +17978,7 @@
       </p:sp>
       <p:sp>
         <p:nvSpPr>
-          <p:cNvPr id="24" name="TextBox 23"/>
+          <p:cNvPr id="23" name="TextBox 22"/>
           <p:cNvSpPr txBox="1"/>
           <p:nvPr/>
         </p:nvSpPr>
@@ -18503,7 +18013,7 @@
       </p:sp>
       <p:sp>
         <p:nvSpPr>
-          <p:cNvPr id="25" name="Oval 24"/>
+          <p:cNvPr id="24" name="Oval 23"/>
           <p:cNvSpPr/>
           <p:nvPr/>
         </p:nvSpPr>
@@ -18547,7 +18057,7 @@
       </p:sp>
       <p:sp>
         <p:nvSpPr>
-          <p:cNvPr id="26" name="TextBox 25"/>
+          <p:cNvPr id="25" name="TextBox 24"/>
           <p:cNvSpPr txBox="1"/>
           <p:nvPr/>
         </p:nvSpPr>
@@ -18582,7 +18092,7 @@
       </p:sp>
       <p:sp>
         <p:nvSpPr>
-          <p:cNvPr id="27" name="Oval 26"/>
+          <p:cNvPr id="26" name="Oval 25"/>
           <p:cNvSpPr/>
           <p:nvPr/>
         </p:nvSpPr>
@@ -18626,7 +18136,7 @@
       </p:sp>
       <p:sp>
         <p:nvSpPr>
-          <p:cNvPr id="28" name="TextBox 27"/>
+          <p:cNvPr id="27" name="TextBox 26"/>
           <p:cNvSpPr txBox="1"/>
           <p:nvPr/>
         </p:nvSpPr>
@@ -18661,42 +18171,7 @@
       </p:sp>
       <p:sp>
         <p:nvSpPr>
-          <p:cNvPr id="29" name="TextBox 28"/>
-          <p:cNvSpPr txBox="1"/>
-          <p:nvPr/>
-        </p:nvSpPr>
-        <p:spPr>
-          <a:xfrm>
-            <a:off x="6629400" y="5074920"/>
-            <a:ext cx="4572000" cy="457200"/>
-          </a:xfrm>
-          <a:prstGeom prst="rect">
-            <a:avLst/>
-          </a:prstGeom>
-          <a:noFill/>
-        </p:spPr>
-        <p:txBody>
-          <a:bodyPr wrap="square" lIns="0" rIns="0" tIns="0" bIns="0">
-            <a:spAutoFit/>
-          </a:bodyPr>
-          <a:lstStyle/>
-          <a:p>
-            <a:pPr algn="l"/>
-            <a:r>
-              <a:rPr sz="900" b="1" i="0">
-                <a:solidFill>
-                  <a:srgbClr val="B64F0F"/>
-                </a:solidFill>
-                <a:latin typeface="Arial"/>
-              </a:rPr>
-              <a:t>FLAGS  Davis Warren (Michigan) named starter Aug 18 over Dylan Rizk, Michael Mitchell Jr. · Warren tore right ACL in Dec 2024 bowl, missed all of 2025; first game back</a:t>
-            </a:r>
-          </a:p>
-        </p:txBody>
-      </p:sp>
-      <p:sp>
-        <p:nvSpPr>
-          <p:cNvPr id="30" name="Rounded Rectangle 29"/>
+          <p:cNvPr id="28" name="Rounded Rectangle 27"/>
           <p:cNvSpPr/>
           <p:nvPr/>
         </p:nvSpPr>
@@ -18740,7 +18215,7 @@
       </p:sp>
       <p:sp>
         <p:nvSpPr>
-          <p:cNvPr id="31" name="TextBox 30"/>
+          <p:cNvPr id="29" name="TextBox 28"/>
           <p:cNvSpPr txBox="1"/>
           <p:nvPr/>
         </p:nvSpPr>
@@ -18775,7 +18250,7 @@
       </p:sp>
       <p:sp>
         <p:nvSpPr>
-          <p:cNvPr id="32" name="TextBox 31"/>
+          <p:cNvPr id="30" name="TextBox 29"/>
           <p:cNvSpPr txBox="1"/>
           <p:nvPr/>
         </p:nvSpPr>
@@ -18810,7 +18285,7 @@
       </p:sp>
       <p:sp>
         <p:nvSpPr>
-          <p:cNvPr id="33" name="TextBox 32"/>
+          <p:cNvPr id="31" name="TextBox 30"/>
           <p:cNvSpPr txBox="1"/>
           <p:nvPr/>
         </p:nvSpPr>
@@ -18845,7 +18320,7 @@
       </p:sp>
       <p:sp>
         <p:nvSpPr>
-          <p:cNvPr id="34" name="TextBox 33"/>
+          <p:cNvPr id="32" name="TextBox 31"/>
           <p:cNvSpPr txBox="1"/>
           <p:nvPr/>
         </p:nvSpPr>

</xml_diff>